<commit_message>
docs(slides): revise defense presentation grammar
</commit_message>
<xml_diff>
--- a/docs/tcc/apresentacao-inventoryrfid-15min.pptx
+++ b/docs/tcc/apresentacao-inventoryrfid-15min.pptx
@@ -2,30 +2,30 @@
 <file path=ppt/presentation.xml><?xml version="1.0" encoding="utf-8"?>
 <p:presentation xmlns:p="http://schemas.openxmlformats.org/presentationml/2006/main">
   <p:sldMasterIdLst>
-    <p:sldMasterId xmlns:r="http://schemas.openxmlformats.org/officeDocument/2006/relationships" id="2147483648" r:id="R4a6fca85541a4200"/>
+    <p:sldMasterId xmlns:r="http://schemas.openxmlformats.org/officeDocument/2006/relationships" id="2147483648" r:id="R43545dfda9e64c2a"/>
   </p:sldMasterIdLst>
   <p:notesMasterIdLst>
-    <p:notesMasterId xmlns:r="http://schemas.openxmlformats.org/officeDocument/2006/relationships" r:id="Rf39da1d323d74157"/>
+    <p:notesMasterId xmlns:r="http://schemas.openxmlformats.org/officeDocument/2006/relationships" r:id="R39f9d7dd789f44f2"/>
   </p:notesMasterIdLst>
   <p:sldIdLst>
-    <p:sldId xmlns:r="http://schemas.openxmlformats.org/officeDocument/2006/relationships" id="256" r:id="R4eaf35ffd85e4a8b"/>
-    <p:sldId xmlns:r="http://schemas.openxmlformats.org/officeDocument/2006/relationships" id="257" r:id="R4179bdd8797c4df5"/>
-    <p:sldId xmlns:r="http://schemas.openxmlformats.org/officeDocument/2006/relationships" id="258" r:id="Rb809e4d2caa6443e"/>
-    <p:sldId xmlns:r="http://schemas.openxmlformats.org/officeDocument/2006/relationships" id="259" r:id="R66a8b5019ee74685"/>
-    <p:sldId xmlns:r="http://schemas.openxmlformats.org/officeDocument/2006/relationships" id="260" r:id="R19405955715b49e7"/>
-    <p:sldId xmlns:r="http://schemas.openxmlformats.org/officeDocument/2006/relationships" id="261" r:id="R5a5502e129334a82"/>
-    <p:sldId xmlns:r="http://schemas.openxmlformats.org/officeDocument/2006/relationships" id="262" r:id="Rd7b61ff5ee254f04"/>
-    <p:sldId xmlns:r="http://schemas.openxmlformats.org/officeDocument/2006/relationships" id="263" r:id="R44780b7540fc486d"/>
-    <p:sldId xmlns:r="http://schemas.openxmlformats.org/officeDocument/2006/relationships" id="264" r:id="R9a1879e2e2244f00"/>
-    <p:sldId xmlns:r="http://schemas.openxmlformats.org/officeDocument/2006/relationships" id="265" r:id="R43a3154d20694a74"/>
-    <p:sldId xmlns:r="http://schemas.openxmlformats.org/officeDocument/2006/relationships" id="266" r:id="Rc8afa6c0eaf0409e"/>
-    <p:sldId xmlns:r="http://schemas.openxmlformats.org/officeDocument/2006/relationships" id="267" r:id="R82c87f9a71054393"/>
-    <p:sldId xmlns:r="http://schemas.openxmlformats.org/officeDocument/2006/relationships" id="268" r:id="R4cff3c5fde7f4998"/>
-    <p:sldId xmlns:r="http://schemas.openxmlformats.org/officeDocument/2006/relationships" id="269" r:id="Rca48dba49a3e45d2"/>
-    <p:sldId xmlns:r="http://schemas.openxmlformats.org/officeDocument/2006/relationships" id="270" r:id="R3c9d222b3d214f00"/>
-    <p:sldId xmlns:r="http://schemas.openxmlformats.org/officeDocument/2006/relationships" id="271" r:id="R01a64c56ece54e12"/>
-    <p:sldId xmlns:r="http://schemas.openxmlformats.org/officeDocument/2006/relationships" id="272" r:id="Rd01a79c20c0b49af"/>
-    <p:sldId xmlns:r="http://schemas.openxmlformats.org/officeDocument/2006/relationships" id="273" r:id="R13b43d7764fe4ba3"/>
+    <p:sldId xmlns:r="http://schemas.openxmlformats.org/officeDocument/2006/relationships" id="256" r:id="R159669b962ea457b"/>
+    <p:sldId xmlns:r="http://schemas.openxmlformats.org/officeDocument/2006/relationships" id="257" r:id="Rd0095882a1f34030"/>
+    <p:sldId xmlns:r="http://schemas.openxmlformats.org/officeDocument/2006/relationships" id="258" r:id="R7b5a7a8e837d46d0"/>
+    <p:sldId xmlns:r="http://schemas.openxmlformats.org/officeDocument/2006/relationships" id="259" r:id="Rb48b9c078b454070"/>
+    <p:sldId xmlns:r="http://schemas.openxmlformats.org/officeDocument/2006/relationships" id="260" r:id="Ra5c575f2f1b54e6d"/>
+    <p:sldId xmlns:r="http://schemas.openxmlformats.org/officeDocument/2006/relationships" id="261" r:id="R9ebfba287f05484e"/>
+    <p:sldId xmlns:r="http://schemas.openxmlformats.org/officeDocument/2006/relationships" id="262" r:id="R28f305d4169441b8"/>
+    <p:sldId xmlns:r="http://schemas.openxmlformats.org/officeDocument/2006/relationships" id="263" r:id="R3f6d5af997f8466b"/>
+    <p:sldId xmlns:r="http://schemas.openxmlformats.org/officeDocument/2006/relationships" id="264" r:id="Rd62676320c3b4c27"/>
+    <p:sldId xmlns:r="http://schemas.openxmlformats.org/officeDocument/2006/relationships" id="265" r:id="R84054fc4683d40e4"/>
+    <p:sldId xmlns:r="http://schemas.openxmlformats.org/officeDocument/2006/relationships" id="266" r:id="Rcb994dd5c906471b"/>
+    <p:sldId xmlns:r="http://schemas.openxmlformats.org/officeDocument/2006/relationships" id="267" r:id="R0e29a88dd2044b80"/>
+    <p:sldId xmlns:r="http://schemas.openxmlformats.org/officeDocument/2006/relationships" id="268" r:id="R50024e125e004730"/>
+    <p:sldId xmlns:r="http://schemas.openxmlformats.org/officeDocument/2006/relationships" id="269" r:id="Rb0824ccb40824511"/>
+    <p:sldId xmlns:r="http://schemas.openxmlformats.org/officeDocument/2006/relationships" id="270" r:id="Rc44309d88a8c45e3"/>
+    <p:sldId xmlns:r="http://schemas.openxmlformats.org/officeDocument/2006/relationships" id="271" r:id="R6e90138918424774"/>
+    <p:sldId xmlns:r="http://schemas.openxmlformats.org/officeDocument/2006/relationships" id="272" r:id="R5d6fed1d0bdb448b"/>
+    <p:sldId xmlns:r="http://schemas.openxmlformats.org/officeDocument/2006/relationships" id="273" r:id="Rba2079b5334a4ba8"/>
   </p:sldIdLst>
   <p:sldSz cx="12192000" cy="6858000"/>
   <p:notesSz cx="6858000" cy="9144000"/>
@@ -1694,7 +1694,7 @@
   </p:cSld>
   <p:clrMap bg1="lt1" tx1="dk1" bg2="lt2" tx2="dk2" accent1="accent1" accent2="accent2" accent3="accent3" accent4="accent4" accent5="accent5" accent6="accent6" hlink="hlink" folHlink="folHlink"/>
   <p:sldLayoutIdLst>
-    <p:sldLayoutId xmlns:r="http://schemas.openxmlformats.org/officeDocument/2006/relationships" id="2147483649" r:id="Rd3b5d9fe70a24b6c"/>
+    <p:sldLayoutId xmlns:r="http://schemas.openxmlformats.org/officeDocument/2006/relationships" id="2147483649" r:id="Rbe6446b3d2de443a"/>
   </p:sldLayoutIdLst>
   <p:txStyles>
     <p:titleStyle>
@@ -2192,7 +2192,7 @@
           <p:cNvPr id="1" name="">
             <a:extLst xmlns:a="http://schemas.openxmlformats.org/drawingml/2006/main">
               <a:ext uri="{FF2B5EF4-FFF2-40B4-BE49-F238E27FC236}">
-                <a16:creationId xmlns:a16="http://schemas.microsoft.com/office/drawing/2014/main" id="{0461EEF3-BF93-4D62-BF44-9B1B5DBB18CB}"/>
+                <a16:creationId xmlns:a16="http://schemas.microsoft.com/office/drawing/2014/main" id="{6BFDC0D0-3942-4F3E-ABA0-6A823B95318F}"/>
               </a:ext>
             </a:extLst>
           </p:cNvPr>
@@ -2227,7 +2227,7 @@
           <p:cNvPr id="2" name="">
             <a:extLst xmlns:a="http://schemas.openxmlformats.org/drawingml/2006/main">
               <a:ext uri="{FF2B5EF4-FFF2-40B4-BE49-F238E27FC236}">
-                <a16:creationId xmlns:a16="http://schemas.microsoft.com/office/drawing/2014/main" id="{8F7236BC-B777-46D8-86F2-1B1FBB795A37}"/>
+                <a16:creationId xmlns:a16="http://schemas.microsoft.com/office/drawing/2014/main" id="{C45245AA-DABA-4C22-9A46-EA621784DC84}"/>
               </a:ext>
             </a:extLst>
           </p:cNvPr>
@@ -2264,7 +2264,7 @@
           <p:cNvPr id="3" name="">
             <a:extLst xmlns:a="http://schemas.openxmlformats.org/drawingml/2006/main">
               <a:ext uri="{FF2B5EF4-FFF2-40B4-BE49-F238E27FC236}">
-                <a16:creationId xmlns:a16="http://schemas.microsoft.com/office/drawing/2014/main" id="{8AB89BF6-31CD-450A-A036-A4CA1163FD51}"/>
+                <a16:creationId xmlns:a16="http://schemas.microsoft.com/office/drawing/2014/main" id="{AB069D1E-3C5C-410A-A2CD-0FE3BA25254B}"/>
               </a:ext>
             </a:extLst>
           </p:cNvPr>
@@ -2303,7 +2303,7 @@
           <p:nvPr/>
         </p:nvPicPr>
         <p:blipFill>
-          <a:blip xmlns:r="http://schemas.openxmlformats.org/officeDocument/2006/relationships" xmlns:a="http://schemas.openxmlformats.org/drawingml/2006/main" r:embed="R0f922eb0994c4f6c"/>
+          <a:blip xmlns:r="http://schemas.openxmlformats.org/officeDocument/2006/relationships" xmlns:a="http://schemas.openxmlformats.org/drawingml/2006/main" r:embed="R04953fb74f1542f2"/>
           <a:stretch xmlns:a="http://schemas.openxmlformats.org/drawingml/2006/main"/>
         </p:blipFill>
         <p:spPr>
@@ -2321,7 +2321,7 @@
           <p:cNvPr id="5" name="">
             <a:extLst xmlns:a="http://schemas.openxmlformats.org/drawingml/2006/main">
               <a:ext uri="{FF2B5EF4-FFF2-40B4-BE49-F238E27FC236}">
-                <a16:creationId xmlns:a16="http://schemas.microsoft.com/office/drawing/2014/main" id="{E23DA488-E818-4020-8F70-B636C8D22546}"/>
+                <a16:creationId xmlns:a16="http://schemas.microsoft.com/office/drawing/2014/main" id="{9CD367A2-9B3B-4129-9FF3-FCBB6DC901E0}"/>
               </a:ext>
             </a:extLst>
           </p:cNvPr>
@@ -2385,7 +2385,7 @@
           <p:cNvPr id="6" name="">
             <a:extLst xmlns:a="http://schemas.openxmlformats.org/drawingml/2006/main">
               <a:ext uri="{FF2B5EF4-FFF2-40B4-BE49-F238E27FC236}">
-                <a16:creationId xmlns:a16="http://schemas.microsoft.com/office/drawing/2014/main" id="{197C5A72-1EF0-4DCD-A743-B8A26F82C2D9}"/>
+                <a16:creationId xmlns:a16="http://schemas.microsoft.com/office/drawing/2014/main" id="{D216E253-673E-470A-BEF0-065B711D4FC1}"/>
               </a:ext>
             </a:extLst>
           </p:cNvPr>
@@ -2449,7 +2449,7 @@
           <p:cNvPr id="7" name="">
             <a:extLst xmlns:a="http://schemas.openxmlformats.org/drawingml/2006/main">
               <a:ext uri="{FF2B5EF4-FFF2-40B4-BE49-F238E27FC236}">
-                <a16:creationId xmlns:a16="http://schemas.microsoft.com/office/drawing/2014/main" id="{3291BE63-3D3F-445B-8146-C14E49B9ABC5}"/>
+                <a16:creationId xmlns:a16="http://schemas.microsoft.com/office/drawing/2014/main" id="{F27EE8A9-9ECD-4D93-88B5-5B01D1CBFAC9}"/>
               </a:ext>
             </a:extLst>
           </p:cNvPr>
@@ -2513,7 +2513,7 @@
           <p:cNvPr id="8" name="">
             <a:extLst xmlns:a="http://schemas.openxmlformats.org/drawingml/2006/main">
               <a:ext uri="{FF2B5EF4-FFF2-40B4-BE49-F238E27FC236}">
-                <a16:creationId xmlns:a16="http://schemas.microsoft.com/office/drawing/2014/main" id="{1B152180-E394-419B-B6A3-2232C110C5D0}"/>
+                <a16:creationId xmlns:a16="http://schemas.microsoft.com/office/drawing/2014/main" id="{9E08E1C8-F955-4A5A-85D6-3676CB3E6B20}"/>
               </a:ext>
             </a:extLst>
           </p:cNvPr>
@@ -2577,7 +2577,7 @@
           <p:cNvPr id="9" name="">
             <a:extLst xmlns:a="http://schemas.openxmlformats.org/drawingml/2006/main">
               <a:ext uri="{FF2B5EF4-FFF2-40B4-BE49-F238E27FC236}">
-                <a16:creationId xmlns:a16="http://schemas.microsoft.com/office/drawing/2014/main" id="{646B82D8-0339-4132-BC8A-A2AA7740BB6F}"/>
+                <a16:creationId xmlns:a16="http://schemas.microsoft.com/office/drawing/2014/main" id="{CB88DC4D-79A5-4839-8334-1EF48278F5F8}"/>
               </a:ext>
             </a:extLst>
           </p:cNvPr>
@@ -2641,7 +2641,7 @@
           <p:cNvPr id="10" name="">
             <a:extLst xmlns:a="http://schemas.openxmlformats.org/drawingml/2006/main">
               <a:ext uri="{FF2B5EF4-FFF2-40B4-BE49-F238E27FC236}">
-                <a16:creationId xmlns:a16="http://schemas.microsoft.com/office/drawing/2014/main" id="{831907A3-D80F-41F1-9EE4-011729692953}"/>
+                <a16:creationId xmlns:a16="http://schemas.microsoft.com/office/drawing/2014/main" id="{6B9B6CBD-3FD0-4941-8A9A-4C2CEDB71DBC}"/>
               </a:ext>
             </a:extLst>
           </p:cNvPr>
@@ -2703,7 +2703,7 @@
     </p:spTree>
     <p:extLst>
       <p:ext uri="{BB962C8B-B14F-4D97-AF65-F5344CB8AC3E}">
-        <p14:creationId xmlns:p14="http://schemas.microsoft.com/office/powerpoint/2010/main" val="1082675065"/>
+        <p14:creationId xmlns:p14="http://schemas.microsoft.com/office/powerpoint/2010/main" val="1144226744"/>
       </p:ext>
     </p:extLst>
   </p:cSld>
@@ -2727,7 +2727,7 @@
           <p:cNvPr id="1" name="">
             <a:extLst xmlns:a="http://schemas.openxmlformats.org/drawingml/2006/main">
               <a:ext uri="{FF2B5EF4-FFF2-40B4-BE49-F238E27FC236}">
-                <a16:creationId xmlns:a16="http://schemas.microsoft.com/office/drawing/2014/main" id="{C1AE9AE8-03B9-429C-A1B4-73B07FEEC516}"/>
+                <a16:creationId xmlns:a16="http://schemas.microsoft.com/office/drawing/2014/main" id="{AF1225CE-AE12-41EC-8CD8-066375C03482}"/>
               </a:ext>
             </a:extLst>
           </p:cNvPr>
@@ -2762,7 +2762,7 @@
           <p:cNvPr id="2" name="">
             <a:extLst xmlns:a="http://schemas.openxmlformats.org/drawingml/2006/main">
               <a:ext uri="{FF2B5EF4-FFF2-40B4-BE49-F238E27FC236}">
-                <a16:creationId xmlns:a16="http://schemas.microsoft.com/office/drawing/2014/main" id="{B0742B51-C7EA-48E1-A73D-397DC2D4BB63}"/>
+                <a16:creationId xmlns:a16="http://schemas.microsoft.com/office/drawing/2014/main" id="{1E44224B-72A8-4447-8E8B-0DA99F70D3BA}"/>
               </a:ext>
             </a:extLst>
           </p:cNvPr>
@@ -2797,7 +2797,7 @@
           <p:cNvPr id="3" name="">
             <a:extLst xmlns:a="http://schemas.openxmlformats.org/drawingml/2006/main">
               <a:ext uri="{FF2B5EF4-FFF2-40B4-BE49-F238E27FC236}">
-                <a16:creationId xmlns:a16="http://schemas.microsoft.com/office/drawing/2014/main" id="{FB328688-CCCE-4642-8CFA-E75258F1964F}"/>
+                <a16:creationId xmlns:a16="http://schemas.microsoft.com/office/drawing/2014/main" id="{56117049-FBAC-4D18-BA44-6B80F69CB178}"/>
               </a:ext>
             </a:extLst>
           </p:cNvPr>
@@ -2832,7 +2832,7 @@
           <p:cNvPr id="4" name="kicker-10-label">
             <a:extLst xmlns:a="http://schemas.openxmlformats.org/drawingml/2006/main">
               <a:ext uri="{FF2B5EF4-FFF2-40B4-BE49-F238E27FC236}">
-                <a16:creationId xmlns:a16="http://schemas.microsoft.com/office/drawing/2014/main" id="{330C3BA2-D2B1-4AD0-A97C-9AD61F590F68}"/>
+                <a16:creationId xmlns:a16="http://schemas.microsoft.com/office/drawing/2014/main" id="{620E696A-7148-40A0-8E9A-ECF50B1730E4}"/>
               </a:ext>
             </a:extLst>
           </p:cNvPr>
@@ -2896,7 +2896,7 @@
           <p:cNvPr id="5" name="">
             <a:extLst xmlns:a="http://schemas.openxmlformats.org/drawingml/2006/main">
               <a:ext uri="{FF2B5EF4-FFF2-40B4-BE49-F238E27FC236}">
-                <a16:creationId xmlns:a16="http://schemas.microsoft.com/office/drawing/2014/main" id="{4923AA4F-2F3A-4B4B-BC1D-EF9DCDE1DE10}"/>
+                <a16:creationId xmlns:a16="http://schemas.microsoft.com/office/drawing/2014/main" id="{F627EB3C-C035-459F-9FE6-2558B234BC98}"/>
               </a:ext>
             </a:extLst>
           </p:cNvPr>
@@ -2960,7 +2960,7 @@
           <p:cNvPr id="6" name="">
             <a:extLst xmlns:a="http://schemas.openxmlformats.org/drawingml/2006/main">
               <a:ext uri="{FF2B5EF4-FFF2-40B4-BE49-F238E27FC236}">
-                <a16:creationId xmlns:a16="http://schemas.microsoft.com/office/drawing/2014/main" id="{F4B0F857-06DB-4E88-80FC-AF387A523279}"/>
+                <a16:creationId xmlns:a16="http://schemas.microsoft.com/office/drawing/2014/main" id="{3D03F64E-F7CD-4623-AF34-45A7C1661D1B}"/>
               </a:ext>
             </a:extLst>
           </p:cNvPr>
@@ -3024,7 +3024,7 @@
           <p:cNvPr id="7" name="">
             <a:extLst xmlns:a="http://schemas.openxmlformats.org/drawingml/2006/main">
               <a:ext uri="{FF2B5EF4-FFF2-40B4-BE49-F238E27FC236}">
-                <a16:creationId xmlns:a16="http://schemas.microsoft.com/office/drawing/2014/main" id="{32423173-DBC8-4E7C-B54B-C8BC61136996}"/>
+                <a16:creationId xmlns:a16="http://schemas.microsoft.com/office/drawing/2014/main" id="{DA4E1589-329A-45C1-AF77-F7B6267911DA}"/>
               </a:ext>
             </a:extLst>
           </p:cNvPr>
@@ -3061,7 +3061,7 @@
           <p:nvPr/>
         </p:nvPicPr>
         <p:blipFill>
-          <a:blip xmlns:r="http://schemas.openxmlformats.org/officeDocument/2006/relationships" xmlns:a="http://schemas.openxmlformats.org/drawingml/2006/main" r:embed="R716999d0b1e249bf"/>
+          <a:blip xmlns:r="http://schemas.openxmlformats.org/officeDocument/2006/relationships" xmlns:a="http://schemas.openxmlformats.org/drawingml/2006/main" r:embed="R9e716ffe152e4f22"/>
           <a:stretch xmlns:a="http://schemas.openxmlformats.org/drawingml/2006/main"/>
         </p:blipFill>
         <p:spPr>
@@ -3079,7 +3079,7 @@
           <p:cNvPr id="9" name="">
             <a:extLst xmlns:a="http://schemas.openxmlformats.org/drawingml/2006/main">
               <a:ext uri="{FF2B5EF4-FFF2-40B4-BE49-F238E27FC236}">
-                <a16:creationId xmlns:a16="http://schemas.microsoft.com/office/drawing/2014/main" id="{CD92136A-A164-4DE4-B6E2-2074705F9CC0}"/>
+                <a16:creationId xmlns:a16="http://schemas.microsoft.com/office/drawing/2014/main" id="{C5745CF5-2E6B-4D9C-B3C7-3AB9F5189F03}"/>
               </a:ext>
             </a:extLst>
           </p:cNvPr>
@@ -3141,7 +3141,7 @@
     </p:spTree>
     <p:extLst>
       <p:ext uri="{BB962C8B-B14F-4D97-AF65-F5344CB8AC3E}">
-        <p14:creationId xmlns:p14="http://schemas.microsoft.com/office/powerpoint/2010/main" val="1911870863"/>
+        <p14:creationId xmlns:p14="http://schemas.microsoft.com/office/powerpoint/2010/main" val="1029712221"/>
       </p:ext>
     </p:extLst>
   </p:cSld>
@@ -3165,7 +3165,7 @@
           <p:cNvPr id="1" name="">
             <a:extLst xmlns:a="http://schemas.openxmlformats.org/drawingml/2006/main">
               <a:ext uri="{FF2B5EF4-FFF2-40B4-BE49-F238E27FC236}">
-                <a16:creationId xmlns:a16="http://schemas.microsoft.com/office/drawing/2014/main" id="{0DD17672-45DB-4A72-B063-3B0D3A66B8FF}"/>
+                <a16:creationId xmlns:a16="http://schemas.microsoft.com/office/drawing/2014/main" id="{64B99FCE-56EB-4FBA-9D21-66670D512624}"/>
               </a:ext>
             </a:extLst>
           </p:cNvPr>
@@ -3200,7 +3200,7 @@
           <p:cNvPr id="2" name="">
             <a:extLst xmlns:a="http://schemas.openxmlformats.org/drawingml/2006/main">
               <a:ext uri="{FF2B5EF4-FFF2-40B4-BE49-F238E27FC236}">
-                <a16:creationId xmlns:a16="http://schemas.microsoft.com/office/drawing/2014/main" id="{C02D3180-2181-42F6-A292-0307E1CFC4D9}"/>
+                <a16:creationId xmlns:a16="http://schemas.microsoft.com/office/drawing/2014/main" id="{EF865899-0555-4542-9895-B9B7ACF996B3}"/>
               </a:ext>
             </a:extLst>
           </p:cNvPr>
@@ -3235,7 +3235,7 @@
           <p:cNvPr id="3" name="">
             <a:extLst xmlns:a="http://schemas.openxmlformats.org/drawingml/2006/main">
               <a:ext uri="{FF2B5EF4-FFF2-40B4-BE49-F238E27FC236}">
-                <a16:creationId xmlns:a16="http://schemas.microsoft.com/office/drawing/2014/main" id="{1821D2A5-D8F5-4357-A530-371DE1414E4E}"/>
+                <a16:creationId xmlns:a16="http://schemas.microsoft.com/office/drawing/2014/main" id="{6A98387F-1726-4238-8860-B29E53238C8B}"/>
               </a:ext>
             </a:extLst>
           </p:cNvPr>
@@ -3270,7 +3270,7 @@
           <p:cNvPr id="4" name="kicker-11-label">
             <a:extLst xmlns:a="http://schemas.openxmlformats.org/drawingml/2006/main">
               <a:ext uri="{FF2B5EF4-FFF2-40B4-BE49-F238E27FC236}">
-                <a16:creationId xmlns:a16="http://schemas.microsoft.com/office/drawing/2014/main" id="{A1BD1C8F-4DD0-4F92-AA90-4272DCBC277B}"/>
+                <a16:creationId xmlns:a16="http://schemas.microsoft.com/office/drawing/2014/main" id="{646C5D19-B148-4DAF-BE52-0C07757A323E}"/>
               </a:ext>
             </a:extLst>
           </p:cNvPr>
@@ -3334,7 +3334,7 @@
           <p:cNvPr id="5" name="">
             <a:extLst xmlns:a="http://schemas.openxmlformats.org/drawingml/2006/main">
               <a:ext uri="{FF2B5EF4-FFF2-40B4-BE49-F238E27FC236}">
-                <a16:creationId xmlns:a16="http://schemas.microsoft.com/office/drawing/2014/main" id="{F21C8836-B364-4650-A7A0-E577CF6E671B}"/>
+                <a16:creationId xmlns:a16="http://schemas.microsoft.com/office/drawing/2014/main" id="{3E5DC538-E401-4561-9CCE-4AD912532D10}"/>
               </a:ext>
             </a:extLst>
           </p:cNvPr>
@@ -3398,7 +3398,7 @@
           <p:cNvPr id="6" name="">
             <a:extLst xmlns:a="http://schemas.openxmlformats.org/drawingml/2006/main">
               <a:ext uri="{FF2B5EF4-FFF2-40B4-BE49-F238E27FC236}">
-                <a16:creationId xmlns:a16="http://schemas.microsoft.com/office/drawing/2014/main" id="{FA0687A1-A3CE-4355-8852-2B3003E9A060}"/>
+                <a16:creationId xmlns:a16="http://schemas.microsoft.com/office/drawing/2014/main" id="{9AE0BFC1-D082-4D8C-B6B4-506C20596F68}"/>
               </a:ext>
             </a:extLst>
           </p:cNvPr>
@@ -3452,7 +3452,7 @@
                 <a:ea typeface="Arial"/>
                 <a:cs typeface="Arial"/>
               </a:rPr>
-              <a:t>O fluxo distingue validação física real e caminho escalável por sensores/gateways.</a:t>
+              <a:t>O fluxo distingue validação física real e caminho escalável com sensores e gateways.</a:t>
             </a:r>
           </a:p>
         </p:txBody>
@@ -3462,7 +3462,7 @@
           <p:cNvPr id="7" name="">
             <a:extLst xmlns:a="http://schemas.openxmlformats.org/drawingml/2006/main">
               <a:ext uri="{FF2B5EF4-FFF2-40B4-BE49-F238E27FC236}">
-                <a16:creationId xmlns:a16="http://schemas.microsoft.com/office/drawing/2014/main" id="{464EBA6B-359C-4A4D-92B0-5B744ED0AAE1}"/>
+                <a16:creationId xmlns:a16="http://schemas.microsoft.com/office/drawing/2014/main" id="{EE192D1D-3D20-4BDF-B8C2-459DCE5E0279}"/>
               </a:ext>
             </a:extLst>
           </p:cNvPr>
@@ -3495,7 +3495,7 @@
           <p:cNvPr id="8" name="">
             <a:extLst xmlns:a="http://schemas.openxmlformats.org/drawingml/2006/main">
               <a:ext uri="{FF2B5EF4-FFF2-40B4-BE49-F238E27FC236}">
-                <a16:creationId xmlns:a16="http://schemas.microsoft.com/office/drawing/2014/main" id="{3B59E23C-225C-465A-BE87-1F50F23B1C8B}"/>
+                <a16:creationId xmlns:a16="http://schemas.microsoft.com/office/drawing/2014/main" id="{0C62A640-F4F2-4E75-A0F3-A0418F5911E9}"/>
               </a:ext>
             </a:extLst>
           </p:cNvPr>
@@ -3528,7 +3528,7 @@
           <p:cNvPr id="9" name="">
             <a:extLst xmlns:a="http://schemas.openxmlformats.org/drawingml/2006/main">
               <a:ext uri="{FF2B5EF4-FFF2-40B4-BE49-F238E27FC236}">
-                <a16:creationId xmlns:a16="http://schemas.microsoft.com/office/drawing/2014/main" id="{3E4A55EB-6001-4A27-B7D0-D86857FB0630}"/>
+                <a16:creationId xmlns:a16="http://schemas.microsoft.com/office/drawing/2014/main" id="{D4309A75-478A-4262-A709-127FD611ABE9}"/>
               </a:ext>
             </a:extLst>
           </p:cNvPr>
@@ -3592,7 +3592,7 @@
           <p:cNvPr id="10" name="">
             <a:extLst xmlns:a="http://schemas.openxmlformats.org/drawingml/2006/main">
               <a:ext uri="{FF2B5EF4-FFF2-40B4-BE49-F238E27FC236}">
-                <a16:creationId xmlns:a16="http://schemas.microsoft.com/office/drawing/2014/main" id="{C218DF58-B0D3-483E-8179-C19710B89836}"/>
+                <a16:creationId xmlns:a16="http://schemas.microsoft.com/office/drawing/2014/main" id="{38986266-F57B-4209-ACA5-265978A8C082}"/>
               </a:ext>
             </a:extLst>
           </p:cNvPr>
@@ -3625,7 +3625,7 @@
           <p:cNvPr id="11" name="">
             <a:extLst xmlns:a="http://schemas.openxmlformats.org/drawingml/2006/main">
               <a:ext uri="{FF2B5EF4-FFF2-40B4-BE49-F238E27FC236}">
-                <a16:creationId xmlns:a16="http://schemas.microsoft.com/office/drawing/2014/main" id="{3294D65D-8644-4D23-A8DC-4919A39EA901}"/>
+                <a16:creationId xmlns:a16="http://schemas.microsoft.com/office/drawing/2014/main" id="{512FD235-DB2A-4A6A-8C9C-B40D8D00EBCC}"/>
               </a:ext>
             </a:extLst>
           </p:cNvPr>
@@ -3689,7 +3689,7 @@
           <p:cNvPr id="12" name="">
             <a:extLst xmlns:a="http://schemas.openxmlformats.org/drawingml/2006/main">
               <a:ext uri="{FF2B5EF4-FFF2-40B4-BE49-F238E27FC236}">
-                <a16:creationId xmlns:a16="http://schemas.microsoft.com/office/drawing/2014/main" id="{9C72E8EF-7A03-46E4-84F0-92AC093EB3E9}"/>
+                <a16:creationId xmlns:a16="http://schemas.microsoft.com/office/drawing/2014/main" id="{1E170B36-61E5-471D-A25A-7FED3008FA74}"/>
               </a:ext>
             </a:extLst>
           </p:cNvPr>
@@ -3753,7 +3753,7 @@
           <p:cNvPr id="13" name="">
             <a:extLst xmlns:a="http://schemas.openxmlformats.org/drawingml/2006/main">
               <a:ext uri="{FF2B5EF4-FFF2-40B4-BE49-F238E27FC236}">
-                <a16:creationId xmlns:a16="http://schemas.microsoft.com/office/drawing/2014/main" id="{3457AEBA-55C9-456F-A6F0-33ACA5C75D1D}"/>
+                <a16:creationId xmlns:a16="http://schemas.microsoft.com/office/drawing/2014/main" id="{125E5ECB-0BBF-4DCF-B7CC-C67018815F37}"/>
               </a:ext>
             </a:extLst>
           </p:cNvPr>
@@ -3786,7 +3786,7 @@
           <p:cNvPr id="14" name="">
             <a:extLst xmlns:a="http://schemas.openxmlformats.org/drawingml/2006/main">
               <a:ext uri="{FF2B5EF4-FFF2-40B4-BE49-F238E27FC236}">
-                <a16:creationId xmlns:a16="http://schemas.microsoft.com/office/drawing/2014/main" id="{90101C80-6295-438F-AB0E-E31823A56D5A}"/>
+                <a16:creationId xmlns:a16="http://schemas.microsoft.com/office/drawing/2014/main" id="{4288898E-0C6F-4AA4-8999-9D233F20B9E7}"/>
               </a:ext>
             </a:extLst>
           </p:cNvPr>
@@ -3850,7 +3850,7 @@
           <p:cNvPr id="15" name="">
             <a:extLst xmlns:a="http://schemas.openxmlformats.org/drawingml/2006/main">
               <a:ext uri="{FF2B5EF4-FFF2-40B4-BE49-F238E27FC236}">
-                <a16:creationId xmlns:a16="http://schemas.microsoft.com/office/drawing/2014/main" id="{A168F899-6A95-4E0D-A4F6-8F89784CDBCF}"/>
+                <a16:creationId xmlns:a16="http://schemas.microsoft.com/office/drawing/2014/main" id="{96F67145-F3A9-4038-BB21-DCDD5F41EAF5}"/>
               </a:ext>
             </a:extLst>
           </p:cNvPr>
@@ -3914,7 +3914,7 @@
           <p:cNvPr id="16" name="">
             <a:extLst xmlns:a="http://schemas.openxmlformats.org/drawingml/2006/main">
               <a:ext uri="{FF2B5EF4-FFF2-40B4-BE49-F238E27FC236}">
-                <a16:creationId xmlns:a16="http://schemas.microsoft.com/office/drawing/2014/main" id="{3C5E0119-EAC7-408B-A8E7-34D980E0BF38}"/>
+                <a16:creationId xmlns:a16="http://schemas.microsoft.com/office/drawing/2014/main" id="{2D524AD9-E3D0-4F7A-BC9E-21B7162323BF}"/>
               </a:ext>
             </a:extLst>
           </p:cNvPr>
@@ -3947,7 +3947,7 @@
           <p:cNvPr id="17" name="">
             <a:extLst xmlns:a="http://schemas.openxmlformats.org/drawingml/2006/main">
               <a:ext uri="{FF2B5EF4-FFF2-40B4-BE49-F238E27FC236}">
-                <a16:creationId xmlns:a16="http://schemas.microsoft.com/office/drawing/2014/main" id="{87E3118D-BA3C-4027-8355-18C73E47BEEE}"/>
+                <a16:creationId xmlns:a16="http://schemas.microsoft.com/office/drawing/2014/main" id="{E130B39F-A39D-4336-92EF-835D3481F17D}"/>
               </a:ext>
             </a:extLst>
           </p:cNvPr>
@@ -4011,7 +4011,7 @@
           <p:cNvPr id="18" name="">
             <a:extLst xmlns:a="http://schemas.openxmlformats.org/drawingml/2006/main">
               <a:ext uri="{FF2B5EF4-FFF2-40B4-BE49-F238E27FC236}">
-                <a16:creationId xmlns:a16="http://schemas.microsoft.com/office/drawing/2014/main" id="{866A4DB9-DBED-4158-85B9-B56893A98157}"/>
+                <a16:creationId xmlns:a16="http://schemas.microsoft.com/office/drawing/2014/main" id="{EEA5295C-238F-4A04-8F69-B96D75A03803}"/>
               </a:ext>
             </a:extLst>
           </p:cNvPr>
@@ -4075,7 +4075,7 @@
           <p:cNvPr id="19" name="">
             <a:extLst xmlns:a="http://schemas.openxmlformats.org/drawingml/2006/main">
               <a:ext uri="{FF2B5EF4-FFF2-40B4-BE49-F238E27FC236}">
-                <a16:creationId xmlns:a16="http://schemas.microsoft.com/office/drawing/2014/main" id="{3DDF8EFE-8BD2-40F3-BE72-F6747977D9A3}"/>
+                <a16:creationId xmlns:a16="http://schemas.microsoft.com/office/drawing/2014/main" id="{9DB82AD1-E7DB-469C-B0C5-4B382A793AF4}"/>
               </a:ext>
             </a:extLst>
           </p:cNvPr>
@@ -4108,7 +4108,7 @@
           <p:cNvPr id="20" name="">
             <a:extLst xmlns:a="http://schemas.openxmlformats.org/drawingml/2006/main">
               <a:ext uri="{FF2B5EF4-FFF2-40B4-BE49-F238E27FC236}">
-                <a16:creationId xmlns:a16="http://schemas.microsoft.com/office/drawing/2014/main" id="{196E6010-05F7-4807-9CBB-1FB9EC2B4097}"/>
+                <a16:creationId xmlns:a16="http://schemas.microsoft.com/office/drawing/2014/main" id="{FBACFC25-BEDF-44A3-953A-BE3ACA8A5DDB}"/>
               </a:ext>
             </a:extLst>
           </p:cNvPr>
@@ -4172,7 +4172,7 @@
           <p:cNvPr id="21" name="">
             <a:extLst xmlns:a="http://schemas.openxmlformats.org/drawingml/2006/main">
               <a:ext uri="{FF2B5EF4-FFF2-40B4-BE49-F238E27FC236}">
-                <a16:creationId xmlns:a16="http://schemas.microsoft.com/office/drawing/2014/main" id="{9F6A50E3-BF46-4037-B324-48C8BD9F1309}"/>
+                <a16:creationId xmlns:a16="http://schemas.microsoft.com/office/drawing/2014/main" id="{E3B36849-FBCA-4048-BA82-7665FD21C042}"/>
               </a:ext>
             </a:extLst>
           </p:cNvPr>
@@ -4236,7 +4236,7 @@
           <p:cNvPr id="22" name="">
             <a:extLst xmlns:a="http://schemas.openxmlformats.org/drawingml/2006/main">
               <a:ext uri="{FF2B5EF4-FFF2-40B4-BE49-F238E27FC236}">
-                <a16:creationId xmlns:a16="http://schemas.microsoft.com/office/drawing/2014/main" id="{57B9FC0D-EF09-48D1-A572-489E945B8990}"/>
+                <a16:creationId xmlns:a16="http://schemas.microsoft.com/office/drawing/2014/main" id="{0CD1DFB3-ECCF-4F80-9C30-FFA48AA262A2}"/>
               </a:ext>
             </a:extLst>
           </p:cNvPr>
@@ -4271,7 +4271,7 @@
           <p:cNvPr id="23" name="">
             <a:extLst xmlns:a="http://schemas.openxmlformats.org/drawingml/2006/main">
               <a:ext uri="{FF2B5EF4-FFF2-40B4-BE49-F238E27FC236}">
-                <a16:creationId xmlns:a16="http://schemas.microsoft.com/office/drawing/2014/main" id="{DE879521-8375-47CF-880D-176DF922CF09}"/>
+                <a16:creationId xmlns:a16="http://schemas.microsoft.com/office/drawing/2014/main" id="{AA401C1D-EFFF-4F7C-A129-6CAA066B8D2B}"/>
               </a:ext>
             </a:extLst>
           </p:cNvPr>
@@ -4335,7 +4335,7 @@
           <p:cNvPr id="24" name="">
             <a:extLst xmlns:a="http://schemas.openxmlformats.org/drawingml/2006/main">
               <a:ext uri="{FF2B5EF4-FFF2-40B4-BE49-F238E27FC236}">
-                <a16:creationId xmlns:a16="http://schemas.microsoft.com/office/drawing/2014/main" id="{359F98B7-4562-4DE3-AD96-C5A9E9EB4CBE}"/>
+                <a16:creationId xmlns:a16="http://schemas.microsoft.com/office/drawing/2014/main" id="{150B8182-861A-48E4-ADCE-4B09C92717DE}"/>
               </a:ext>
             </a:extLst>
           </p:cNvPr>
@@ -4368,7 +4368,7 @@
           <p:cNvPr id="25" name="">
             <a:extLst xmlns:a="http://schemas.openxmlformats.org/drawingml/2006/main">
               <a:ext uri="{FF2B5EF4-FFF2-40B4-BE49-F238E27FC236}">
-                <a16:creationId xmlns:a16="http://schemas.microsoft.com/office/drawing/2014/main" id="{B53B0D52-59A0-46A1-8DD0-959BB306F98E}"/>
+                <a16:creationId xmlns:a16="http://schemas.microsoft.com/office/drawing/2014/main" id="{89E8B19A-1D59-455F-8029-78AE70327EF3}"/>
               </a:ext>
             </a:extLst>
           </p:cNvPr>
@@ -4401,7 +4401,7 @@
           <p:cNvPr id="26" name="">
             <a:extLst xmlns:a="http://schemas.openxmlformats.org/drawingml/2006/main">
               <a:ext uri="{FF2B5EF4-FFF2-40B4-BE49-F238E27FC236}">
-                <a16:creationId xmlns:a16="http://schemas.microsoft.com/office/drawing/2014/main" id="{99592252-6308-4E17-80F7-531BC64384C5}"/>
+                <a16:creationId xmlns:a16="http://schemas.microsoft.com/office/drawing/2014/main" id="{0A3C2C4C-BA8F-4D0D-9D6D-85FD8C4CEDE7}"/>
               </a:ext>
             </a:extLst>
           </p:cNvPr>
@@ -4465,7 +4465,7 @@
           <p:cNvPr id="27" name="">
             <a:extLst xmlns:a="http://schemas.openxmlformats.org/drawingml/2006/main">
               <a:ext uri="{FF2B5EF4-FFF2-40B4-BE49-F238E27FC236}">
-                <a16:creationId xmlns:a16="http://schemas.microsoft.com/office/drawing/2014/main" id="{64DE7FA6-6DCD-45C4-BBC5-48C0E3D9085C}"/>
+                <a16:creationId xmlns:a16="http://schemas.microsoft.com/office/drawing/2014/main" id="{65E62B8B-8242-43F3-A17A-4C552DD9E99F}"/>
               </a:ext>
             </a:extLst>
           </p:cNvPr>
@@ -4498,7 +4498,7 @@
           <p:cNvPr id="28" name="">
             <a:extLst xmlns:a="http://schemas.openxmlformats.org/drawingml/2006/main">
               <a:ext uri="{FF2B5EF4-FFF2-40B4-BE49-F238E27FC236}">
-                <a16:creationId xmlns:a16="http://schemas.microsoft.com/office/drawing/2014/main" id="{F4F9DF70-4046-431C-9B8F-CF1CB84CA69D}"/>
+                <a16:creationId xmlns:a16="http://schemas.microsoft.com/office/drawing/2014/main" id="{CB524AEE-D6C1-41CF-8BA1-37C93691DD04}"/>
               </a:ext>
             </a:extLst>
           </p:cNvPr>
@@ -4562,7 +4562,7 @@
           <p:cNvPr id="29" name="">
             <a:extLst xmlns:a="http://schemas.openxmlformats.org/drawingml/2006/main">
               <a:ext uri="{FF2B5EF4-FFF2-40B4-BE49-F238E27FC236}">
-                <a16:creationId xmlns:a16="http://schemas.microsoft.com/office/drawing/2014/main" id="{938E93DC-9382-496E-92ED-A6A97DEAFF1D}"/>
+                <a16:creationId xmlns:a16="http://schemas.microsoft.com/office/drawing/2014/main" id="{4724E3E5-8B64-4E4E-8158-E4C5E08FD66B}"/>
               </a:ext>
             </a:extLst>
           </p:cNvPr>
@@ -4616,7 +4616,7 @@
                 <a:ea typeface="Arial"/>
                 <a:cs typeface="Arial"/>
               </a:rPr>
-              <a:t>Sensor/gateway</a:t>
+              <a:t>Sensor ou gateway</a:t>
             </a:r>
           </a:p>
         </p:txBody>
@@ -4626,7 +4626,7 @@
           <p:cNvPr id="30" name="">
             <a:extLst xmlns:a="http://schemas.openxmlformats.org/drawingml/2006/main">
               <a:ext uri="{FF2B5EF4-FFF2-40B4-BE49-F238E27FC236}">
-                <a16:creationId xmlns:a16="http://schemas.microsoft.com/office/drawing/2014/main" id="{4E9B4F9D-ED00-4A92-8C3A-A34FE89E492F}"/>
+                <a16:creationId xmlns:a16="http://schemas.microsoft.com/office/drawing/2014/main" id="{DBCB68A9-43AD-4589-A078-136CE8F038A6}"/>
               </a:ext>
             </a:extLst>
           </p:cNvPr>
@@ -4659,7 +4659,7 @@
           <p:cNvPr id="31" name="">
             <a:extLst xmlns:a="http://schemas.openxmlformats.org/drawingml/2006/main">
               <a:ext uri="{FF2B5EF4-FFF2-40B4-BE49-F238E27FC236}">
-                <a16:creationId xmlns:a16="http://schemas.microsoft.com/office/drawing/2014/main" id="{3E068CDA-A696-4828-9FF7-36EE50708621}"/>
+                <a16:creationId xmlns:a16="http://schemas.microsoft.com/office/drawing/2014/main" id="{9B972962-7378-41BC-BD96-8665E926D2E7}"/>
               </a:ext>
             </a:extLst>
           </p:cNvPr>
@@ -4723,7 +4723,7 @@
           <p:cNvPr id="32" name="">
             <a:extLst xmlns:a="http://schemas.openxmlformats.org/drawingml/2006/main">
               <a:ext uri="{FF2B5EF4-FFF2-40B4-BE49-F238E27FC236}">
-                <a16:creationId xmlns:a16="http://schemas.microsoft.com/office/drawing/2014/main" id="{FC30F6A9-20F0-4528-8A28-6AB6D16E0B9F}"/>
+                <a16:creationId xmlns:a16="http://schemas.microsoft.com/office/drawing/2014/main" id="{8575C622-08EB-48DB-BCAF-240844DB44B5}"/>
               </a:ext>
             </a:extLst>
           </p:cNvPr>
@@ -4787,7 +4787,7 @@
           <p:cNvPr id="33" name="">
             <a:extLst xmlns:a="http://schemas.openxmlformats.org/drawingml/2006/main">
               <a:ext uri="{FF2B5EF4-FFF2-40B4-BE49-F238E27FC236}">
-                <a16:creationId xmlns:a16="http://schemas.microsoft.com/office/drawing/2014/main" id="{F98E9121-3336-45B0-B271-83D53BFB0241}"/>
+                <a16:creationId xmlns:a16="http://schemas.microsoft.com/office/drawing/2014/main" id="{EC12748B-FD33-4AE3-BE6C-09C82642473E}"/>
               </a:ext>
             </a:extLst>
           </p:cNvPr>
@@ -4820,7 +4820,7 @@
           <p:cNvPr id="34" name="">
             <a:extLst xmlns:a="http://schemas.openxmlformats.org/drawingml/2006/main">
               <a:ext uri="{FF2B5EF4-FFF2-40B4-BE49-F238E27FC236}">
-                <a16:creationId xmlns:a16="http://schemas.microsoft.com/office/drawing/2014/main" id="{0FF56449-A461-42F7-9179-D31BDA4A0991}"/>
+                <a16:creationId xmlns:a16="http://schemas.microsoft.com/office/drawing/2014/main" id="{1035CC6E-27DF-4761-9B3B-F82A80322641}"/>
               </a:ext>
             </a:extLst>
           </p:cNvPr>
@@ -4884,7 +4884,7 @@
           <p:cNvPr id="35" name="">
             <a:extLst xmlns:a="http://schemas.openxmlformats.org/drawingml/2006/main">
               <a:ext uri="{FF2B5EF4-FFF2-40B4-BE49-F238E27FC236}">
-                <a16:creationId xmlns:a16="http://schemas.microsoft.com/office/drawing/2014/main" id="{89C6F905-C56E-476F-ACF4-5B48D844CF9A}"/>
+                <a16:creationId xmlns:a16="http://schemas.microsoft.com/office/drawing/2014/main" id="{BBE67BF5-B488-4FBE-8709-A338A880BE8F}"/>
               </a:ext>
             </a:extLst>
           </p:cNvPr>
@@ -4948,7 +4948,7 @@
           <p:cNvPr id="36" name="">
             <a:extLst xmlns:a="http://schemas.openxmlformats.org/drawingml/2006/main">
               <a:ext uri="{FF2B5EF4-FFF2-40B4-BE49-F238E27FC236}">
-                <a16:creationId xmlns:a16="http://schemas.microsoft.com/office/drawing/2014/main" id="{ED372D45-7FFE-4894-BE7D-DAA4E0CDB0B1}"/>
+                <a16:creationId xmlns:a16="http://schemas.microsoft.com/office/drawing/2014/main" id="{61A13AEC-E353-4DE4-847C-4E3DD2C8264E}"/>
               </a:ext>
             </a:extLst>
           </p:cNvPr>
@@ -4981,7 +4981,7 @@
           <p:cNvPr id="37" name="">
             <a:extLst xmlns:a="http://schemas.openxmlformats.org/drawingml/2006/main">
               <a:ext uri="{FF2B5EF4-FFF2-40B4-BE49-F238E27FC236}">
-                <a16:creationId xmlns:a16="http://schemas.microsoft.com/office/drawing/2014/main" id="{C944E605-E757-4A55-8EBF-DBB8BA0EB709}"/>
+                <a16:creationId xmlns:a16="http://schemas.microsoft.com/office/drawing/2014/main" id="{1B804B0C-CCC8-475D-85AB-29FB190BC496}"/>
               </a:ext>
             </a:extLst>
           </p:cNvPr>
@@ -5045,7 +5045,7 @@
           <p:cNvPr id="38" name="">
             <a:extLst xmlns:a="http://schemas.openxmlformats.org/drawingml/2006/main">
               <a:ext uri="{FF2B5EF4-FFF2-40B4-BE49-F238E27FC236}">
-                <a16:creationId xmlns:a16="http://schemas.microsoft.com/office/drawing/2014/main" id="{534CC665-6EC7-4C93-912D-BDC8ED7C2F5D}"/>
+                <a16:creationId xmlns:a16="http://schemas.microsoft.com/office/drawing/2014/main" id="{21091C81-89F4-46AD-8049-C23ADF14DCD5}"/>
               </a:ext>
             </a:extLst>
           </p:cNvPr>
@@ -5109,7 +5109,7 @@
           <p:cNvPr id="39" name="">
             <a:extLst xmlns:a="http://schemas.openxmlformats.org/drawingml/2006/main">
               <a:ext uri="{FF2B5EF4-FFF2-40B4-BE49-F238E27FC236}">
-                <a16:creationId xmlns:a16="http://schemas.microsoft.com/office/drawing/2014/main" id="{0AE0F045-65D4-4506-BEC5-16CF78B6B1D1}"/>
+                <a16:creationId xmlns:a16="http://schemas.microsoft.com/office/drawing/2014/main" id="{F60CDAAB-25DB-4228-B955-E826365FD0E5}"/>
               </a:ext>
             </a:extLst>
           </p:cNvPr>
@@ -5144,7 +5144,7 @@
           <p:cNvPr id="40" name="">
             <a:extLst xmlns:a="http://schemas.openxmlformats.org/drawingml/2006/main">
               <a:ext uri="{FF2B5EF4-FFF2-40B4-BE49-F238E27FC236}">
-                <a16:creationId xmlns:a16="http://schemas.microsoft.com/office/drawing/2014/main" id="{D250497B-6F4F-4D1E-9326-965B961B05BE}"/>
+                <a16:creationId xmlns:a16="http://schemas.microsoft.com/office/drawing/2014/main" id="{E67BD268-A5AF-4156-9169-7AC8D90DDD72}"/>
               </a:ext>
             </a:extLst>
           </p:cNvPr>
@@ -5206,7 +5206,7 @@
     </p:spTree>
     <p:extLst>
       <p:ext uri="{BB962C8B-B14F-4D97-AF65-F5344CB8AC3E}">
-        <p14:creationId xmlns:p14="http://schemas.microsoft.com/office/powerpoint/2010/main" val="1328647305"/>
+        <p14:creationId xmlns:p14="http://schemas.microsoft.com/office/powerpoint/2010/main" val="350447744"/>
       </p:ext>
     </p:extLst>
   </p:cSld>
@@ -5230,7 +5230,7 @@
           <p:cNvPr id="1" name="">
             <a:extLst xmlns:a="http://schemas.openxmlformats.org/drawingml/2006/main">
               <a:ext uri="{FF2B5EF4-FFF2-40B4-BE49-F238E27FC236}">
-                <a16:creationId xmlns:a16="http://schemas.microsoft.com/office/drawing/2014/main" id="{372A7132-EC90-438F-B04B-74FB4B5FCDE9}"/>
+                <a16:creationId xmlns:a16="http://schemas.microsoft.com/office/drawing/2014/main" id="{CFE34866-41AD-4D2F-A35F-F893412AC6D8}"/>
               </a:ext>
             </a:extLst>
           </p:cNvPr>
@@ -5265,7 +5265,7 @@
           <p:cNvPr id="2" name="">
             <a:extLst xmlns:a="http://schemas.openxmlformats.org/drawingml/2006/main">
               <a:ext uri="{FF2B5EF4-FFF2-40B4-BE49-F238E27FC236}">
-                <a16:creationId xmlns:a16="http://schemas.microsoft.com/office/drawing/2014/main" id="{11CCF71A-03F9-4052-A7C5-320DB7E0A77E}"/>
+                <a16:creationId xmlns:a16="http://schemas.microsoft.com/office/drawing/2014/main" id="{0494F262-E42A-4C10-B97C-39A27F6E7D61}"/>
               </a:ext>
             </a:extLst>
           </p:cNvPr>
@@ -5300,7 +5300,7 @@
           <p:cNvPr id="3" name="">
             <a:extLst xmlns:a="http://schemas.openxmlformats.org/drawingml/2006/main">
               <a:ext uri="{FF2B5EF4-FFF2-40B4-BE49-F238E27FC236}">
-                <a16:creationId xmlns:a16="http://schemas.microsoft.com/office/drawing/2014/main" id="{98B50E0C-0927-4D8F-9A0E-F70591A448AB}"/>
+                <a16:creationId xmlns:a16="http://schemas.microsoft.com/office/drawing/2014/main" id="{5776CE33-6847-4BEA-BB5D-878F189546FD}"/>
               </a:ext>
             </a:extLst>
           </p:cNvPr>
@@ -5335,7 +5335,7 @@
           <p:cNvPr id="4" name="kicker-12-label">
             <a:extLst xmlns:a="http://schemas.openxmlformats.org/drawingml/2006/main">
               <a:ext uri="{FF2B5EF4-FFF2-40B4-BE49-F238E27FC236}">
-                <a16:creationId xmlns:a16="http://schemas.microsoft.com/office/drawing/2014/main" id="{D48FCB2A-9205-43A8-BAD6-3384E7D65C01}"/>
+                <a16:creationId xmlns:a16="http://schemas.microsoft.com/office/drawing/2014/main" id="{058904E6-1D78-4809-858D-1158E7C96FD7}"/>
               </a:ext>
             </a:extLst>
           </p:cNvPr>
@@ -5399,7 +5399,7 @@
           <p:cNvPr id="5" name="">
             <a:extLst xmlns:a="http://schemas.openxmlformats.org/drawingml/2006/main">
               <a:ext uri="{FF2B5EF4-FFF2-40B4-BE49-F238E27FC236}">
-                <a16:creationId xmlns:a16="http://schemas.microsoft.com/office/drawing/2014/main" id="{4BDFD292-BCE2-40AA-B225-166F6639E6FB}"/>
+                <a16:creationId xmlns:a16="http://schemas.microsoft.com/office/drawing/2014/main" id="{F873821C-B7F2-4B37-8507-28A18830C7A6}"/>
               </a:ext>
             </a:extLst>
           </p:cNvPr>
@@ -5463,7 +5463,7 @@
           <p:cNvPr id="6" name="">
             <a:extLst xmlns:a="http://schemas.openxmlformats.org/drawingml/2006/main">
               <a:ext uri="{FF2B5EF4-FFF2-40B4-BE49-F238E27FC236}">
-                <a16:creationId xmlns:a16="http://schemas.microsoft.com/office/drawing/2014/main" id="{BCE3AF90-F9DA-49C6-9EAF-ABC6C4BE95C8}"/>
+                <a16:creationId xmlns:a16="http://schemas.microsoft.com/office/drawing/2014/main" id="{D54AC521-822D-4329-A326-F9A6D324E6F5}"/>
               </a:ext>
             </a:extLst>
           </p:cNvPr>
@@ -5527,7 +5527,7 @@
           <p:cNvPr id="7" name="">
             <a:extLst xmlns:a="http://schemas.openxmlformats.org/drawingml/2006/main">
               <a:ext uri="{FF2B5EF4-FFF2-40B4-BE49-F238E27FC236}">
-                <a16:creationId xmlns:a16="http://schemas.microsoft.com/office/drawing/2014/main" id="{F906579C-85C5-4D89-99D2-85E8EFB237BF}"/>
+                <a16:creationId xmlns:a16="http://schemas.microsoft.com/office/drawing/2014/main" id="{3EF72A5C-B1AD-414E-972A-53C046A9250E}"/>
               </a:ext>
             </a:extLst>
           </p:cNvPr>
@@ -5560,7 +5560,7 @@
           <p:cNvPr id="8" name="">
             <a:extLst xmlns:a="http://schemas.openxmlformats.org/drawingml/2006/main">
               <a:ext uri="{FF2B5EF4-FFF2-40B4-BE49-F238E27FC236}">
-                <a16:creationId xmlns:a16="http://schemas.microsoft.com/office/drawing/2014/main" id="{274ED6E2-2949-4C79-BB7C-3D0B6B3F1FCC}"/>
+                <a16:creationId xmlns:a16="http://schemas.microsoft.com/office/drawing/2014/main" id="{A7ECC21B-68C7-4E0A-9AFB-4564D28A035A}"/>
               </a:ext>
             </a:extLst>
           </p:cNvPr>
@@ -5593,7 +5593,7 @@
           <p:cNvPr id="9" name="">
             <a:extLst xmlns:a="http://schemas.openxmlformats.org/drawingml/2006/main">
               <a:ext uri="{FF2B5EF4-FFF2-40B4-BE49-F238E27FC236}">
-                <a16:creationId xmlns:a16="http://schemas.microsoft.com/office/drawing/2014/main" id="{AD093990-9EBB-4EAD-98AB-5465A43C7745}"/>
+                <a16:creationId xmlns:a16="http://schemas.microsoft.com/office/drawing/2014/main" id="{1B2F5246-115F-4EF1-A8BD-1211FAB7A8FA}"/>
               </a:ext>
             </a:extLst>
           </p:cNvPr>
@@ -5657,7 +5657,7 @@
           <p:cNvPr id="10" name="">
             <a:extLst xmlns:a="http://schemas.openxmlformats.org/drawingml/2006/main">
               <a:ext uri="{FF2B5EF4-FFF2-40B4-BE49-F238E27FC236}">
-                <a16:creationId xmlns:a16="http://schemas.microsoft.com/office/drawing/2014/main" id="{7F440B8E-D592-472F-A958-E990C4F48FEC}"/>
+                <a16:creationId xmlns:a16="http://schemas.microsoft.com/office/drawing/2014/main" id="{53FA9947-8BF9-41BC-B1E8-E5C5F60978CE}"/>
               </a:ext>
             </a:extLst>
           </p:cNvPr>
@@ -5721,7 +5721,7 @@
           <p:cNvPr id="11" name="">
             <a:extLst xmlns:a="http://schemas.openxmlformats.org/drawingml/2006/main">
               <a:ext uri="{FF2B5EF4-FFF2-40B4-BE49-F238E27FC236}">
-                <a16:creationId xmlns:a16="http://schemas.microsoft.com/office/drawing/2014/main" id="{B393A5EE-7B3D-49A5-9171-A145C1E865F1}"/>
+                <a16:creationId xmlns:a16="http://schemas.microsoft.com/office/drawing/2014/main" id="{3F385631-2077-4DB2-99A7-95E01C8DF653}"/>
               </a:ext>
             </a:extLst>
           </p:cNvPr>
@@ -5775,7 +5775,7 @@
                 <a:ea typeface="Arial"/>
                 <a:cs typeface="Arial"/>
               </a:rPr>
-              <a:t>tags_read enviado pelo comunicador ou por dispositivo com rede.</a:t>
+              <a:t>tags_read enviado pelo comunicador ou por dispositivo conectado à rede.</a:t>
             </a:r>
           </a:p>
         </p:txBody>
@@ -5785,7 +5785,7 @@
           <p:cNvPr id="12" name="">
             <a:extLst xmlns:a="http://schemas.openxmlformats.org/drawingml/2006/main">
               <a:ext uri="{FF2B5EF4-FFF2-40B4-BE49-F238E27FC236}">
-                <a16:creationId xmlns:a16="http://schemas.microsoft.com/office/drawing/2014/main" id="{CA666687-AE34-4A03-89E4-3C3A4A50AF89}"/>
+                <a16:creationId xmlns:a16="http://schemas.microsoft.com/office/drawing/2014/main" id="{9AE9968D-5B91-4E70-89E4-5AA6723CF1E9}"/>
               </a:ext>
             </a:extLst>
           </p:cNvPr>
@@ -5818,7 +5818,7 @@
           <p:cNvPr id="13" name="">
             <a:extLst xmlns:a="http://schemas.openxmlformats.org/drawingml/2006/main">
               <a:ext uri="{FF2B5EF4-FFF2-40B4-BE49-F238E27FC236}">
-                <a16:creationId xmlns:a16="http://schemas.microsoft.com/office/drawing/2014/main" id="{CA257EE4-B260-416B-838A-01CC8D8102D4}"/>
+                <a16:creationId xmlns:a16="http://schemas.microsoft.com/office/drawing/2014/main" id="{6FA2A035-CC89-496A-B5B4-FB0B018CBDB2}"/>
               </a:ext>
             </a:extLst>
           </p:cNvPr>
@@ -5851,7 +5851,7 @@
           <p:cNvPr id="14" name="">
             <a:extLst xmlns:a="http://schemas.openxmlformats.org/drawingml/2006/main">
               <a:ext uri="{FF2B5EF4-FFF2-40B4-BE49-F238E27FC236}">
-                <a16:creationId xmlns:a16="http://schemas.microsoft.com/office/drawing/2014/main" id="{83E79EEE-06A1-4E94-87F8-81F39B194E51}"/>
+                <a16:creationId xmlns:a16="http://schemas.microsoft.com/office/drawing/2014/main" id="{88174E2A-765F-4207-A824-D4B510BF3BDE}"/>
               </a:ext>
             </a:extLst>
           </p:cNvPr>
@@ -5915,7 +5915,7 @@
           <p:cNvPr id="15" name="">
             <a:extLst xmlns:a="http://schemas.openxmlformats.org/drawingml/2006/main">
               <a:ext uri="{FF2B5EF4-FFF2-40B4-BE49-F238E27FC236}">
-                <a16:creationId xmlns:a16="http://schemas.microsoft.com/office/drawing/2014/main" id="{230476DF-59D1-4665-A483-4F01D5149D79}"/>
+                <a16:creationId xmlns:a16="http://schemas.microsoft.com/office/drawing/2014/main" id="{A75D0BE1-A8E9-41F1-9FA1-C4ADB9CD2461}"/>
               </a:ext>
             </a:extLst>
           </p:cNvPr>
@@ -5979,7 +5979,7 @@
           <p:cNvPr id="16" name="">
             <a:extLst xmlns:a="http://schemas.openxmlformats.org/drawingml/2006/main">
               <a:ext uri="{FF2B5EF4-FFF2-40B4-BE49-F238E27FC236}">
-                <a16:creationId xmlns:a16="http://schemas.microsoft.com/office/drawing/2014/main" id="{7EC51782-0EC7-4580-B92F-015E615A7957}"/>
+                <a16:creationId xmlns:a16="http://schemas.microsoft.com/office/drawing/2014/main" id="{C881D794-F168-4D7B-A0BF-F65E61EBB3DD}"/>
               </a:ext>
             </a:extLst>
           </p:cNvPr>
@@ -6043,7 +6043,7 @@
           <p:cNvPr id="17" name="">
             <a:extLst xmlns:a="http://schemas.openxmlformats.org/drawingml/2006/main">
               <a:ext uri="{FF2B5EF4-FFF2-40B4-BE49-F238E27FC236}">
-                <a16:creationId xmlns:a16="http://schemas.microsoft.com/office/drawing/2014/main" id="{C3C23BFB-6958-45B8-8375-8D89D07DF2BC}"/>
+                <a16:creationId xmlns:a16="http://schemas.microsoft.com/office/drawing/2014/main" id="{4252BCFF-E0ED-484B-B439-0DB9C5238AA8}"/>
               </a:ext>
             </a:extLst>
           </p:cNvPr>
@@ -6076,7 +6076,7 @@
           <p:cNvPr id="18" name="">
             <a:extLst xmlns:a="http://schemas.openxmlformats.org/drawingml/2006/main">
               <a:ext uri="{FF2B5EF4-FFF2-40B4-BE49-F238E27FC236}">
-                <a16:creationId xmlns:a16="http://schemas.microsoft.com/office/drawing/2014/main" id="{965D2C83-691D-468E-AB31-3EA9D4AB06F2}"/>
+                <a16:creationId xmlns:a16="http://schemas.microsoft.com/office/drawing/2014/main" id="{CE432C8E-B1A2-442B-8FF5-C77719373747}"/>
               </a:ext>
             </a:extLst>
           </p:cNvPr>
@@ -6109,7 +6109,7 @@
           <p:cNvPr id="19" name="">
             <a:extLst xmlns:a="http://schemas.openxmlformats.org/drawingml/2006/main">
               <a:ext uri="{FF2B5EF4-FFF2-40B4-BE49-F238E27FC236}">
-                <a16:creationId xmlns:a16="http://schemas.microsoft.com/office/drawing/2014/main" id="{EF351969-DA93-40F9-955E-5D5154A8DF84}"/>
+                <a16:creationId xmlns:a16="http://schemas.microsoft.com/office/drawing/2014/main" id="{89AEEF2E-6143-4577-8A15-DC16F1C4A54E}"/>
               </a:ext>
             </a:extLst>
           </p:cNvPr>
@@ -6173,7 +6173,7 @@
           <p:cNvPr id="20" name="">
             <a:extLst xmlns:a="http://schemas.openxmlformats.org/drawingml/2006/main">
               <a:ext uri="{FF2B5EF4-FFF2-40B4-BE49-F238E27FC236}">
-                <a16:creationId xmlns:a16="http://schemas.microsoft.com/office/drawing/2014/main" id="{97D88408-643E-4EA7-AD21-F17AA3E40E7A}"/>
+                <a16:creationId xmlns:a16="http://schemas.microsoft.com/office/drawing/2014/main" id="{78261F19-7179-45E4-BDFF-737410EFAB74}"/>
               </a:ext>
             </a:extLst>
           </p:cNvPr>
@@ -6237,7 +6237,7 @@
           <p:cNvPr id="21" name="">
             <a:extLst xmlns:a="http://schemas.openxmlformats.org/drawingml/2006/main">
               <a:ext uri="{FF2B5EF4-FFF2-40B4-BE49-F238E27FC236}">
-                <a16:creationId xmlns:a16="http://schemas.microsoft.com/office/drawing/2014/main" id="{306D91F4-94EA-4BEC-9E22-F2245A23AF69}"/>
+                <a16:creationId xmlns:a16="http://schemas.microsoft.com/office/drawing/2014/main" id="{936A5E55-3952-4918-9411-3D024F920C75}"/>
               </a:ext>
             </a:extLst>
           </p:cNvPr>
@@ -6299,7 +6299,7 @@
     </p:spTree>
     <p:extLst>
       <p:ext uri="{BB962C8B-B14F-4D97-AF65-F5344CB8AC3E}">
-        <p14:creationId xmlns:p14="http://schemas.microsoft.com/office/powerpoint/2010/main" val="1487319244"/>
+        <p14:creationId xmlns:p14="http://schemas.microsoft.com/office/powerpoint/2010/main" val="341238139"/>
       </p:ext>
     </p:extLst>
   </p:cSld>
@@ -6323,7 +6323,7 @@
           <p:cNvPr id="1" name="">
             <a:extLst xmlns:a="http://schemas.openxmlformats.org/drawingml/2006/main">
               <a:ext uri="{FF2B5EF4-FFF2-40B4-BE49-F238E27FC236}">
-                <a16:creationId xmlns:a16="http://schemas.microsoft.com/office/drawing/2014/main" id="{F59183EC-0B08-4047-876C-BDE32F4FDB50}"/>
+                <a16:creationId xmlns:a16="http://schemas.microsoft.com/office/drawing/2014/main" id="{3B0DB5BA-648A-4D77-B150-4D5E9E578E44}"/>
               </a:ext>
             </a:extLst>
           </p:cNvPr>
@@ -6358,7 +6358,7 @@
           <p:cNvPr id="2" name="">
             <a:extLst xmlns:a="http://schemas.openxmlformats.org/drawingml/2006/main">
               <a:ext uri="{FF2B5EF4-FFF2-40B4-BE49-F238E27FC236}">
-                <a16:creationId xmlns:a16="http://schemas.microsoft.com/office/drawing/2014/main" id="{33C90837-77BC-4B13-9288-B9DACDC2124D}"/>
+                <a16:creationId xmlns:a16="http://schemas.microsoft.com/office/drawing/2014/main" id="{CDB9693F-77D8-4629-A1D3-354F9BD4BB5E}"/>
               </a:ext>
             </a:extLst>
           </p:cNvPr>
@@ -6393,7 +6393,7 @@
           <p:cNvPr id="3" name="">
             <a:extLst xmlns:a="http://schemas.openxmlformats.org/drawingml/2006/main">
               <a:ext uri="{FF2B5EF4-FFF2-40B4-BE49-F238E27FC236}">
-                <a16:creationId xmlns:a16="http://schemas.microsoft.com/office/drawing/2014/main" id="{05064874-6D1F-4E45-8CAE-940A2B610A3F}"/>
+                <a16:creationId xmlns:a16="http://schemas.microsoft.com/office/drawing/2014/main" id="{016815E9-CD33-4CA2-9394-97B7F8AA5902}"/>
               </a:ext>
             </a:extLst>
           </p:cNvPr>
@@ -6428,7 +6428,7 @@
           <p:cNvPr id="4" name="kicker-13-label">
             <a:extLst xmlns:a="http://schemas.openxmlformats.org/drawingml/2006/main">
               <a:ext uri="{FF2B5EF4-FFF2-40B4-BE49-F238E27FC236}">
-                <a16:creationId xmlns:a16="http://schemas.microsoft.com/office/drawing/2014/main" id="{F8A7A11E-43CF-4D10-BB9D-D51C99963850}"/>
+                <a16:creationId xmlns:a16="http://schemas.microsoft.com/office/drawing/2014/main" id="{6278A94F-1903-4A70-90F4-23E30ED0D32F}"/>
               </a:ext>
             </a:extLst>
           </p:cNvPr>
@@ -6492,7 +6492,7 @@
           <p:cNvPr id="5" name="">
             <a:extLst xmlns:a="http://schemas.openxmlformats.org/drawingml/2006/main">
               <a:ext uri="{FF2B5EF4-FFF2-40B4-BE49-F238E27FC236}">
-                <a16:creationId xmlns:a16="http://schemas.microsoft.com/office/drawing/2014/main" id="{11E9F2E2-734D-4275-90F0-6009F0C89D50}"/>
+                <a16:creationId xmlns:a16="http://schemas.microsoft.com/office/drawing/2014/main" id="{C3C4A1D5-2ED9-4889-96CF-F0E3A8A4BFBC}"/>
               </a:ext>
             </a:extLst>
           </p:cNvPr>
@@ -6556,7 +6556,7 @@
           <p:cNvPr id="6" name="">
             <a:extLst xmlns:a="http://schemas.openxmlformats.org/drawingml/2006/main">
               <a:ext uri="{FF2B5EF4-FFF2-40B4-BE49-F238E27FC236}">
-                <a16:creationId xmlns:a16="http://schemas.microsoft.com/office/drawing/2014/main" id="{C637117E-A594-46AA-AE4A-07E96F3ED656}"/>
+                <a16:creationId xmlns:a16="http://schemas.microsoft.com/office/drawing/2014/main" id="{08449CE0-1B47-4544-8363-7156E9A472BA}"/>
               </a:ext>
             </a:extLst>
           </p:cNvPr>
@@ -6620,7 +6620,7 @@
           <p:cNvPr id="7" name="">
             <a:extLst xmlns:a="http://schemas.openxmlformats.org/drawingml/2006/main">
               <a:ext uri="{FF2B5EF4-FFF2-40B4-BE49-F238E27FC236}">
-                <a16:creationId xmlns:a16="http://schemas.microsoft.com/office/drawing/2014/main" id="{CB58F05A-471C-489B-8A8D-4737A28EC812}"/>
+                <a16:creationId xmlns:a16="http://schemas.microsoft.com/office/drawing/2014/main" id="{81608831-8938-4C2C-B38A-BD140FEAAD80}"/>
               </a:ext>
             </a:extLst>
           </p:cNvPr>
@@ -6657,7 +6657,7 @@
           <p:nvPr/>
         </p:nvPicPr>
         <p:blipFill>
-          <a:blip xmlns:r="http://schemas.openxmlformats.org/officeDocument/2006/relationships" xmlns:a="http://schemas.openxmlformats.org/drawingml/2006/main" r:embed="Rf7cef116931349dd"/>
+          <a:blip xmlns:r="http://schemas.openxmlformats.org/officeDocument/2006/relationships" xmlns:a="http://schemas.openxmlformats.org/drawingml/2006/main" r:embed="R139495e2785e4183"/>
           <a:stretch xmlns:a="http://schemas.openxmlformats.org/drawingml/2006/main"/>
         </p:blipFill>
         <p:spPr>
@@ -6675,7 +6675,7 @@
           <p:cNvPr id="9" name="">
             <a:extLst xmlns:a="http://schemas.openxmlformats.org/drawingml/2006/main">
               <a:ext uri="{FF2B5EF4-FFF2-40B4-BE49-F238E27FC236}">
-                <a16:creationId xmlns:a16="http://schemas.microsoft.com/office/drawing/2014/main" id="{3D5BC9DD-0238-4512-92A5-9A623D01AE87}"/>
+                <a16:creationId xmlns:a16="http://schemas.microsoft.com/office/drawing/2014/main" id="{544553A0-0C40-4C25-98B2-72BE86241324}"/>
               </a:ext>
             </a:extLst>
           </p:cNvPr>
@@ -6737,7 +6737,7 @@
     </p:spTree>
     <p:extLst>
       <p:ext uri="{BB962C8B-B14F-4D97-AF65-F5344CB8AC3E}">
-        <p14:creationId xmlns:p14="http://schemas.microsoft.com/office/powerpoint/2010/main" val="1836739828"/>
+        <p14:creationId xmlns:p14="http://schemas.microsoft.com/office/powerpoint/2010/main" val="1680946120"/>
       </p:ext>
     </p:extLst>
   </p:cSld>
@@ -6761,7 +6761,7 @@
           <p:cNvPr id="1" name="">
             <a:extLst xmlns:a="http://schemas.openxmlformats.org/drawingml/2006/main">
               <a:ext uri="{FF2B5EF4-FFF2-40B4-BE49-F238E27FC236}">
-                <a16:creationId xmlns:a16="http://schemas.microsoft.com/office/drawing/2014/main" id="{D8FBD14E-3DE6-43E0-B19B-3921E4C6AFA6}"/>
+                <a16:creationId xmlns:a16="http://schemas.microsoft.com/office/drawing/2014/main" id="{2EF0BA2D-5688-445A-845E-29129AB583CF}"/>
               </a:ext>
             </a:extLst>
           </p:cNvPr>
@@ -6796,7 +6796,7 @@
           <p:cNvPr id="2" name="">
             <a:extLst xmlns:a="http://schemas.openxmlformats.org/drawingml/2006/main">
               <a:ext uri="{FF2B5EF4-FFF2-40B4-BE49-F238E27FC236}">
-                <a16:creationId xmlns:a16="http://schemas.microsoft.com/office/drawing/2014/main" id="{F8AA70B8-2C49-42EC-A309-B9FF760817C3}"/>
+                <a16:creationId xmlns:a16="http://schemas.microsoft.com/office/drawing/2014/main" id="{5A0F9E65-62AA-4E72-B9C4-71351F5BCF4F}"/>
               </a:ext>
             </a:extLst>
           </p:cNvPr>
@@ -6831,7 +6831,7 @@
           <p:cNvPr id="3" name="">
             <a:extLst xmlns:a="http://schemas.openxmlformats.org/drawingml/2006/main">
               <a:ext uri="{FF2B5EF4-FFF2-40B4-BE49-F238E27FC236}">
-                <a16:creationId xmlns:a16="http://schemas.microsoft.com/office/drawing/2014/main" id="{83ED56D5-2778-44F9-B113-75F70039AA01}"/>
+                <a16:creationId xmlns:a16="http://schemas.microsoft.com/office/drawing/2014/main" id="{CDB4AE69-0DD2-4218-B831-4FD737DD5334}"/>
               </a:ext>
             </a:extLst>
           </p:cNvPr>
@@ -6866,7 +6866,7 @@
           <p:cNvPr id="4" name="kicker-14-label">
             <a:extLst xmlns:a="http://schemas.openxmlformats.org/drawingml/2006/main">
               <a:ext uri="{FF2B5EF4-FFF2-40B4-BE49-F238E27FC236}">
-                <a16:creationId xmlns:a16="http://schemas.microsoft.com/office/drawing/2014/main" id="{385794FC-D7A6-41ED-BEBC-04CA91AAAF4A}"/>
+                <a16:creationId xmlns:a16="http://schemas.microsoft.com/office/drawing/2014/main" id="{6EB50B20-642E-4B24-8391-AD5AE55EF40A}"/>
               </a:ext>
             </a:extLst>
           </p:cNvPr>
@@ -6930,7 +6930,7 @@
           <p:cNvPr id="5" name="">
             <a:extLst xmlns:a="http://schemas.openxmlformats.org/drawingml/2006/main">
               <a:ext uri="{FF2B5EF4-FFF2-40B4-BE49-F238E27FC236}">
-                <a16:creationId xmlns:a16="http://schemas.microsoft.com/office/drawing/2014/main" id="{6FF1EC9A-0AB5-41AB-A2FE-854058F0B90F}"/>
+                <a16:creationId xmlns:a16="http://schemas.microsoft.com/office/drawing/2014/main" id="{011E8726-C7B7-4384-8AE7-AF56CA2F6DA8}"/>
               </a:ext>
             </a:extLst>
           </p:cNvPr>
@@ -6994,7 +6994,7 @@
           <p:cNvPr id="6" name="">
             <a:extLst xmlns:a="http://schemas.openxmlformats.org/drawingml/2006/main">
               <a:ext uri="{FF2B5EF4-FFF2-40B4-BE49-F238E27FC236}">
-                <a16:creationId xmlns:a16="http://schemas.microsoft.com/office/drawing/2014/main" id="{B2FCF761-63F9-495B-A9CC-EB1B12D6CF51}"/>
+                <a16:creationId xmlns:a16="http://schemas.microsoft.com/office/drawing/2014/main" id="{5FFEACC4-5D5D-400D-8FBB-5CB1F69EE52F}"/>
               </a:ext>
             </a:extLst>
           </p:cNvPr>
@@ -7058,7 +7058,7 @@
           <p:cNvPr id="7" name="">
             <a:extLst xmlns:a="http://schemas.openxmlformats.org/drawingml/2006/main">
               <a:ext uri="{FF2B5EF4-FFF2-40B4-BE49-F238E27FC236}">
-                <a16:creationId xmlns:a16="http://schemas.microsoft.com/office/drawing/2014/main" id="{72687236-C59E-4E23-BE9F-D127F1F7751B}"/>
+                <a16:creationId xmlns:a16="http://schemas.microsoft.com/office/drawing/2014/main" id="{E10AFEB0-526C-49B7-8069-E469727A6483}"/>
               </a:ext>
             </a:extLst>
           </p:cNvPr>
@@ -7095,7 +7095,7 @@
           <p:nvPr/>
         </p:nvPicPr>
         <p:blipFill>
-          <a:blip xmlns:r="http://schemas.openxmlformats.org/officeDocument/2006/relationships" xmlns:a="http://schemas.openxmlformats.org/drawingml/2006/main" r:embed="Rd4c3abe552da4233"/>
+          <a:blip xmlns:r="http://schemas.openxmlformats.org/officeDocument/2006/relationships" xmlns:a="http://schemas.openxmlformats.org/drawingml/2006/main" r:embed="R49dd17c8574144f8"/>
           <a:stretch xmlns:a="http://schemas.openxmlformats.org/drawingml/2006/main"/>
         </p:blipFill>
         <p:spPr>
@@ -7113,7 +7113,7 @@
           <p:cNvPr id="9" name="">
             <a:extLst xmlns:a="http://schemas.openxmlformats.org/drawingml/2006/main">
               <a:ext uri="{FF2B5EF4-FFF2-40B4-BE49-F238E27FC236}">
-                <a16:creationId xmlns:a16="http://schemas.microsoft.com/office/drawing/2014/main" id="{4190A777-0566-4F80-B3C3-DC9B1DC4EEF7}"/>
+                <a16:creationId xmlns:a16="http://schemas.microsoft.com/office/drawing/2014/main" id="{E2AA5352-41FF-4622-A6C3-BA1736F92197}"/>
               </a:ext>
             </a:extLst>
           </p:cNvPr>
@@ -7175,7 +7175,7 @@
     </p:spTree>
     <p:extLst>
       <p:ext uri="{BB962C8B-B14F-4D97-AF65-F5344CB8AC3E}">
-        <p14:creationId xmlns:p14="http://schemas.microsoft.com/office/powerpoint/2010/main" val="1945408907"/>
+        <p14:creationId xmlns:p14="http://schemas.microsoft.com/office/powerpoint/2010/main" val="228050171"/>
       </p:ext>
     </p:extLst>
   </p:cSld>
@@ -7199,7 +7199,7 @@
           <p:cNvPr id="1" name="">
             <a:extLst xmlns:a="http://schemas.openxmlformats.org/drawingml/2006/main">
               <a:ext uri="{FF2B5EF4-FFF2-40B4-BE49-F238E27FC236}">
-                <a16:creationId xmlns:a16="http://schemas.microsoft.com/office/drawing/2014/main" id="{6D612ADE-3EE6-456B-AC7F-29ADB38C7B37}"/>
+                <a16:creationId xmlns:a16="http://schemas.microsoft.com/office/drawing/2014/main" id="{3F9C647F-763A-4DA7-82A5-704D39BCCCA3}"/>
               </a:ext>
             </a:extLst>
           </p:cNvPr>
@@ -7234,7 +7234,7 @@
           <p:cNvPr id="2" name="">
             <a:extLst xmlns:a="http://schemas.openxmlformats.org/drawingml/2006/main">
               <a:ext uri="{FF2B5EF4-FFF2-40B4-BE49-F238E27FC236}">
-                <a16:creationId xmlns:a16="http://schemas.microsoft.com/office/drawing/2014/main" id="{2B13894D-634B-4D76-AEDE-F7A7C0727330}"/>
+                <a16:creationId xmlns:a16="http://schemas.microsoft.com/office/drawing/2014/main" id="{910D881D-763B-4C15-8058-17C7B9DACE2B}"/>
               </a:ext>
             </a:extLst>
           </p:cNvPr>
@@ -7269,7 +7269,7 @@
           <p:cNvPr id="3" name="">
             <a:extLst xmlns:a="http://schemas.openxmlformats.org/drawingml/2006/main">
               <a:ext uri="{FF2B5EF4-FFF2-40B4-BE49-F238E27FC236}">
-                <a16:creationId xmlns:a16="http://schemas.microsoft.com/office/drawing/2014/main" id="{DA6C5524-E9ED-4E94-BA1D-1B1659615979}"/>
+                <a16:creationId xmlns:a16="http://schemas.microsoft.com/office/drawing/2014/main" id="{E1887B9C-CEDB-46A9-94F4-B9169474B394}"/>
               </a:ext>
             </a:extLst>
           </p:cNvPr>
@@ -7304,7 +7304,7 @@
           <p:cNvPr id="4" name="kicker-15-label">
             <a:extLst xmlns:a="http://schemas.openxmlformats.org/drawingml/2006/main">
               <a:ext uri="{FF2B5EF4-FFF2-40B4-BE49-F238E27FC236}">
-                <a16:creationId xmlns:a16="http://schemas.microsoft.com/office/drawing/2014/main" id="{F49D7BA0-A7D8-499A-BD46-B41E8AA87F91}"/>
+                <a16:creationId xmlns:a16="http://schemas.microsoft.com/office/drawing/2014/main" id="{C664B2FA-832C-4D98-92FC-3DE8666A71B2}"/>
               </a:ext>
             </a:extLst>
           </p:cNvPr>
@@ -7368,7 +7368,7 @@
           <p:cNvPr id="5" name="">
             <a:extLst xmlns:a="http://schemas.openxmlformats.org/drawingml/2006/main">
               <a:ext uri="{FF2B5EF4-FFF2-40B4-BE49-F238E27FC236}">
-                <a16:creationId xmlns:a16="http://schemas.microsoft.com/office/drawing/2014/main" id="{1211242D-72EB-4903-BB08-E9AF04DAFABF}"/>
+                <a16:creationId xmlns:a16="http://schemas.microsoft.com/office/drawing/2014/main" id="{5076B7A1-D549-4262-A168-1E3A5994B2F4}"/>
               </a:ext>
             </a:extLst>
           </p:cNvPr>
@@ -7432,7 +7432,7 @@
           <p:cNvPr id="6" name="">
             <a:extLst xmlns:a="http://schemas.openxmlformats.org/drawingml/2006/main">
               <a:ext uri="{FF2B5EF4-FFF2-40B4-BE49-F238E27FC236}">
-                <a16:creationId xmlns:a16="http://schemas.microsoft.com/office/drawing/2014/main" id="{A3ADDD78-6758-4489-B570-104810ED615A}"/>
+                <a16:creationId xmlns:a16="http://schemas.microsoft.com/office/drawing/2014/main" id="{650B008F-48CC-47D1-AC61-6A2A014F8434}"/>
               </a:ext>
             </a:extLst>
           </p:cNvPr>
@@ -7486,7 +7486,7 @@
                 <a:ea typeface="Arial"/>
                 <a:cs typeface="Arial"/>
               </a:rPr>
-              <a:t>Divergências deixam de ser anotações soltas e passam a ter acompanhamento.</a:t>
+              <a:t>Divergências deixam de ser registros avulsos e passam a ter acompanhamento.</a:t>
             </a:r>
           </a:p>
         </p:txBody>
@@ -7496,7 +7496,7 @@
           <p:cNvPr id="7" name="">
             <a:extLst xmlns:a="http://schemas.openxmlformats.org/drawingml/2006/main">
               <a:ext uri="{FF2B5EF4-FFF2-40B4-BE49-F238E27FC236}">
-                <a16:creationId xmlns:a16="http://schemas.microsoft.com/office/drawing/2014/main" id="{91714172-F7B7-4234-9D6F-1AD72A02923E}"/>
+                <a16:creationId xmlns:a16="http://schemas.microsoft.com/office/drawing/2014/main" id="{1303AB94-DE84-442A-87A7-E70611CE9461}"/>
               </a:ext>
             </a:extLst>
           </p:cNvPr>
@@ -7533,7 +7533,7 @@
           <p:nvPr/>
         </p:nvPicPr>
         <p:blipFill>
-          <a:blip xmlns:r="http://schemas.openxmlformats.org/officeDocument/2006/relationships" xmlns:a="http://schemas.openxmlformats.org/drawingml/2006/main" r:embed="R2117966b29104cfa"/>
+          <a:blip xmlns:r="http://schemas.openxmlformats.org/officeDocument/2006/relationships" xmlns:a="http://schemas.openxmlformats.org/drawingml/2006/main" r:embed="R18e75bbc12fe4a06"/>
           <a:stretch xmlns:a="http://schemas.openxmlformats.org/drawingml/2006/main"/>
         </p:blipFill>
         <p:spPr>
@@ -7551,7 +7551,7 @@
           <p:cNvPr id="9" name="">
             <a:extLst xmlns:a="http://schemas.openxmlformats.org/drawingml/2006/main">
               <a:ext uri="{FF2B5EF4-FFF2-40B4-BE49-F238E27FC236}">
-                <a16:creationId xmlns:a16="http://schemas.microsoft.com/office/drawing/2014/main" id="{45430145-5A6E-42D8-8B84-5E6271FCDED3}"/>
+                <a16:creationId xmlns:a16="http://schemas.microsoft.com/office/drawing/2014/main" id="{4C42C508-7570-4FD9-8C4E-D7BCA9260412}"/>
               </a:ext>
             </a:extLst>
           </p:cNvPr>
@@ -7613,7 +7613,7 @@
     </p:spTree>
     <p:extLst>
       <p:ext uri="{BB962C8B-B14F-4D97-AF65-F5344CB8AC3E}">
-        <p14:creationId xmlns:p14="http://schemas.microsoft.com/office/powerpoint/2010/main" val="28378174"/>
+        <p14:creationId xmlns:p14="http://schemas.microsoft.com/office/powerpoint/2010/main" val="228579272"/>
       </p:ext>
     </p:extLst>
   </p:cSld>
@@ -7637,7 +7637,7 @@
           <p:cNvPr id="1" name="">
             <a:extLst xmlns:a="http://schemas.openxmlformats.org/drawingml/2006/main">
               <a:ext uri="{FF2B5EF4-FFF2-40B4-BE49-F238E27FC236}">
-                <a16:creationId xmlns:a16="http://schemas.microsoft.com/office/drawing/2014/main" id="{2C11F806-D6E8-4AEE-A136-4718B06DAD9B}"/>
+                <a16:creationId xmlns:a16="http://schemas.microsoft.com/office/drawing/2014/main" id="{8309DF2B-D175-4E02-927D-C8D11F60B1CD}"/>
               </a:ext>
             </a:extLst>
           </p:cNvPr>
@@ -7672,7 +7672,7 @@
           <p:cNvPr id="2" name="">
             <a:extLst xmlns:a="http://schemas.openxmlformats.org/drawingml/2006/main">
               <a:ext uri="{FF2B5EF4-FFF2-40B4-BE49-F238E27FC236}">
-                <a16:creationId xmlns:a16="http://schemas.microsoft.com/office/drawing/2014/main" id="{20BF0FA2-7D30-402C-B86F-4F469ADABF2B}"/>
+                <a16:creationId xmlns:a16="http://schemas.microsoft.com/office/drawing/2014/main" id="{1A8975BD-10EE-4921-B16E-0295B90AE0CF}"/>
               </a:ext>
             </a:extLst>
           </p:cNvPr>
@@ -7707,7 +7707,7 @@
           <p:cNvPr id="3" name="">
             <a:extLst xmlns:a="http://schemas.openxmlformats.org/drawingml/2006/main">
               <a:ext uri="{FF2B5EF4-FFF2-40B4-BE49-F238E27FC236}">
-                <a16:creationId xmlns:a16="http://schemas.microsoft.com/office/drawing/2014/main" id="{A6830016-F883-4257-80FF-103BBEDBF1F0}"/>
+                <a16:creationId xmlns:a16="http://schemas.microsoft.com/office/drawing/2014/main" id="{5EC49DD5-88C1-46CC-8C01-D08A6D94A38D}"/>
               </a:ext>
             </a:extLst>
           </p:cNvPr>
@@ -7742,7 +7742,7 @@
           <p:cNvPr id="4" name="kicker-16-label">
             <a:extLst xmlns:a="http://schemas.openxmlformats.org/drawingml/2006/main">
               <a:ext uri="{FF2B5EF4-FFF2-40B4-BE49-F238E27FC236}">
-                <a16:creationId xmlns:a16="http://schemas.microsoft.com/office/drawing/2014/main" id="{49157E92-E497-4049-A2AE-89F0241E0C58}"/>
+                <a16:creationId xmlns:a16="http://schemas.microsoft.com/office/drawing/2014/main" id="{F26B368A-AA58-4AE4-95EE-5616E0A8DE10}"/>
               </a:ext>
             </a:extLst>
           </p:cNvPr>
@@ -7806,7 +7806,7 @@
           <p:cNvPr id="5" name="">
             <a:extLst xmlns:a="http://schemas.openxmlformats.org/drawingml/2006/main">
               <a:ext uri="{FF2B5EF4-FFF2-40B4-BE49-F238E27FC236}">
-                <a16:creationId xmlns:a16="http://schemas.microsoft.com/office/drawing/2014/main" id="{4D445E5E-18BD-4B27-BC88-8941D0252DBF}"/>
+                <a16:creationId xmlns:a16="http://schemas.microsoft.com/office/drawing/2014/main" id="{2F9EFC27-510C-4A45-BFE7-9159D61C8723}"/>
               </a:ext>
             </a:extLst>
           </p:cNvPr>
@@ -7870,7 +7870,7 @@
           <p:cNvPr id="6" name="">
             <a:extLst xmlns:a="http://schemas.openxmlformats.org/drawingml/2006/main">
               <a:ext uri="{FF2B5EF4-FFF2-40B4-BE49-F238E27FC236}">
-                <a16:creationId xmlns:a16="http://schemas.microsoft.com/office/drawing/2014/main" id="{7714F0C6-5848-44BD-A8CD-DCB4793A5B07}"/>
+                <a16:creationId xmlns:a16="http://schemas.microsoft.com/office/drawing/2014/main" id="{186938E4-3DFF-49BE-B3D1-41F82794BD63}"/>
               </a:ext>
             </a:extLst>
           </p:cNvPr>
@@ -7934,7 +7934,7 @@
           <p:cNvPr id="7" name="">
             <a:extLst xmlns:a="http://schemas.openxmlformats.org/drawingml/2006/main">
               <a:ext uri="{FF2B5EF4-FFF2-40B4-BE49-F238E27FC236}">
-                <a16:creationId xmlns:a16="http://schemas.microsoft.com/office/drawing/2014/main" id="{793617D2-88C4-4340-943F-9DCEB2B6C478}"/>
+                <a16:creationId xmlns:a16="http://schemas.microsoft.com/office/drawing/2014/main" id="{6CE776D5-9BC5-4CAE-B153-31248C5593E7}"/>
               </a:ext>
             </a:extLst>
           </p:cNvPr>
@@ -7969,7 +7969,7 @@
           <p:cNvPr id="8" name="">
             <a:extLst xmlns:a="http://schemas.openxmlformats.org/drawingml/2006/main">
               <a:ext uri="{FF2B5EF4-FFF2-40B4-BE49-F238E27FC236}">
-                <a16:creationId xmlns:a16="http://schemas.microsoft.com/office/drawing/2014/main" id="{D6B852C4-786E-4C3A-883C-02BF032DC966}"/>
+                <a16:creationId xmlns:a16="http://schemas.microsoft.com/office/drawing/2014/main" id="{8BD06CEE-DA48-4D9C-8750-405F49894FA8}"/>
               </a:ext>
             </a:extLst>
           </p:cNvPr>
@@ -8033,7 +8033,7 @@
           <p:cNvPr id="9" name="">
             <a:extLst xmlns:a="http://schemas.openxmlformats.org/drawingml/2006/main">
               <a:ext uri="{FF2B5EF4-FFF2-40B4-BE49-F238E27FC236}">
-                <a16:creationId xmlns:a16="http://schemas.microsoft.com/office/drawing/2014/main" id="{DADACFE2-0BEF-483E-B1FD-1C63309AFF50}"/>
+                <a16:creationId xmlns:a16="http://schemas.microsoft.com/office/drawing/2014/main" id="{DC597304-D156-4894-86D4-69A1EC279876}"/>
               </a:ext>
             </a:extLst>
           </p:cNvPr>
@@ -8068,7 +8068,7 @@
           <p:cNvPr id="10" name="">
             <a:extLst xmlns:a="http://schemas.openxmlformats.org/drawingml/2006/main">
               <a:ext uri="{FF2B5EF4-FFF2-40B4-BE49-F238E27FC236}">
-                <a16:creationId xmlns:a16="http://schemas.microsoft.com/office/drawing/2014/main" id="{B9833211-DCD1-4834-8D87-86A68D59651F}"/>
+                <a16:creationId xmlns:a16="http://schemas.microsoft.com/office/drawing/2014/main" id="{3807F017-5557-482F-AAB4-8B40FDC3EE36}"/>
               </a:ext>
             </a:extLst>
           </p:cNvPr>
@@ -8132,7 +8132,7 @@
           <p:cNvPr id="11" name="">
             <a:extLst xmlns:a="http://schemas.openxmlformats.org/drawingml/2006/main">
               <a:ext uri="{FF2B5EF4-FFF2-40B4-BE49-F238E27FC236}">
-                <a16:creationId xmlns:a16="http://schemas.microsoft.com/office/drawing/2014/main" id="{751275FE-4848-456D-84A1-E4E2606521BE}"/>
+                <a16:creationId xmlns:a16="http://schemas.microsoft.com/office/drawing/2014/main" id="{721171DE-304B-41A7-878A-54751B357B6C}"/>
               </a:ext>
             </a:extLst>
           </p:cNvPr>
@@ -8167,7 +8167,7 @@
           <p:cNvPr id="12" name="">
             <a:extLst xmlns:a="http://schemas.openxmlformats.org/drawingml/2006/main">
               <a:ext uri="{FF2B5EF4-FFF2-40B4-BE49-F238E27FC236}">
-                <a16:creationId xmlns:a16="http://schemas.microsoft.com/office/drawing/2014/main" id="{D85EBDFD-B455-408E-8C83-297323B071B9}"/>
+                <a16:creationId xmlns:a16="http://schemas.microsoft.com/office/drawing/2014/main" id="{BD53EBFB-B619-4E6D-B42A-EF98A1D1B1E4}"/>
               </a:ext>
             </a:extLst>
           </p:cNvPr>
@@ -8231,7 +8231,7 @@
           <p:cNvPr id="13" name="">
             <a:extLst xmlns:a="http://schemas.openxmlformats.org/drawingml/2006/main">
               <a:ext uri="{FF2B5EF4-FFF2-40B4-BE49-F238E27FC236}">
-                <a16:creationId xmlns:a16="http://schemas.microsoft.com/office/drawing/2014/main" id="{D28F1886-3F5C-45CA-A689-78809A975F67}"/>
+                <a16:creationId xmlns:a16="http://schemas.microsoft.com/office/drawing/2014/main" id="{990280A3-8CC7-4F92-B7DC-9A3C27240A6A}"/>
               </a:ext>
             </a:extLst>
           </p:cNvPr>
@@ -8264,7 +8264,7 @@
           <p:cNvPr id="14" name="">
             <a:extLst xmlns:a="http://schemas.openxmlformats.org/drawingml/2006/main">
               <a:ext uri="{FF2B5EF4-FFF2-40B4-BE49-F238E27FC236}">
-                <a16:creationId xmlns:a16="http://schemas.microsoft.com/office/drawing/2014/main" id="{E13FDB10-9664-4B4F-A7BE-491515FCEE83}"/>
+                <a16:creationId xmlns:a16="http://schemas.microsoft.com/office/drawing/2014/main" id="{65913B18-5F93-4A25-B48B-00550B31F7F7}"/>
               </a:ext>
             </a:extLst>
           </p:cNvPr>
@@ -8328,7 +8328,7 @@
           <p:cNvPr id="15" name="">
             <a:extLst xmlns:a="http://schemas.openxmlformats.org/drawingml/2006/main">
               <a:ext uri="{FF2B5EF4-FFF2-40B4-BE49-F238E27FC236}">
-                <a16:creationId xmlns:a16="http://schemas.microsoft.com/office/drawing/2014/main" id="{870CA847-0119-48B1-90FC-084C4EAC571B}"/>
+                <a16:creationId xmlns:a16="http://schemas.microsoft.com/office/drawing/2014/main" id="{C69DFE6F-1762-46F9-8675-BFA91FE49473}"/>
               </a:ext>
             </a:extLst>
           </p:cNvPr>
@@ -8361,7 +8361,7 @@
           <p:cNvPr id="16" name="">
             <a:extLst xmlns:a="http://schemas.openxmlformats.org/drawingml/2006/main">
               <a:ext uri="{FF2B5EF4-FFF2-40B4-BE49-F238E27FC236}">
-                <a16:creationId xmlns:a16="http://schemas.microsoft.com/office/drawing/2014/main" id="{6D46F0E8-F93C-46BE-9A73-09BE0EA3BB8F}"/>
+                <a16:creationId xmlns:a16="http://schemas.microsoft.com/office/drawing/2014/main" id="{E4803207-8679-4256-BC5A-23A4EAB0F2CC}"/>
               </a:ext>
             </a:extLst>
           </p:cNvPr>
@@ -8425,7 +8425,7 @@
           <p:cNvPr id="17" name="">
             <a:extLst xmlns:a="http://schemas.openxmlformats.org/drawingml/2006/main">
               <a:ext uri="{FF2B5EF4-FFF2-40B4-BE49-F238E27FC236}">
-                <a16:creationId xmlns:a16="http://schemas.microsoft.com/office/drawing/2014/main" id="{4AF3B053-F694-4FFC-8892-44A2D2888DEF}"/>
+                <a16:creationId xmlns:a16="http://schemas.microsoft.com/office/drawing/2014/main" id="{862445F7-3B6B-4518-A297-9BA76AAD2F7E}"/>
               </a:ext>
             </a:extLst>
           </p:cNvPr>
@@ -8458,7 +8458,7 @@
           <p:cNvPr id="18" name="">
             <a:extLst xmlns:a="http://schemas.openxmlformats.org/drawingml/2006/main">
               <a:ext uri="{FF2B5EF4-FFF2-40B4-BE49-F238E27FC236}">
-                <a16:creationId xmlns:a16="http://schemas.microsoft.com/office/drawing/2014/main" id="{2656D515-E805-49A3-A6E7-947A89221D08}"/>
+                <a16:creationId xmlns:a16="http://schemas.microsoft.com/office/drawing/2014/main" id="{58E4DFFF-B1BD-46B7-B9F9-DFF716AE0E6F}"/>
               </a:ext>
             </a:extLst>
           </p:cNvPr>
@@ -8512,7 +8512,7 @@
                 <a:ea typeface="Arial"/>
                 <a:cs typeface="Arial"/>
               </a:rPr>
-              <a:t>item detectado e ausentes classificados</a:t>
+              <a:t>item detectado e itens ausentes classificados</a:t>
             </a:r>
           </a:p>
         </p:txBody>
@@ -8522,7 +8522,7 @@
           <p:cNvPr id="19" name="">
             <a:extLst xmlns:a="http://schemas.openxmlformats.org/drawingml/2006/main">
               <a:ext uri="{FF2B5EF4-FFF2-40B4-BE49-F238E27FC236}">
-                <a16:creationId xmlns:a16="http://schemas.microsoft.com/office/drawing/2014/main" id="{FEF3F5D3-62AB-44A0-8196-6FA11ED4421C}"/>
+                <a16:creationId xmlns:a16="http://schemas.microsoft.com/office/drawing/2014/main" id="{A5CB03F9-0566-4887-B729-56527F343112}"/>
               </a:ext>
             </a:extLst>
           </p:cNvPr>
@@ -8555,7 +8555,7 @@
           <p:cNvPr id="20" name="">
             <a:extLst xmlns:a="http://schemas.openxmlformats.org/drawingml/2006/main">
               <a:ext uri="{FF2B5EF4-FFF2-40B4-BE49-F238E27FC236}">
-                <a16:creationId xmlns:a16="http://schemas.microsoft.com/office/drawing/2014/main" id="{C64EC3D0-1594-46D0-A676-EDB6EE9E5137}"/>
+                <a16:creationId xmlns:a16="http://schemas.microsoft.com/office/drawing/2014/main" id="{ADD0D57C-B2E8-4C23-BD98-AC5ADD25ADCB}"/>
               </a:ext>
             </a:extLst>
           </p:cNvPr>
@@ -8619,7 +8619,7 @@
           <p:cNvPr id="21" name="">
             <a:extLst xmlns:a="http://schemas.openxmlformats.org/drawingml/2006/main">
               <a:ext uri="{FF2B5EF4-FFF2-40B4-BE49-F238E27FC236}">
-                <a16:creationId xmlns:a16="http://schemas.microsoft.com/office/drawing/2014/main" id="{FD9810A6-1730-42B7-9DFD-79DF266642AC}"/>
+                <a16:creationId xmlns:a16="http://schemas.microsoft.com/office/drawing/2014/main" id="{72344EFE-D87E-4226-9529-6CAC6562A4AF}"/>
               </a:ext>
             </a:extLst>
           </p:cNvPr>
@@ -8652,7 +8652,7 @@
           <p:cNvPr id="22" name="">
             <a:extLst xmlns:a="http://schemas.openxmlformats.org/drawingml/2006/main">
               <a:ext uri="{FF2B5EF4-FFF2-40B4-BE49-F238E27FC236}">
-                <a16:creationId xmlns:a16="http://schemas.microsoft.com/office/drawing/2014/main" id="{3DCE87E0-B3AA-4E97-8EBA-DE866E61494C}"/>
+                <a16:creationId xmlns:a16="http://schemas.microsoft.com/office/drawing/2014/main" id="{30027594-2C91-4390-8BA9-64328A9E1954}"/>
               </a:ext>
             </a:extLst>
           </p:cNvPr>
@@ -8716,7 +8716,7 @@
           <p:cNvPr id="23" name="">
             <a:extLst xmlns:a="http://schemas.openxmlformats.org/drawingml/2006/main">
               <a:ext uri="{FF2B5EF4-FFF2-40B4-BE49-F238E27FC236}">
-                <a16:creationId xmlns:a16="http://schemas.microsoft.com/office/drawing/2014/main" id="{36452FD2-9AC9-4F2E-84BE-EC0B46332C17}"/>
+                <a16:creationId xmlns:a16="http://schemas.microsoft.com/office/drawing/2014/main" id="{F216A744-3AA2-42A0-8B5F-B38FE456E10E}"/>
               </a:ext>
             </a:extLst>
           </p:cNvPr>
@@ -8749,7 +8749,7 @@
           <p:cNvPr id="24" name="">
             <a:extLst xmlns:a="http://schemas.openxmlformats.org/drawingml/2006/main">
               <a:ext uri="{FF2B5EF4-FFF2-40B4-BE49-F238E27FC236}">
-                <a16:creationId xmlns:a16="http://schemas.microsoft.com/office/drawing/2014/main" id="{78890526-45E5-4B65-9DBF-4EE7EAB3E060}"/>
+                <a16:creationId xmlns:a16="http://schemas.microsoft.com/office/drawing/2014/main" id="{3408B53C-F481-47E3-B128-91DA475D7A80}"/>
               </a:ext>
             </a:extLst>
           </p:cNvPr>
@@ -8813,7 +8813,7 @@
           <p:cNvPr id="25" name="">
             <a:extLst xmlns:a="http://schemas.openxmlformats.org/drawingml/2006/main">
               <a:ext uri="{FF2B5EF4-FFF2-40B4-BE49-F238E27FC236}">
-                <a16:creationId xmlns:a16="http://schemas.microsoft.com/office/drawing/2014/main" id="{0D5A4913-38BD-47A8-81F9-B4494C0E8264}"/>
+                <a16:creationId xmlns:a16="http://schemas.microsoft.com/office/drawing/2014/main" id="{43BEBED3-F176-4CF9-B61B-6542ADA655ED}"/>
               </a:ext>
             </a:extLst>
           </p:cNvPr>
@@ -8846,7 +8846,7 @@
           <p:cNvPr id="26" name="">
             <a:extLst xmlns:a="http://schemas.openxmlformats.org/drawingml/2006/main">
               <a:ext uri="{FF2B5EF4-FFF2-40B4-BE49-F238E27FC236}">
-                <a16:creationId xmlns:a16="http://schemas.microsoft.com/office/drawing/2014/main" id="{A8F280E1-F0EF-44B5-8098-2353DE3F743F}"/>
+                <a16:creationId xmlns:a16="http://schemas.microsoft.com/office/drawing/2014/main" id="{FCC1CBAE-02F7-4259-85B0-239F6B2B12E6}"/>
               </a:ext>
             </a:extLst>
           </p:cNvPr>
@@ -8910,7 +8910,7 @@
           <p:cNvPr id="27" name="">
             <a:extLst xmlns:a="http://schemas.openxmlformats.org/drawingml/2006/main">
               <a:ext uri="{FF2B5EF4-FFF2-40B4-BE49-F238E27FC236}">
-                <a16:creationId xmlns:a16="http://schemas.microsoft.com/office/drawing/2014/main" id="{74685DC4-3920-4B88-AF5B-31A19F7AF6E3}"/>
+                <a16:creationId xmlns:a16="http://schemas.microsoft.com/office/drawing/2014/main" id="{114F21FD-7520-434D-96BD-1602C36EF03C}"/>
               </a:ext>
             </a:extLst>
           </p:cNvPr>
@@ -8943,7 +8943,7 @@
           <p:cNvPr id="28" name="">
             <a:extLst xmlns:a="http://schemas.openxmlformats.org/drawingml/2006/main">
               <a:ext uri="{FF2B5EF4-FFF2-40B4-BE49-F238E27FC236}">
-                <a16:creationId xmlns:a16="http://schemas.microsoft.com/office/drawing/2014/main" id="{13B1B1B6-A17A-44DB-8CC9-E6E4FBD59F99}"/>
+                <a16:creationId xmlns:a16="http://schemas.microsoft.com/office/drawing/2014/main" id="{EA31F0F8-BE63-4638-BD56-0F7373EC0A2B}"/>
               </a:ext>
             </a:extLst>
           </p:cNvPr>
@@ -9007,7 +9007,7 @@
           <p:cNvPr id="29" name="">
             <a:extLst xmlns:a="http://schemas.openxmlformats.org/drawingml/2006/main">
               <a:ext uri="{FF2B5EF4-FFF2-40B4-BE49-F238E27FC236}">
-                <a16:creationId xmlns:a16="http://schemas.microsoft.com/office/drawing/2014/main" id="{80314F39-9B96-4E2B-A8EC-7FEB6921FC61}"/>
+                <a16:creationId xmlns:a16="http://schemas.microsoft.com/office/drawing/2014/main" id="{3A61A31D-62D9-4677-922F-E200B0BE2864}"/>
               </a:ext>
             </a:extLst>
           </p:cNvPr>
@@ -9040,7 +9040,7 @@
           <p:cNvPr id="30" name="">
             <a:extLst xmlns:a="http://schemas.openxmlformats.org/drawingml/2006/main">
               <a:ext uri="{FF2B5EF4-FFF2-40B4-BE49-F238E27FC236}">
-                <a16:creationId xmlns:a16="http://schemas.microsoft.com/office/drawing/2014/main" id="{A42B51D4-D0D1-44F1-A2BD-C3C61110F313}"/>
+                <a16:creationId xmlns:a16="http://schemas.microsoft.com/office/drawing/2014/main" id="{6387BA0F-C9DD-4E74-BD3F-8B8D02F9AA10}"/>
               </a:ext>
             </a:extLst>
           </p:cNvPr>
@@ -9104,7 +9104,7 @@
           <p:cNvPr id="31" name="">
             <a:extLst xmlns:a="http://schemas.openxmlformats.org/drawingml/2006/main">
               <a:ext uri="{FF2B5EF4-FFF2-40B4-BE49-F238E27FC236}">
-                <a16:creationId xmlns:a16="http://schemas.microsoft.com/office/drawing/2014/main" id="{12D1C2E0-76ED-48F6-8071-0635051BFB08}"/>
+                <a16:creationId xmlns:a16="http://schemas.microsoft.com/office/drawing/2014/main" id="{F3E3921F-481E-42E3-A9D5-A8ECA1E5B667}"/>
               </a:ext>
             </a:extLst>
           </p:cNvPr>
@@ -9137,7 +9137,7 @@
           <p:cNvPr id="32" name="">
             <a:extLst xmlns:a="http://schemas.openxmlformats.org/drawingml/2006/main">
               <a:ext uri="{FF2B5EF4-FFF2-40B4-BE49-F238E27FC236}">
-                <a16:creationId xmlns:a16="http://schemas.microsoft.com/office/drawing/2014/main" id="{511874E4-C9DF-49F8-AE71-6B50EE6C97ED}"/>
+                <a16:creationId xmlns:a16="http://schemas.microsoft.com/office/drawing/2014/main" id="{3C2C63AF-AFD9-40B9-A405-1626491AC54B}"/>
               </a:ext>
             </a:extLst>
           </p:cNvPr>
@@ -9201,7 +9201,7 @@
           <p:cNvPr id="33" name="">
             <a:extLst xmlns:a="http://schemas.openxmlformats.org/drawingml/2006/main">
               <a:ext uri="{FF2B5EF4-FFF2-40B4-BE49-F238E27FC236}">
-                <a16:creationId xmlns:a16="http://schemas.microsoft.com/office/drawing/2014/main" id="{E3046C45-6A38-4932-ACAC-C8A29912F9ED}"/>
+                <a16:creationId xmlns:a16="http://schemas.microsoft.com/office/drawing/2014/main" id="{110604F0-FA1F-46DD-ABBF-5997517C745C}"/>
               </a:ext>
             </a:extLst>
           </p:cNvPr>
@@ -9234,7 +9234,7 @@
           <p:cNvPr id="34" name="">
             <a:extLst xmlns:a="http://schemas.openxmlformats.org/drawingml/2006/main">
               <a:ext uri="{FF2B5EF4-FFF2-40B4-BE49-F238E27FC236}">
-                <a16:creationId xmlns:a16="http://schemas.microsoft.com/office/drawing/2014/main" id="{475E31B5-1F33-410B-9F75-DBBE8DE6AA4B}"/>
+                <a16:creationId xmlns:a16="http://schemas.microsoft.com/office/drawing/2014/main" id="{9751942C-EC42-4261-B38A-D0C75BCD802E}"/>
               </a:ext>
             </a:extLst>
           </p:cNvPr>
@@ -9298,7 +9298,7 @@
           <p:cNvPr id="35" name="">
             <a:extLst xmlns:a="http://schemas.openxmlformats.org/drawingml/2006/main">
               <a:ext uri="{FF2B5EF4-FFF2-40B4-BE49-F238E27FC236}">
-                <a16:creationId xmlns:a16="http://schemas.microsoft.com/office/drawing/2014/main" id="{3AB6E064-C82D-4A92-BA17-BD844FEB581E}"/>
+                <a16:creationId xmlns:a16="http://schemas.microsoft.com/office/drawing/2014/main" id="{C92EA50A-634D-42CC-B490-3552831A003C}"/>
               </a:ext>
             </a:extLst>
           </p:cNvPr>
@@ -9331,7 +9331,7 @@
           <p:cNvPr id="36" name="">
             <a:extLst xmlns:a="http://schemas.openxmlformats.org/drawingml/2006/main">
               <a:ext uri="{FF2B5EF4-FFF2-40B4-BE49-F238E27FC236}">
-                <a16:creationId xmlns:a16="http://schemas.microsoft.com/office/drawing/2014/main" id="{FB8CC4F9-5DF6-4F00-94B4-31F6C9CDAABD}"/>
+                <a16:creationId xmlns:a16="http://schemas.microsoft.com/office/drawing/2014/main" id="{4636EB5E-7A48-45CE-AB89-44C8EF067945}"/>
               </a:ext>
             </a:extLst>
           </p:cNvPr>
@@ -9395,7 +9395,7 @@
           <p:cNvPr id="37" name="">
             <a:extLst xmlns:a="http://schemas.openxmlformats.org/drawingml/2006/main">
               <a:ext uri="{FF2B5EF4-FFF2-40B4-BE49-F238E27FC236}">
-                <a16:creationId xmlns:a16="http://schemas.microsoft.com/office/drawing/2014/main" id="{C3B6248E-31CD-403B-9AC2-F6EECD30D84C}"/>
+                <a16:creationId xmlns:a16="http://schemas.microsoft.com/office/drawing/2014/main" id="{27E894F3-3091-4D08-8BE2-61FC2B6BB0EC}"/>
               </a:ext>
             </a:extLst>
           </p:cNvPr>
@@ -9428,7 +9428,7 @@
           <p:cNvPr id="38" name="">
             <a:extLst xmlns:a="http://schemas.openxmlformats.org/drawingml/2006/main">
               <a:ext uri="{FF2B5EF4-FFF2-40B4-BE49-F238E27FC236}">
-                <a16:creationId xmlns:a16="http://schemas.microsoft.com/office/drawing/2014/main" id="{73269D3B-7B79-4F6F-9CA7-F8275F184105}"/>
+                <a16:creationId xmlns:a16="http://schemas.microsoft.com/office/drawing/2014/main" id="{BBCDCFE6-2817-40E7-81D3-A037266488B0}"/>
               </a:ext>
             </a:extLst>
           </p:cNvPr>
@@ -9492,7 +9492,7 @@
           <p:cNvPr id="39" name="">
             <a:extLst xmlns:a="http://schemas.openxmlformats.org/drawingml/2006/main">
               <a:ext uri="{FF2B5EF4-FFF2-40B4-BE49-F238E27FC236}">
-                <a16:creationId xmlns:a16="http://schemas.microsoft.com/office/drawing/2014/main" id="{B1812F2C-AA8F-4733-81E6-46DD9DE17665}"/>
+                <a16:creationId xmlns:a16="http://schemas.microsoft.com/office/drawing/2014/main" id="{D8933BDF-F14A-4E0E-ABBB-8352C3D63852}"/>
               </a:ext>
             </a:extLst>
           </p:cNvPr>
@@ -9525,7 +9525,7 @@
           <p:cNvPr id="40" name="">
             <a:extLst xmlns:a="http://schemas.openxmlformats.org/drawingml/2006/main">
               <a:ext uri="{FF2B5EF4-FFF2-40B4-BE49-F238E27FC236}">
-                <a16:creationId xmlns:a16="http://schemas.microsoft.com/office/drawing/2014/main" id="{17966A0D-E3A3-4246-80BE-1452B0081EFE}"/>
+                <a16:creationId xmlns:a16="http://schemas.microsoft.com/office/drawing/2014/main" id="{7E27211C-B6A7-4437-9C29-CE5E9C436476}"/>
               </a:ext>
             </a:extLst>
           </p:cNvPr>
@@ -9589,7 +9589,7 @@
           <p:cNvPr id="41" name="">
             <a:extLst xmlns:a="http://schemas.openxmlformats.org/drawingml/2006/main">
               <a:ext uri="{FF2B5EF4-FFF2-40B4-BE49-F238E27FC236}">
-                <a16:creationId xmlns:a16="http://schemas.microsoft.com/office/drawing/2014/main" id="{53B4972D-8B83-4F35-AB3C-6091A5126E9C}"/>
+                <a16:creationId xmlns:a16="http://schemas.microsoft.com/office/drawing/2014/main" id="{4D16A8BE-485A-428F-AA8E-3891F4594331}"/>
               </a:ext>
             </a:extLst>
           </p:cNvPr>
@@ -9622,7 +9622,7 @@
           <p:cNvPr id="42" name="">
             <a:extLst xmlns:a="http://schemas.openxmlformats.org/drawingml/2006/main">
               <a:ext uri="{FF2B5EF4-FFF2-40B4-BE49-F238E27FC236}">
-                <a16:creationId xmlns:a16="http://schemas.microsoft.com/office/drawing/2014/main" id="{B7A4D288-BDCA-472E-9238-96F9EB747D69}"/>
+                <a16:creationId xmlns:a16="http://schemas.microsoft.com/office/drawing/2014/main" id="{33B868A9-EB0A-4086-B14D-36F69BA3AE42}"/>
               </a:ext>
             </a:extLst>
           </p:cNvPr>
@@ -9686,7 +9686,7 @@
           <p:cNvPr id="43" name="">
             <a:extLst xmlns:a="http://schemas.openxmlformats.org/drawingml/2006/main">
               <a:ext uri="{FF2B5EF4-FFF2-40B4-BE49-F238E27FC236}">
-                <a16:creationId xmlns:a16="http://schemas.microsoft.com/office/drawing/2014/main" id="{29D5E0F5-ED58-484B-91EA-361B6EAAF339}"/>
+                <a16:creationId xmlns:a16="http://schemas.microsoft.com/office/drawing/2014/main" id="{5CEE78C3-E42F-416D-A729-E6BE45E8FD94}"/>
               </a:ext>
             </a:extLst>
           </p:cNvPr>
@@ -9719,7 +9719,7 @@
           <p:cNvPr id="44" name="">
             <a:extLst xmlns:a="http://schemas.openxmlformats.org/drawingml/2006/main">
               <a:ext uri="{FF2B5EF4-FFF2-40B4-BE49-F238E27FC236}">
-                <a16:creationId xmlns:a16="http://schemas.microsoft.com/office/drawing/2014/main" id="{A0882B6C-D91C-4083-9275-8BCD991B296A}"/>
+                <a16:creationId xmlns:a16="http://schemas.microsoft.com/office/drawing/2014/main" id="{9BCAE5B2-5E8E-4CE9-8DB5-57349400E8B7}"/>
               </a:ext>
             </a:extLst>
           </p:cNvPr>
@@ -9783,7 +9783,7 @@
           <p:cNvPr id="45" name="">
             <a:extLst xmlns:a="http://schemas.openxmlformats.org/drawingml/2006/main">
               <a:ext uri="{FF2B5EF4-FFF2-40B4-BE49-F238E27FC236}">
-                <a16:creationId xmlns:a16="http://schemas.microsoft.com/office/drawing/2014/main" id="{8736A1F6-5AC4-4E4B-A90D-B24A5D0863CB}"/>
+                <a16:creationId xmlns:a16="http://schemas.microsoft.com/office/drawing/2014/main" id="{326B87D7-B2E6-4826-863D-B9CC41E3EE5F}"/>
               </a:ext>
             </a:extLst>
           </p:cNvPr>
@@ -9816,7 +9816,7 @@
           <p:cNvPr id="46" name="">
             <a:extLst xmlns:a="http://schemas.openxmlformats.org/drawingml/2006/main">
               <a:ext uri="{FF2B5EF4-FFF2-40B4-BE49-F238E27FC236}">
-                <a16:creationId xmlns:a16="http://schemas.microsoft.com/office/drawing/2014/main" id="{D16EE2DF-C4F9-4381-891D-E57CA4A3697F}"/>
+                <a16:creationId xmlns:a16="http://schemas.microsoft.com/office/drawing/2014/main" id="{036F9CC8-5A27-46E4-9251-9D071840412E}"/>
               </a:ext>
             </a:extLst>
           </p:cNvPr>
@@ -9880,7 +9880,7 @@
           <p:cNvPr id="47" name="">
             <a:extLst xmlns:a="http://schemas.openxmlformats.org/drawingml/2006/main">
               <a:ext uri="{FF2B5EF4-FFF2-40B4-BE49-F238E27FC236}">
-                <a16:creationId xmlns:a16="http://schemas.microsoft.com/office/drawing/2014/main" id="{35E1D79B-3D37-4B13-9280-2D16EA0646AA}"/>
+                <a16:creationId xmlns:a16="http://schemas.microsoft.com/office/drawing/2014/main" id="{F541AA5E-306E-4E70-A7B4-898605AC028C}"/>
               </a:ext>
             </a:extLst>
           </p:cNvPr>
@@ -9913,7 +9913,7 @@
           <p:cNvPr id="48" name="">
             <a:extLst xmlns:a="http://schemas.openxmlformats.org/drawingml/2006/main">
               <a:ext uri="{FF2B5EF4-FFF2-40B4-BE49-F238E27FC236}">
-                <a16:creationId xmlns:a16="http://schemas.microsoft.com/office/drawing/2014/main" id="{00AA8A6A-89C2-402B-A8A0-EB151BA61B2B}"/>
+                <a16:creationId xmlns:a16="http://schemas.microsoft.com/office/drawing/2014/main" id="{AF3674C6-720B-4CF9-B700-06212ADFFF57}"/>
               </a:ext>
             </a:extLst>
           </p:cNvPr>
@@ -9967,7 +9967,7 @@
                 <a:ea typeface="Arial"/>
                 <a:cs typeface="Arial"/>
               </a:rPr>
-              <a:t>estado sinalizado</a:t>
+              <a:t>estado sinalizado no sistema</a:t>
             </a:r>
           </a:p>
         </p:txBody>
@@ -9975,7 +9975,7 @@
     </p:spTree>
     <p:extLst>
       <p:ext uri="{BB962C8B-B14F-4D97-AF65-F5344CB8AC3E}">
-        <p14:creationId xmlns:p14="http://schemas.microsoft.com/office/powerpoint/2010/main" val="355289757"/>
+        <p14:creationId xmlns:p14="http://schemas.microsoft.com/office/powerpoint/2010/main" val="531511077"/>
       </p:ext>
     </p:extLst>
   </p:cSld>
@@ -9999,7 +9999,7 @@
           <p:cNvPr id="1" name="">
             <a:extLst xmlns:a="http://schemas.openxmlformats.org/drawingml/2006/main">
               <a:ext uri="{FF2B5EF4-FFF2-40B4-BE49-F238E27FC236}">
-                <a16:creationId xmlns:a16="http://schemas.microsoft.com/office/drawing/2014/main" id="{2BBCA70C-CEDE-4FAE-BE75-94BC2B0C036B}"/>
+                <a16:creationId xmlns:a16="http://schemas.microsoft.com/office/drawing/2014/main" id="{809B73F1-7DDB-4C45-9F51-A2727091BDB7}"/>
               </a:ext>
             </a:extLst>
           </p:cNvPr>
@@ -10034,7 +10034,7 @@
           <p:cNvPr id="2" name="">
             <a:extLst xmlns:a="http://schemas.openxmlformats.org/drawingml/2006/main">
               <a:ext uri="{FF2B5EF4-FFF2-40B4-BE49-F238E27FC236}">
-                <a16:creationId xmlns:a16="http://schemas.microsoft.com/office/drawing/2014/main" id="{C4804D80-A2B2-4707-976F-A78AF89EDC96}"/>
+                <a16:creationId xmlns:a16="http://schemas.microsoft.com/office/drawing/2014/main" id="{50DB641D-DED2-4617-9974-87AE588AAB50}"/>
               </a:ext>
             </a:extLst>
           </p:cNvPr>
@@ -10069,7 +10069,7 @@
           <p:cNvPr id="3" name="">
             <a:extLst xmlns:a="http://schemas.openxmlformats.org/drawingml/2006/main">
               <a:ext uri="{FF2B5EF4-FFF2-40B4-BE49-F238E27FC236}">
-                <a16:creationId xmlns:a16="http://schemas.microsoft.com/office/drawing/2014/main" id="{16DCE24A-A721-42BA-8556-B3F75EC58ED2}"/>
+                <a16:creationId xmlns:a16="http://schemas.microsoft.com/office/drawing/2014/main" id="{36C13617-EE48-45F2-A6CE-806F63EB2475}"/>
               </a:ext>
             </a:extLst>
           </p:cNvPr>
@@ -10104,7 +10104,7 @@
           <p:cNvPr id="4" name="kicker-17-label">
             <a:extLst xmlns:a="http://schemas.openxmlformats.org/drawingml/2006/main">
               <a:ext uri="{FF2B5EF4-FFF2-40B4-BE49-F238E27FC236}">
-                <a16:creationId xmlns:a16="http://schemas.microsoft.com/office/drawing/2014/main" id="{ED60B812-621C-4FAC-BF70-EECFDD31EE5E}"/>
+                <a16:creationId xmlns:a16="http://schemas.microsoft.com/office/drawing/2014/main" id="{F7D66470-4B0F-4862-BD0D-BC8585A16EDC}"/>
               </a:ext>
             </a:extLst>
           </p:cNvPr>
@@ -10168,7 +10168,7 @@
           <p:cNvPr id="5" name="">
             <a:extLst xmlns:a="http://schemas.openxmlformats.org/drawingml/2006/main">
               <a:ext uri="{FF2B5EF4-FFF2-40B4-BE49-F238E27FC236}">
-                <a16:creationId xmlns:a16="http://schemas.microsoft.com/office/drawing/2014/main" id="{F560D539-A803-491F-B5CB-676813C92BA4}"/>
+                <a16:creationId xmlns:a16="http://schemas.microsoft.com/office/drawing/2014/main" id="{2EB904AB-3291-42DC-A322-05879B2CA082}"/>
               </a:ext>
             </a:extLst>
           </p:cNvPr>
@@ -10232,7 +10232,7 @@
           <p:cNvPr id="6" name="">
             <a:extLst xmlns:a="http://schemas.openxmlformats.org/drawingml/2006/main">
               <a:ext uri="{FF2B5EF4-FFF2-40B4-BE49-F238E27FC236}">
-                <a16:creationId xmlns:a16="http://schemas.microsoft.com/office/drawing/2014/main" id="{FE1A3B6A-34B5-4A3D-9920-07B95AAA4CD1}"/>
+                <a16:creationId xmlns:a16="http://schemas.microsoft.com/office/drawing/2014/main" id="{2BB057D3-2000-4513-9CDD-981EA24DCDCE}"/>
               </a:ext>
             </a:extLst>
           </p:cNvPr>
@@ -10296,7 +10296,7 @@
           <p:cNvPr id="7" name="">
             <a:extLst xmlns:a="http://schemas.openxmlformats.org/drawingml/2006/main">
               <a:ext uri="{FF2B5EF4-FFF2-40B4-BE49-F238E27FC236}">
-                <a16:creationId xmlns:a16="http://schemas.microsoft.com/office/drawing/2014/main" id="{2D58D3BF-0D48-49BD-AC84-D38CEFD0A6ED}"/>
+                <a16:creationId xmlns:a16="http://schemas.microsoft.com/office/drawing/2014/main" id="{004DEF1A-65D8-44F1-9247-D69C25C7BB31}"/>
               </a:ext>
             </a:extLst>
           </p:cNvPr>
@@ -10331,7 +10331,7 @@
           <p:cNvPr id="8" name="">
             <a:extLst xmlns:a="http://schemas.openxmlformats.org/drawingml/2006/main">
               <a:ext uri="{FF2B5EF4-FFF2-40B4-BE49-F238E27FC236}">
-                <a16:creationId xmlns:a16="http://schemas.microsoft.com/office/drawing/2014/main" id="{4D2668D3-5EF8-4817-9BFF-6F3BA158E45B}"/>
+                <a16:creationId xmlns:a16="http://schemas.microsoft.com/office/drawing/2014/main" id="{E5600DBC-C655-47EC-AE24-DC7EC8A52D55}"/>
               </a:ext>
             </a:extLst>
           </p:cNvPr>
@@ -10395,7 +10395,7 @@
           <p:cNvPr id="9" name="">
             <a:extLst xmlns:a="http://schemas.openxmlformats.org/drawingml/2006/main">
               <a:ext uri="{FF2B5EF4-FFF2-40B4-BE49-F238E27FC236}">
-                <a16:creationId xmlns:a16="http://schemas.microsoft.com/office/drawing/2014/main" id="{AE3601C0-4457-4FDE-A9CF-B22A1C4D46DD}"/>
+                <a16:creationId xmlns:a16="http://schemas.microsoft.com/office/drawing/2014/main" id="{CC629499-161E-4F4E-A0FE-AA7A5C1C6B8B}"/>
               </a:ext>
             </a:extLst>
           </p:cNvPr>
@@ -10430,7 +10430,7 @@
           <p:cNvPr id="10" name="">
             <a:extLst xmlns:a="http://schemas.openxmlformats.org/drawingml/2006/main">
               <a:ext uri="{FF2B5EF4-FFF2-40B4-BE49-F238E27FC236}">
-                <a16:creationId xmlns:a16="http://schemas.microsoft.com/office/drawing/2014/main" id="{EDAC3A33-8BE0-4F42-8509-440B7D496CE0}"/>
+                <a16:creationId xmlns:a16="http://schemas.microsoft.com/office/drawing/2014/main" id="{8C0CFE0C-43C9-4960-8B78-4DD557507B7B}"/>
               </a:ext>
             </a:extLst>
           </p:cNvPr>
@@ -10494,7 +10494,7 @@
           <p:cNvPr id="11" name="">
             <a:extLst xmlns:a="http://schemas.openxmlformats.org/drawingml/2006/main">
               <a:ext uri="{FF2B5EF4-FFF2-40B4-BE49-F238E27FC236}">
-                <a16:creationId xmlns:a16="http://schemas.microsoft.com/office/drawing/2014/main" id="{486B88CB-3D50-44EA-AAEB-15BC3BBCE2B2}"/>
+                <a16:creationId xmlns:a16="http://schemas.microsoft.com/office/drawing/2014/main" id="{B92ED6C2-99BE-46C6-8F63-94B5410BDEB1}"/>
               </a:ext>
             </a:extLst>
           </p:cNvPr>
@@ -10529,7 +10529,7 @@
           <p:cNvPr id="12" name="">
             <a:extLst xmlns:a="http://schemas.openxmlformats.org/drawingml/2006/main">
               <a:ext uri="{FF2B5EF4-FFF2-40B4-BE49-F238E27FC236}">
-                <a16:creationId xmlns:a16="http://schemas.microsoft.com/office/drawing/2014/main" id="{FCD6A0D3-A50D-44C0-A9AA-712651AFF3F6}"/>
+                <a16:creationId xmlns:a16="http://schemas.microsoft.com/office/drawing/2014/main" id="{5DCC97C0-A81D-4BC6-A5BF-3F2CAF77A95A}"/>
               </a:ext>
             </a:extLst>
           </p:cNvPr>
@@ -10583,7 +10583,7 @@
                 <a:ea typeface="Arial"/>
                 <a:cs typeface="Arial"/>
               </a:rPr>
-              <a:t>Os limites são claros: não foram medidos alcance, taxa de leitura, múltiplas tags ou interferência ambiental.</a:t>
+              <a:t>Os limites permanecem explícitos: não foram medidos alcance, taxa de leitura, múltiplas tags ou interferência ambiental.</a:t>
             </a:r>
           </a:p>
         </p:txBody>
@@ -10593,7 +10593,7 @@
           <p:cNvPr id="13" name="">
             <a:extLst xmlns:a="http://schemas.openxmlformats.org/drawingml/2006/main">
               <a:ext uri="{FF2B5EF4-FFF2-40B4-BE49-F238E27FC236}">
-                <a16:creationId xmlns:a16="http://schemas.microsoft.com/office/drawing/2014/main" id="{E8350B40-AC52-4CBA-BA3B-EAF6991AC172}"/>
+                <a16:creationId xmlns:a16="http://schemas.microsoft.com/office/drawing/2014/main" id="{0BCBF195-C605-4087-B82F-C231D0C53847}"/>
               </a:ext>
             </a:extLst>
           </p:cNvPr>
@@ -10626,7 +10626,7 @@
           <p:cNvPr id="14" name="">
             <a:extLst xmlns:a="http://schemas.openxmlformats.org/drawingml/2006/main">
               <a:ext uri="{FF2B5EF4-FFF2-40B4-BE49-F238E27FC236}">
-                <a16:creationId xmlns:a16="http://schemas.microsoft.com/office/drawing/2014/main" id="{4482BFA2-431A-4716-94BB-AA60A7AF539E}"/>
+                <a16:creationId xmlns:a16="http://schemas.microsoft.com/office/drawing/2014/main" id="{7A7E51EF-2254-413D-A1EE-68C05940287F}"/>
               </a:ext>
             </a:extLst>
           </p:cNvPr>
@@ -10690,7 +10690,7 @@
           <p:cNvPr id="15" name="">
             <a:extLst xmlns:a="http://schemas.openxmlformats.org/drawingml/2006/main">
               <a:ext uri="{FF2B5EF4-FFF2-40B4-BE49-F238E27FC236}">
-                <a16:creationId xmlns:a16="http://schemas.microsoft.com/office/drawing/2014/main" id="{B9981114-9634-4A73-9B44-216CC49931D0}"/>
+                <a16:creationId xmlns:a16="http://schemas.microsoft.com/office/drawing/2014/main" id="{371F9E6C-678A-4858-BD90-CF9B90453FBC}"/>
               </a:ext>
             </a:extLst>
           </p:cNvPr>
@@ -10754,7 +10754,7 @@
           <p:cNvPr id="16" name="">
             <a:extLst xmlns:a="http://schemas.openxmlformats.org/drawingml/2006/main">
               <a:ext uri="{FF2B5EF4-FFF2-40B4-BE49-F238E27FC236}">
-                <a16:creationId xmlns:a16="http://schemas.microsoft.com/office/drawing/2014/main" id="{9BF6DA87-6E73-4930-B902-D75D5B20BD6F}"/>
+                <a16:creationId xmlns:a16="http://schemas.microsoft.com/office/drawing/2014/main" id="{B2C731AA-DD51-4358-8A4B-D526E441202C}"/>
               </a:ext>
             </a:extLst>
           </p:cNvPr>
@@ -10787,7 +10787,7 @@
           <p:cNvPr id="17" name="">
             <a:extLst xmlns:a="http://schemas.openxmlformats.org/drawingml/2006/main">
               <a:ext uri="{FF2B5EF4-FFF2-40B4-BE49-F238E27FC236}">
-                <a16:creationId xmlns:a16="http://schemas.microsoft.com/office/drawing/2014/main" id="{358C2953-B7EB-4999-9767-DE54D47D172B}"/>
+                <a16:creationId xmlns:a16="http://schemas.microsoft.com/office/drawing/2014/main" id="{4206DA77-D982-4C11-BA22-E8216CBF1F23}"/>
               </a:ext>
             </a:extLst>
           </p:cNvPr>
@@ -10851,7 +10851,7 @@
           <p:cNvPr id="18" name="">
             <a:extLst xmlns:a="http://schemas.openxmlformats.org/drawingml/2006/main">
               <a:ext uri="{FF2B5EF4-FFF2-40B4-BE49-F238E27FC236}">
-                <a16:creationId xmlns:a16="http://schemas.microsoft.com/office/drawing/2014/main" id="{4AFDB090-3354-4E36-AE3A-8294F1955148}"/>
+                <a16:creationId xmlns:a16="http://schemas.microsoft.com/office/drawing/2014/main" id="{E0156CA2-2862-4191-8718-B0CE6D56E909}"/>
               </a:ext>
             </a:extLst>
           </p:cNvPr>
@@ -10915,7 +10915,7 @@
           <p:cNvPr id="19" name="">
             <a:extLst xmlns:a="http://schemas.openxmlformats.org/drawingml/2006/main">
               <a:ext uri="{FF2B5EF4-FFF2-40B4-BE49-F238E27FC236}">
-                <a16:creationId xmlns:a16="http://schemas.microsoft.com/office/drawing/2014/main" id="{43B6E0F0-A16B-4D0C-87A3-D101AFD6933B}"/>
+                <a16:creationId xmlns:a16="http://schemas.microsoft.com/office/drawing/2014/main" id="{D0AB648D-7DE3-4EBB-8378-3D9CBC22ED26}"/>
               </a:ext>
             </a:extLst>
           </p:cNvPr>
@@ -10948,7 +10948,7 @@
           <p:cNvPr id="20" name="">
             <a:extLst xmlns:a="http://schemas.openxmlformats.org/drawingml/2006/main">
               <a:ext uri="{FF2B5EF4-FFF2-40B4-BE49-F238E27FC236}">
-                <a16:creationId xmlns:a16="http://schemas.microsoft.com/office/drawing/2014/main" id="{7EA55D50-FA13-4F14-846B-473A90D5EE3C}"/>
+                <a16:creationId xmlns:a16="http://schemas.microsoft.com/office/drawing/2014/main" id="{CE5A2F87-3DAE-4931-9587-48E769D66D14}"/>
               </a:ext>
             </a:extLst>
           </p:cNvPr>
@@ -11012,7 +11012,7 @@
           <p:cNvPr id="21" name="">
             <a:extLst xmlns:a="http://schemas.openxmlformats.org/drawingml/2006/main">
               <a:ext uri="{FF2B5EF4-FFF2-40B4-BE49-F238E27FC236}">
-                <a16:creationId xmlns:a16="http://schemas.microsoft.com/office/drawing/2014/main" id="{AE640119-548A-41F8-ADC4-EEB96A498EA2}"/>
+                <a16:creationId xmlns:a16="http://schemas.microsoft.com/office/drawing/2014/main" id="{24C43E52-D051-46A8-89F1-A8AB463833AF}"/>
               </a:ext>
             </a:extLst>
           </p:cNvPr>
@@ -11074,7 +11074,7 @@
     </p:spTree>
     <p:extLst>
       <p:ext uri="{BB962C8B-B14F-4D97-AF65-F5344CB8AC3E}">
-        <p14:creationId xmlns:p14="http://schemas.microsoft.com/office/powerpoint/2010/main" val="1703301477"/>
+        <p14:creationId xmlns:p14="http://schemas.microsoft.com/office/powerpoint/2010/main" val="1642374200"/>
       </p:ext>
     </p:extLst>
   </p:cSld>
@@ -11098,7 +11098,7 @@
           <p:cNvPr id="1" name="">
             <a:extLst xmlns:a="http://schemas.openxmlformats.org/drawingml/2006/main">
               <a:ext uri="{FF2B5EF4-FFF2-40B4-BE49-F238E27FC236}">
-                <a16:creationId xmlns:a16="http://schemas.microsoft.com/office/drawing/2014/main" id="{56264D3D-FC24-4AF9-B6B7-F2F52A008EAA}"/>
+                <a16:creationId xmlns:a16="http://schemas.microsoft.com/office/drawing/2014/main" id="{4A68556D-3330-47F9-9960-5011FC5DEA24}"/>
               </a:ext>
             </a:extLst>
           </p:cNvPr>
@@ -11133,7 +11133,7 @@
           <p:cNvPr id="2" name="">
             <a:extLst xmlns:a="http://schemas.openxmlformats.org/drawingml/2006/main">
               <a:ext uri="{FF2B5EF4-FFF2-40B4-BE49-F238E27FC236}">
-                <a16:creationId xmlns:a16="http://schemas.microsoft.com/office/drawing/2014/main" id="{15F857AB-36E6-44FD-82F4-DF2CAB00888A}"/>
+                <a16:creationId xmlns:a16="http://schemas.microsoft.com/office/drawing/2014/main" id="{53468982-4B2D-4252-A805-DC34BEEED585}"/>
               </a:ext>
             </a:extLst>
           </p:cNvPr>
@@ -11168,7 +11168,7 @@
           <p:cNvPr id="3" name="">
             <a:extLst xmlns:a="http://schemas.openxmlformats.org/drawingml/2006/main">
               <a:ext uri="{FF2B5EF4-FFF2-40B4-BE49-F238E27FC236}">
-                <a16:creationId xmlns:a16="http://schemas.microsoft.com/office/drawing/2014/main" id="{0AE8D884-ECF4-4727-A11E-1068C8CA3078}"/>
+                <a16:creationId xmlns:a16="http://schemas.microsoft.com/office/drawing/2014/main" id="{D6742722-07D7-4764-BA6D-1925190EED9C}"/>
               </a:ext>
             </a:extLst>
           </p:cNvPr>
@@ -11203,7 +11203,7 @@
           <p:cNvPr id="4" name="kicker-18-label">
             <a:extLst xmlns:a="http://schemas.openxmlformats.org/drawingml/2006/main">
               <a:ext uri="{FF2B5EF4-FFF2-40B4-BE49-F238E27FC236}">
-                <a16:creationId xmlns:a16="http://schemas.microsoft.com/office/drawing/2014/main" id="{E6A3F6B2-4488-46FB-A782-B254DD164ACD}"/>
+                <a16:creationId xmlns:a16="http://schemas.microsoft.com/office/drawing/2014/main" id="{8B1DC06A-315A-4322-A086-1802281CA4F0}"/>
               </a:ext>
             </a:extLst>
           </p:cNvPr>
@@ -11267,7 +11267,7 @@
           <p:cNvPr id="5" name="">
             <a:extLst xmlns:a="http://schemas.openxmlformats.org/drawingml/2006/main">
               <a:ext uri="{FF2B5EF4-FFF2-40B4-BE49-F238E27FC236}">
-                <a16:creationId xmlns:a16="http://schemas.microsoft.com/office/drawing/2014/main" id="{7569DBBD-9C50-4697-B34D-C67769F11B65}"/>
+                <a16:creationId xmlns:a16="http://schemas.microsoft.com/office/drawing/2014/main" id="{22CD2DDD-A51B-45A6-9A79-CEC5B95FE150}"/>
               </a:ext>
             </a:extLst>
           </p:cNvPr>
@@ -11331,7 +11331,7 @@
           <p:cNvPr id="6" name="">
             <a:extLst xmlns:a="http://schemas.openxmlformats.org/drawingml/2006/main">
               <a:ext uri="{FF2B5EF4-FFF2-40B4-BE49-F238E27FC236}">
-                <a16:creationId xmlns:a16="http://schemas.microsoft.com/office/drawing/2014/main" id="{8AD60E3B-EEAC-416F-904A-A39400A27D63}"/>
+                <a16:creationId xmlns:a16="http://schemas.microsoft.com/office/drawing/2014/main" id="{5173379A-C498-4B0A-B770-680E3ACEACB5}"/>
               </a:ext>
             </a:extLst>
           </p:cNvPr>
@@ -11395,7 +11395,7 @@
           <p:cNvPr id="7" name="">
             <a:extLst xmlns:a="http://schemas.openxmlformats.org/drawingml/2006/main">
               <a:ext uri="{FF2B5EF4-FFF2-40B4-BE49-F238E27FC236}">
-                <a16:creationId xmlns:a16="http://schemas.microsoft.com/office/drawing/2014/main" id="{85792C21-F429-4483-A325-4529FBF4C3E9}"/>
+                <a16:creationId xmlns:a16="http://schemas.microsoft.com/office/drawing/2014/main" id="{1744BB83-892C-483E-BD1C-FAD95C066605}"/>
               </a:ext>
             </a:extLst>
           </p:cNvPr>
@@ -11430,7 +11430,7 @@
           <p:cNvPr id="8" name="">
             <a:extLst xmlns:a="http://schemas.openxmlformats.org/drawingml/2006/main">
               <a:ext uri="{FF2B5EF4-FFF2-40B4-BE49-F238E27FC236}">
-                <a16:creationId xmlns:a16="http://schemas.microsoft.com/office/drawing/2014/main" id="{6472C3CB-8349-4B5F-841B-4A094A95E190}"/>
+                <a16:creationId xmlns:a16="http://schemas.microsoft.com/office/drawing/2014/main" id="{8727E9D2-02EA-49CD-8069-C9E318A2F596}"/>
               </a:ext>
             </a:extLst>
           </p:cNvPr>
@@ -11494,7 +11494,7 @@
           <p:cNvPr id="9" name="">
             <a:extLst xmlns:a="http://schemas.openxmlformats.org/drawingml/2006/main">
               <a:ext uri="{FF2B5EF4-FFF2-40B4-BE49-F238E27FC236}">
-                <a16:creationId xmlns:a16="http://schemas.microsoft.com/office/drawing/2014/main" id="{ACCFB778-0DEA-45F0-913A-19A163FA56CF}"/>
+                <a16:creationId xmlns:a16="http://schemas.microsoft.com/office/drawing/2014/main" id="{4850C9E4-63D8-4DD8-936B-C13B1F1A5167}"/>
               </a:ext>
             </a:extLst>
           </p:cNvPr>
@@ -11529,7 +11529,7 @@
           <p:cNvPr id="10" name="">
             <a:extLst xmlns:a="http://schemas.openxmlformats.org/drawingml/2006/main">
               <a:ext uri="{FF2B5EF4-FFF2-40B4-BE49-F238E27FC236}">
-                <a16:creationId xmlns:a16="http://schemas.microsoft.com/office/drawing/2014/main" id="{30388660-2CDF-4C07-A8FF-F9344AD47961}"/>
+                <a16:creationId xmlns:a16="http://schemas.microsoft.com/office/drawing/2014/main" id="{D2317845-8AFB-45A4-91DF-F666D0AE8DCA}"/>
               </a:ext>
             </a:extLst>
           </p:cNvPr>
@@ -11593,7 +11593,7 @@
           <p:cNvPr id="11" name="">
             <a:extLst xmlns:a="http://schemas.openxmlformats.org/drawingml/2006/main">
               <a:ext uri="{FF2B5EF4-FFF2-40B4-BE49-F238E27FC236}">
-                <a16:creationId xmlns:a16="http://schemas.microsoft.com/office/drawing/2014/main" id="{A5E75F25-5E4A-4287-917E-248047129AB4}"/>
+                <a16:creationId xmlns:a16="http://schemas.microsoft.com/office/drawing/2014/main" id="{FCB2ECD1-1E69-4B2C-8423-4A6C343C2034}"/>
               </a:ext>
             </a:extLst>
           </p:cNvPr>
@@ -11628,7 +11628,7 @@
           <p:cNvPr id="12" name="">
             <a:extLst xmlns:a="http://schemas.openxmlformats.org/drawingml/2006/main">
               <a:ext uri="{FF2B5EF4-FFF2-40B4-BE49-F238E27FC236}">
-                <a16:creationId xmlns:a16="http://schemas.microsoft.com/office/drawing/2014/main" id="{E2030871-667C-44E9-83F1-00B48C4BB693}"/>
+                <a16:creationId xmlns:a16="http://schemas.microsoft.com/office/drawing/2014/main" id="{801574FA-3701-4206-AFF8-583B410F9FC1}"/>
               </a:ext>
             </a:extLst>
           </p:cNvPr>
@@ -11692,7 +11692,7 @@
           <p:cNvPr id="13" name="">
             <a:extLst xmlns:a="http://schemas.openxmlformats.org/drawingml/2006/main">
               <a:ext uri="{FF2B5EF4-FFF2-40B4-BE49-F238E27FC236}">
-                <a16:creationId xmlns:a16="http://schemas.microsoft.com/office/drawing/2014/main" id="{7E5F43E4-F59F-4C7D-BFA3-27946005EA54}"/>
+                <a16:creationId xmlns:a16="http://schemas.microsoft.com/office/drawing/2014/main" id="{D76C83CF-AE0E-453A-81E5-3AC79F79A62D}"/>
               </a:ext>
             </a:extLst>
           </p:cNvPr>
@@ -11727,7 +11727,7 @@
           <p:cNvPr id="14" name="">
             <a:extLst xmlns:a="http://schemas.openxmlformats.org/drawingml/2006/main">
               <a:ext uri="{FF2B5EF4-FFF2-40B4-BE49-F238E27FC236}">
-                <a16:creationId xmlns:a16="http://schemas.microsoft.com/office/drawing/2014/main" id="{3EC6B2B7-019B-4FA4-AF2F-F5828F6764FF}"/>
+                <a16:creationId xmlns:a16="http://schemas.microsoft.com/office/drawing/2014/main" id="{1737EC00-5556-4894-9EB7-2C2C5F1C8956}"/>
               </a:ext>
             </a:extLst>
           </p:cNvPr>
@@ -11791,7 +11791,7 @@
           <p:cNvPr id="15" name="">
             <a:extLst xmlns:a="http://schemas.openxmlformats.org/drawingml/2006/main">
               <a:ext uri="{FF2B5EF4-FFF2-40B4-BE49-F238E27FC236}">
-                <a16:creationId xmlns:a16="http://schemas.microsoft.com/office/drawing/2014/main" id="{C85811BA-C642-42D9-81E3-9D6BA43CEBAE}"/>
+                <a16:creationId xmlns:a16="http://schemas.microsoft.com/office/drawing/2014/main" id="{A187A0AF-E0E7-4936-BAA6-4ABE3D0DDE4B}"/>
               </a:ext>
             </a:extLst>
           </p:cNvPr>
@@ -11826,7 +11826,7 @@
           <p:cNvPr id="16" name="">
             <a:extLst xmlns:a="http://schemas.openxmlformats.org/drawingml/2006/main">
               <a:ext uri="{FF2B5EF4-FFF2-40B4-BE49-F238E27FC236}">
-                <a16:creationId xmlns:a16="http://schemas.microsoft.com/office/drawing/2014/main" id="{28F50C39-D136-48FD-9C25-A3AD0F88060A}"/>
+                <a16:creationId xmlns:a16="http://schemas.microsoft.com/office/drawing/2014/main" id="{3F464D85-D073-4DAE-AC8F-9580036DC4B5}"/>
               </a:ext>
             </a:extLst>
           </p:cNvPr>
@@ -11890,7 +11890,7 @@
           <p:cNvPr id="17" name="">
             <a:extLst xmlns:a="http://schemas.openxmlformats.org/drawingml/2006/main">
               <a:ext uri="{FF2B5EF4-FFF2-40B4-BE49-F238E27FC236}">
-                <a16:creationId xmlns:a16="http://schemas.microsoft.com/office/drawing/2014/main" id="{87B0F7BD-938B-4A09-A340-54480F6C0CDB}"/>
+                <a16:creationId xmlns:a16="http://schemas.microsoft.com/office/drawing/2014/main" id="{A40BA6BA-A192-4B3E-9502-146F78D6918A}"/>
               </a:ext>
             </a:extLst>
           </p:cNvPr>
@@ -11925,7 +11925,7 @@
           <p:cNvPr id="18" name="">
             <a:extLst xmlns:a="http://schemas.openxmlformats.org/drawingml/2006/main">
               <a:ext uri="{FF2B5EF4-FFF2-40B4-BE49-F238E27FC236}">
-                <a16:creationId xmlns:a16="http://schemas.microsoft.com/office/drawing/2014/main" id="{8F5D6A14-082D-4AD4-A1B4-718E456E546A}"/>
+                <a16:creationId xmlns:a16="http://schemas.microsoft.com/office/drawing/2014/main" id="{AE2CB222-AFF1-4D1D-BA53-0878D8FFF9CF}"/>
               </a:ext>
             </a:extLst>
           </p:cNvPr>
@@ -11989,7 +11989,7 @@
           <p:cNvPr id="19" name="">
             <a:extLst xmlns:a="http://schemas.openxmlformats.org/drawingml/2006/main">
               <a:ext uri="{FF2B5EF4-FFF2-40B4-BE49-F238E27FC236}">
-                <a16:creationId xmlns:a16="http://schemas.microsoft.com/office/drawing/2014/main" id="{BD748ECB-BB8D-4031-A0DA-D9AAEC3203E2}"/>
+                <a16:creationId xmlns:a16="http://schemas.microsoft.com/office/drawing/2014/main" id="{9C5D158A-6DFC-4125-8D63-C6E6C75DFF49}"/>
               </a:ext>
             </a:extLst>
           </p:cNvPr>
@@ -12024,7 +12024,7 @@
           <p:cNvPr id="20" name="">
             <a:extLst xmlns:a="http://schemas.openxmlformats.org/drawingml/2006/main">
               <a:ext uri="{FF2B5EF4-FFF2-40B4-BE49-F238E27FC236}">
-                <a16:creationId xmlns:a16="http://schemas.microsoft.com/office/drawing/2014/main" id="{FADF5E71-9C16-4E35-A48E-273027A7DE2D}"/>
+                <a16:creationId xmlns:a16="http://schemas.microsoft.com/office/drawing/2014/main" id="{44221127-9C90-4185-9D32-ED58257B944D}"/>
               </a:ext>
             </a:extLst>
           </p:cNvPr>
@@ -12086,7 +12086,7 @@
     </p:spTree>
     <p:extLst>
       <p:ext uri="{BB962C8B-B14F-4D97-AF65-F5344CB8AC3E}">
-        <p14:creationId xmlns:p14="http://schemas.microsoft.com/office/powerpoint/2010/main" val="434034130"/>
+        <p14:creationId xmlns:p14="http://schemas.microsoft.com/office/powerpoint/2010/main" val="1136043387"/>
       </p:ext>
     </p:extLst>
   </p:cSld>
@@ -12110,7 +12110,7 @@
           <p:cNvPr id="1" name="">
             <a:extLst xmlns:a="http://schemas.openxmlformats.org/drawingml/2006/main">
               <a:ext uri="{FF2B5EF4-FFF2-40B4-BE49-F238E27FC236}">
-                <a16:creationId xmlns:a16="http://schemas.microsoft.com/office/drawing/2014/main" id="{E39109FA-1344-4935-9F02-E78F9317B15E}"/>
+                <a16:creationId xmlns:a16="http://schemas.microsoft.com/office/drawing/2014/main" id="{AF475372-66AB-4253-B23E-0017E0E1E12E}"/>
               </a:ext>
             </a:extLst>
           </p:cNvPr>
@@ -12145,7 +12145,7 @@
           <p:cNvPr id="2" name="">
             <a:extLst xmlns:a="http://schemas.openxmlformats.org/drawingml/2006/main">
               <a:ext uri="{FF2B5EF4-FFF2-40B4-BE49-F238E27FC236}">
-                <a16:creationId xmlns:a16="http://schemas.microsoft.com/office/drawing/2014/main" id="{38DF0635-C2D5-4BD7-BEC7-4B9EE2E64327}"/>
+                <a16:creationId xmlns:a16="http://schemas.microsoft.com/office/drawing/2014/main" id="{CFA183BE-934D-4C5C-8D15-0392BC20A0AE}"/>
               </a:ext>
             </a:extLst>
           </p:cNvPr>
@@ -12180,7 +12180,7 @@
           <p:cNvPr id="3" name="">
             <a:extLst xmlns:a="http://schemas.openxmlformats.org/drawingml/2006/main">
               <a:ext uri="{FF2B5EF4-FFF2-40B4-BE49-F238E27FC236}">
-                <a16:creationId xmlns:a16="http://schemas.microsoft.com/office/drawing/2014/main" id="{3C7DAF1A-60B1-4933-AB12-6A1175C95555}"/>
+                <a16:creationId xmlns:a16="http://schemas.microsoft.com/office/drawing/2014/main" id="{EB80431D-6537-4CB2-947B-A60462241039}"/>
               </a:ext>
             </a:extLst>
           </p:cNvPr>
@@ -12215,7 +12215,7 @@
           <p:cNvPr id="4" name="kicker-2-label">
             <a:extLst xmlns:a="http://schemas.openxmlformats.org/drawingml/2006/main">
               <a:ext uri="{FF2B5EF4-FFF2-40B4-BE49-F238E27FC236}">
-                <a16:creationId xmlns:a16="http://schemas.microsoft.com/office/drawing/2014/main" id="{14928FD6-A9B2-4191-8081-AB62544BB292}"/>
+                <a16:creationId xmlns:a16="http://schemas.microsoft.com/office/drawing/2014/main" id="{7436FC57-0028-4CE8-BFA0-104651F5FEF8}"/>
               </a:ext>
             </a:extLst>
           </p:cNvPr>
@@ -12279,7 +12279,7 @@
           <p:cNvPr id="5" name="">
             <a:extLst xmlns:a="http://schemas.openxmlformats.org/drawingml/2006/main">
               <a:ext uri="{FF2B5EF4-FFF2-40B4-BE49-F238E27FC236}">
-                <a16:creationId xmlns:a16="http://schemas.microsoft.com/office/drawing/2014/main" id="{582CBAC1-B0DF-4246-ADD0-DECE81E40D79}"/>
+                <a16:creationId xmlns:a16="http://schemas.microsoft.com/office/drawing/2014/main" id="{1F30E54D-9C1D-4A1D-B867-979C648DDA8F}"/>
               </a:ext>
             </a:extLst>
           </p:cNvPr>
@@ -12343,7 +12343,7 @@
           <p:cNvPr id="6" name="">
             <a:extLst xmlns:a="http://schemas.openxmlformats.org/drawingml/2006/main">
               <a:ext uri="{FF2B5EF4-FFF2-40B4-BE49-F238E27FC236}">
-                <a16:creationId xmlns:a16="http://schemas.microsoft.com/office/drawing/2014/main" id="{1946C33B-8826-4D9D-A61E-5131131468C6}"/>
+                <a16:creationId xmlns:a16="http://schemas.microsoft.com/office/drawing/2014/main" id="{22172801-F913-42F6-82DD-28374E7A7C0A}"/>
               </a:ext>
             </a:extLst>
           </p:cNvPr>
@@ -12407,7 +12407,7 @@
           <p:cNvPr id="7" name="">
             <a:extLst xmlns:a="http://schemas.openxmlformats.org/drawingml/2006/main">
               <a:ext uri="{FF2B5EF4-FFF2-40B4-BE49-F238E27FC236}">
-                <a16:creationId xmlns:a16="http://schemas.microsoft.com/office/drawing/2014/main" id="{0502CE4F-FF41-41BE-B634-FF1EAEC50BA3}"/>
+                <a16:creationId xmlns:a16="http://schemas.microsoft.com/office/drawing/2014/main" id="{A6A0ED1C-4CCC-4F71-95B1-9C36C007617F}"/>
               </a:ext>
             </a:extLst>
           </p:cNvPr>
@@ -12442,7 +12442,7 @@
           <p:cNvPr id="8" name="">
             <a:extLst xmlns:a="http://schemas.openxmlformats.org/drawingml/2006/main">
               <a:ext uri="{FF2B5EF4-FFF2-40B4-BE49-F238E27FC236}">
-                <a16:creationId xmlns:a16="http://schemas.microsoft.com/office/drawing/2014/main" id="{30C3840F-CD3E-4E21-BAD2-6B33A0C26C53}"/>
+                <a16:creationId xmlns:a16="http://schemas.microsoft.com/office/drawing/2014/main" id="{DD8DFD1C-08B4-4380-95DE-1CC1024C0B0B}"/>
               </a:ext>
             </a:extLst>
           </p:cNvPr>
@@ -12506,7 +12506,7 @@
           <p:cNvPr id="9" name="">
             <a:extLst xmlns:a="http://schemas.openxmlformats.org/drawingml/2006/main">
               <a:ext uri="{FF2B5EF4-FFF2-40B4-BE49-F238E27FC236}">
-                <a16:creationId xmlns:a16="http://schemas.microsoft.com/office/drawing/2014/main" id="{85EDA038-F829-4540-B372-3E992FB7DD48}"/>
+                <a16:creationId xmlns:a16="http://schemas.microsoft.com/office/drawing/2014/main" id="{C701E08B-6871-4E79-8A98-BCB21D798558}"/>
               </a:ext>
             </a:extLst>
           </p:cNvPr>
@@ -12541,7 +12541,7 @@
           <p:cNvPr id="10" name="">
             <a:extLst xmlns:a="http://schemas.openxmlformats.org/drawingml/2006/main">
               <a:ext uri="{FF2B5EF4-FFF2-40B4-BE49-F238E27FC236}">
-                <a16:creationId xmlns:a16="http://schemas.microsoft.com/office/drawing/2014/main" id="{2876811A-A333-4D00-97BA-BDE790A254A0}"/>
+                <a16:creationId xmlns:a16="http://schemas.microsoft.com/office/drawing/2014/main" id="{45B38183-092E-4086-A4B4-BEBAABF9F8CF}"/>
               </a:ext>
             </a:extLst>
           </p:cNvPr>
@@ -12605,7 +12605,7 @@
           <p:cNvPr id="11" name="">
             <a:extLst xmlns:a="http://schemas.openxmlformats.org/drawingml/2006/main">
               <a:ext uri="{FF2B5EF4-FFF2-40B4-BE49-F238E27FC236}">
-                <a16:creationId xmlns:a16="http://schemas.microsoft.com/office/drawing/2014/main" id="{D5E57F7E-36C0-4E97-9C85-B60A20D079AA}"/>
+                <a16:creationId xmlns:a16="http://schemas.microsoft.com/office/drawing/2014/main" id="{F13808A8-9C7B-4560-8098-E63A3456DA07}"/>
               </a:ext>
             </a:extLst>
           </p:cNvPr>
@@ -12640,7 +12640,7 @@
           <p:cNvPr id="12" name="">
             <a:extLst xmlns:a="http://schemas.openxmlformats.org/drawingml/2006/main">
               <a:ext uri="{FF2B5EF4-FFF2-40B4-BE49-F238E27FC236}">
-                <a16:creationId xmlns:a16="http://schemas.microsoft.com/office/drawing/2014/main" id="{1DE1C3BB-D877-4E00-ABBD-8B95DE6A1EEB}"/>
+                <a16:creationId xmlns:a16="http://schemas.microsoft.com/office/drawing/2014/main" id="{BBAAAD66-8429-4E6A-B1CB-4F59EC672ABD}"/>
               </a:ext>
             </a:extLst>
           </p:cNvPr>
@@ -12704,7 +12704,7 @@
           <p:cNvPr id="13" name="">
             <a:extLst xmlns:a="http://schemas.openxmlformats.org/drawingml/2006/main">
               <a:ext uri="{FF2B5EF4-FFF2-40B4-BE49-F238E27FC236}">
-                <a16:creationId xmlns:a16="http://schemas.microsoft.com/office/drawing/2014/main" id="{0536F04A-B921-4CB9-94EE-2839ED7A205F}"/>
+                <a16:creationId xmlns:a16="http://schemas.microsoft.com/office/drawing/2014/main" id="{2DE8B99D-E1E3-4124-A37E-DC2BDB94357E}"/>
               </a:ext>
             </a:extLst>
           </p:cNvPr>
@@ -12737,7 +12737,7 @@
           <p:cNvPr id="14" name="">
             <a:extLst xmlns:a="http://schemas.openxmlformats.org/drawingml/2006/main">
               <a:ext uri="{FF2B5EF4-FFF2-40B4-BE49-F238E27FC236}">
-                <a16:creationId xmlns:a16="http://schemas.microsoft.com/office/drawing/2014/main" id="{84D42AB6-CECC-4886-B750-D7A511C4FE63}"/>
+                <a16:creationId xmlns:a16="http://schemas.microsoft.com/office/drawing/2014/main" id="{1C81C4AF-B769-45B9-A04A-AA6EEA8FEB7C}"/>
               </a:ext>
             </a:extLst>
           </p:cNvPr>
@@ -12801,7 +12801,7 @@
           <p:cNvPr id="15" name="">
             <a:extLst xmlns:a="http://schemas.openxmlformats.org/drawingml/2006/main">
               <a:ext uri="{FF2B5EF4-FFF2-40B4-BE49-F238E27FC236}">
-                <a16:creationId xmlns:a16="http://schemas.microsoft.com/office/drawing/2014/main" id="{C50183B4-F2DE-438D-81B8-05F850C1A475}"/>
+                <a16:creationId xmlns:a16="http://schemas.microsoft.com/office/drawing/2014/main" id="{7E121B97-8F6F-4198-8FA2-6D7A2E654CC8}"/>
               </a:ext>
             </a:extLst>
           </p:cNvPr>
@@ -12865,7 +12865,7 @@
           <p:cNvPr id="16" name="">
             <a:extLst xmlns:a="http://schemas.openxmlformats.org/drawingml/2006/main">
               <a:ext uri="{FF2B5EF4-FFF2-40B4-BE49-F238E27FC236}">
-                <a16:creationId xmlns:a16="http://schemas.microsoft.com/office/drawing/2014/main" id="{2B32C97E-B3D5-49CE-B94D-7AFAC32F786E}"/>
+                <a16:creationId xmlns:a16="http://schemas.microsoft.com/office/drawing/2014/main" id="{0EBD66CB-5AD0-47FA-927E-25E2D5566C9E}"/>
               </a:ext>
             </a:extLst>
           </p:cNvPr>
@@ -12898,7 +12898,7 @@
           <p:cNvPr id="17" name="">
             <a:extLst xmlns:a="http://schemas.openxmlformats.org/drawingml/2006/main">
               <a:ext uri="{FF2B5EF4-FFF2-40B4-BE49-F238E27FC236}">
-                <a16:creationId xmlns:a16="http://schemas.microsoft.com/office/drawing/2014/main" id="{20D2057F-DFF6-473D-849C-6E17AA6B0860}"/>
+                <a16:creationId xmlns:a16="http://schemas.microsoft.com/office/drawing/2014/main" id="{25F48C89-B740-4699-97B8-75402DCFE69D}"/>
               </a:ext>
             </a:extLst>
           </p:cNvPr>
@@ -12962,7 +12962,7 @@
           <p:cNvPr id="18" name="">
             <a:extLst xmlns:a="http://schemas.openxmlformats.org/drawingml/2006/main">
               <a:ext uri="{FF2B5EF4-FFF2-40B4-BE49-F238E27FC236}">
-                <a16:creationId xmlns:a16="http://schemas.microsoft.com/office/drawing/2014/main" id="{89BB50CF-D3F5-470D-AA73-38B110800A2F}"/>
+                <a16:creationId xmlns:a16="http://schemas.microsoft.com/office/drawing/2014/main" id="{F614F589-F2B7-4AD7-A211-92A28157EE8E}"/>
               </a:ext>
             </a:extLst>
           </p:cNvPr>
@@ -13026,7 +13026,7 @@
           <p:cNvPr id="19" name="">
             <a:extLst xmlns:a="http://schemas.openxmlformats.org/drawingml/2006/main">
               <a:ext uri="{FF2B5EF4-FFF2-40B4-BE49-F238E27FC236}">
-                <a16:creationId xmlns:a16="http://schemas.microsoft.com/office/drawing/2014/main" id="{CD6B405C-1121-4A50-8FBE-14E3B7E453F1}"/>
+                <a16:creationId xmlns:a16="http://schemas.microsoft.com/office/drawing/2014/main" id="{4A9FC424-9665-4551-AE13-FDA2A30E0549}"/>
               </a:ext>
             </a:extLst>
           </p:cNvPr>
@@ -13059,7 +13059,7 @@
           <p:cNvPr id="20" name="">
             <a:extLst xmlns:a="http://schemas.openxmlformats.org/drawingml/2006/main">
               <a:ext uri="{FF2B5EF4-FFF2-40B4-BE49-F238E27FC236}">
-                <a16:creationId xmlns:a16="http://schemas.microsoft.com/office/drawing/2014/main" id="{BA7A9D36-9AA1-4FD6-99B7-C5C278332989}"/>
+                <a16:creationId xmlns:a16="http://schemas.microsoft.com/office/drawing/2014/main" id="{2FD0F9DA-13D3-44ED-B780-4F0489FFBBCC}"/>
               </a:ext>
             </a:extLst>
           </p:cNvPr>
@@ -13123,7 +13123,7 @@
           <p:cNvPr id="21" name="">
             <a:extLst xmlns:a="http://schemas.openxmlformats.org/drawingml/2006/main">
               <a:ext uri="{FF2B5EF4-FFF2-40B4-BE49-F238E27FC236}">
-                <a16:creationId xmlns:a16="http://schemas.microsoft.com/office/drawing/2014/main" id="{5E6791D9-5C9A-4155-9FFB-44B5036A0528}"/>
+                <a16:creationId xmlns:a16="http://schemas.microsoft.com/office/drawing/2014/main" id="{9DF4A492-BCCF-473D-B717-7F148585E0AC}"/>
               </a:ext>
             </a:extLst>
           </p:cNvPr>
@@ -13185,7 +13185,7 @@
     </p:spTree>
     <p:extLst>
       <p:ext uri="{BB962C8B-B14F-4D97-AF65-F5344CB8AC3E}">
-        <p14:creationId xmlns:p14="http://schemas.microsoft.com/office/powerpoint/2010/main" val="1319033543"/>
+        <p14:creationId xmlns:p14="http://schemas.microsoft.com/office/powerpoint/2010/main" val="1743392795"/>
       </p:ext>
     </p:extLst>
   </p:cSld>
@@ -13209,7 +13209,7 @@
           <p:cNvPr id="1" name="">
             <a:extLst xmlns:a="http://schemas.openxmlformats.org/drawingml/2006/main">
               <a:ext uri="{FF2B5EF4-FFF2-40B4-BE49-F238E27FC236}">
-                <a16:creationId xmlns:a16="http://schemas.microsoft.com/office/drawing/2014/main" id="{F06F2829-4700-494F-9AB2-0EF769F29D55}"/>
+                <a16:creationId xmlns:a16="http://schemas.microsoft.com/office/drawing/2014/main" id="{4691F2F6-4E99-4824-8EA4-19032E74F96A}"/>
               </a:ext>
             </a:extLst>
           </p:cNvPr>
@@ -13244,7 +13244,7 @@
           <p:cNvPr id="2" name="">
             <a:extLst xmlns:a="http://schemas.openxmlformats.org/drawingml/2006/main">
               <a:ext uri="{FF2B5EF4-FFF2-40B4-BE49-F238E27FC236}">
-                <a16:creationId xmlns:a16="http://schemas.microsoft.com/office/drawing/2014/main" id="{991A91B2-034B-45E3-94E6-EEDD0D32FB02}"/>
+                <a16:creationId xmlns:a16="http://schemas.microsoft.com/office/drawing/2014/main" id="{587867B2-3D28-4994-9BE9-A7EFB17B2D83}"/>
               </a:ext>
             </a:extLst>
           </p:cNvPr>
@@ -13279,7 +13279,7 @@
           <p:cNvPr id="3" name="">
             <a:extLst xmlns:a="http://schemas.openxmlformats.org/drawingml/2006/main">
               <a:ext uri="{FF2B5EF4-FFF2-40B4-BE49-F238E27FC236}">
-                <a16:creationId xmlns:a16="http://schemas.microsoft.com/office/drawing/2014/main" id="{6107A644-DD30-4EAC-A173-2C2384042469}"/>
+                <a16:creationId xmlns:a16="http://schemas.microsoft.com/office/drawing/2014/main" id="{054F97CD-8D86-4802-BD93-D57B20D77C85}"/>
               </a:ext>
             </a:extLst>
           </p:cNvPr>
@@ -13314,7 +13314,7 @@
           <p:cNvPr id="4" name="kicker-3-label">
             <a:extLst xmlns:a="http://schemas.openxmlformats.org/drawingml/2006/main">
               <a:ext uri="{FF2B5EF4-FFF2-40B4-BE49-F238E27FC236}">
-                <a16:creationId xmlns:a16="http://schemas.microsoft.com/office/drawing/2014/main" id="{E0BCEBE9-8FCB-41C2-A89E-586868DB8CE0}"/>
+                <a16:creationId xmlns:a16="http://schemas.microsoft.com/office/drawing/2014/main" id="{4C0AD3E6-7E8F-4A42-A9E1-E9EF7C5BD16F}"/>
               </a:ext>
             </a:extLst>
           </p:cNvPr>
@@ -13378,7 +13378,7 @@
           <p:cNvPr id="5" name="">
             <a:extLst xmlns:a="http://schemas.openxmlformats.org/drawingml/2006/main">
               <a:ext uri="{FF2B5EF4-FFF2-40B4-BE49-F238E27FC236}">
-                <a16:creationId xmlns:a16="http://schemas.microsoft.com/office/drawing/2014/main" id="{CD9B4D50-4224-400B-AED1-3FA33196C19B}"/>
+                <a16:creationId xmlns:a16="http://schemas.microsoft.com/office/drawing/2014/main" id="{03A858D0-883C-4AA1-9F07-C8BA3F18EDF3}"/>
               </a:ext>
             </a:extLst>
           </p:cNvPr>
@@ -13442,7 +13442,7 @@
           <p:cNvPr id="6" name="">
             <a:extLst xmlns:a="http://schemas.openxmlformats.org/drawingml/2006/main">
               <a:ext uri="{FF2B5EF4-FFF2-40B4-BE49-F238E27FC236}">
-                <a16:creationId xmlns:a16="http://schemas.microsoft.com/office/drawing/2014/main" id="{9998874B-EF86-427F-BCA7-FDC1FEE9686B}"/>
+                <a16:creationId xmlns:a16="http://schemas.microsoft.com/office/drawing/2014/main" id="{975D1B5F-7878-43D4-93AD-FD016872A3C3}"/>
               </a:ext>
             </a:extLst>
           </p:cNvPr>
@@ -13506,7 +13506,7 @@
           <p:cNvPr id="7" name="">
             <a:extLst xmlns:a="http://schemas.openxmlformats.org/drawingml/2006/main">
               <a:ext uri="{FF2B5EF4-FFF2-40B4-BE49-F238E27FC236}">
-                <a16:creationId xmlns:a16="http://schemas.microsoft.com/office/drawing/2014/main" id="{52D8CBF4-25F4-4871-AFB4-3304AF3C0396}"/>
+                <a16:creationId xmlns:a16="http://schemas.microsoft.com/office/drawing/2014/main" id="{EAAB83F8-145E-49D8-B14F-0394EE5F8F90}"/>
               </a:ext>
             </a:extLst>
           </p:cNvPr>
@@ -13541,7 +13541,7 @@
           <p:cNvPr id="8" name="">
             <a:extLst xmlns:a="http://schemas.openxmlformats.org/drawingml/2006/main">
               <a:ext uri="{FF2B5EF4-FFF2-40B4-BE49-F238E27FC236}">
-                <a16:creationId xmlns:a16="http://schemas.microsoft.com/office/drawing/2014/main" id="{665E4DC2-EDD7-4981-A695-8C67C07E28EF}"/>
+                <a16:creationId xmlns:a16="http://schemas.microsoft.com/office/drawing/2014/main" id="{026E6F50-0493-46EE-8A25-89A8AD024BFA}"/>
               </a:ext>
             </a:extLst>
           </p:cNvPr>
@@ -13605,7 +13605,7 @@
           <p:cNvPr id="9" name="">
             <a:extLst xmlns:a="http://schemas.openxmlformats.org/drawingml/2006/main">
               <a:ext uri="{FF2B5EF4-FFF2-40B4-BE49-F238E27FC236}">
-                <a16:creationId xmlns:a16="http://schemas.microsoft.com/office/drawing/2014/main" id="{C326508D-652B-4B58-B4EF-61C5D2D2D1D9}"/>
+                <a16:creationId xmlns:a16="http://schemas.microsoft.com/office/drawing/2014/main" id="{2065266B-706A-4A29-A8A0-1F9A83FB4A61}"/>
               </a:ext>
             </a:extLst>
           </p:cNvPr>
@@ -13640,7 +13640,7 @@
           <p:cNvPr id="10" name="">
             <a:extLst xmlns:a="http://schemas.openxmlformats.org/drawingml/2006/main">
               <a:ext uri="{FF2B5EF4-FFF2-40B4-BE49-F238E27FC236}">
-                <a16:creationId xmlns:a16="http://schemas.microsoft.com/office/drawing/2014/main" id="{4E13798E-A5B6-4D08-88B6-380DAC43A5CA}"/>
+                <a16:creationId xmlns:a16="http://schemas.microsoft.com/office/drawing/2014/main" id="{7B27D596-A780-4FCF-B019-50EDE94C1742}"/>
               </a:ext>
             </a:extLst>
           </p:cNvPr>
@@ -13704,7 +13704,7 @@
           <p:cNvPr id="11" name="">
             <a:extLst xmlns:a="http://schemas.openxmlformats.org/drawingml/2006/main">
               <a:ext uri="{FF2B5EF4-FFF2-40B4-BE49-F238E27FC236}">
-                <a16:creationId xmlns:a16="http://schemas.microsoft.com/office/drawing/2014/main" id="{1E34759E-833C-4EBB-A99E-58127042B7D5}"/>
+                <a16:creationId xmlns:a16="http://schemas.microsoft.com/office/drawing/2014/main" id="{502995D1-B3E0-4EF5-848F-3E09965E9EDF}"/>
               </a:ext>
             </a:extLst>
           </p:cNvPr>
@@ -13739,7 +13739,7 @@
           <p:cNvPr id="12" name="">
             <a:extLst xmlns:a="http://schemas.openxmlformats.org/drawingml/2006/main">
               <a:ext uri="{FF2B5EF4-FFF2-40B4-BE49-F238E27FC236}">
-                <a16:creationId xmlns:a16="http://schemas.microsoft.com/office/drawing/2014/main" id="{013096B0-70ED-4234-92D3-01098892C535}"/>
+                <a16:creationId xmlns:a16="http://schemas.microsoft.com/office/drawing/2014/main" id="{1E8ECA01-3F9D-4DB1-95D7-7DE57DC93035}"/>
               </a:ext>
             </a:extLst>
           </p:cNvPr>
@@ -13803,7 +13803,7 @@
           <p:cNvPr id="13" name="">
             <a:extLst xmlns:a="http://schemas.openxmlformats.org/drawingml/2006/main">
               <a:ext uri="{FF2B5EF4-FFF2-40B4-BE49-F238E27FC236}">
-                <a16:creationId xmlns:a16="http://schemas.microsoft.com/office/drawing/2014/main" id="{E59F8876-710A-4B88-B2A3-156D77CC8CC9}"/>
+                <a16:creationId xmlns:a16="http://schemas.microsoft.com/office/drawing/2014/main" id="{F5A92C86-245D-4FA7-A247-2BAB91C4F1DA}"/>
               </a:ext>
             </a:extLst>
           </p:cNvPr>
@@ -13836,7 +13836,7 @@
           <p:cNvPr id="14" name="">
             <a:extLst xmlns:a="http://schemas.openxmlformats.org/drawingml/2006/main">
               <a:ext uri="{FF2B5EF4-FFF2-40B4-BE49-F238E27FC236}">
-                <a16:creationId xmlns:a16="http://schemas.microsoft.com/office/drawing/2014/main" id="{47CA8FC4-7BD6-4AD9-87C3-442CE3E4D45E}"/>
+                <a16:creationId xmlns:a16="http://schemas.microsoft.com/office/drawing/2014/main" id="{BD90DA1F-206C-4771-9BA9-FCF4880FFB63}"/>
               </a:ext>
             </a:extLst>
           </p:cNvPr>
@@ -13900,7 +13900,7 @@
           <p:cNvPr id="15" name="">
             <a:extLst xmlns:a="http://schemas.openxmlformats.org/drawingml/2006/main">
               <a:ext uri="{FF2B5EF4-FFF2-40B4-BE49-F238E27FC236}">
-                <a16:creationId xmlns:a16="http://schemas.microsoft.com/office/drawing/2014/main" id="{35100BB9-0F6D-40E3-B515-626F508F3A61}"/>
+                <a16:creationId xmlns:a16="http://schemas.microsoft.com/office/drawing/2014/main" id="{8D02DE6A-6E94-484C-B8A1-E4AE9F4F9810}"/>
               </a:ext>
             </a:extLst>
           </p:cNvPr>
@@ -13964,7 +13964,7 @@
           <p:cNvPr id="16" name="">
             <a:extLst xmlns:a="http://schemas.openxmlformats.org/drawingml/2006/main">
               <a:ext uri="{FF2B5EF4-FFF2-40B4-BE49-F238E27FC236}">
-                <a16:creationId xmlns:a16="http://schemas.microsoft.com/office/drawing/2014/main" id="{65335CA9-9654-4AA4-ADF7-82A1A39E1BA3}"/>
+                <a16:creationId xmlns:a16="http://schemas.microsoft.com/office/drawing/2014/main" id="{9719D2F1-627C-4AFA-94D8-17964EB82CB9}"/>
               </a:ext>
             </a:extLst>
           </p:cNvPr>
@@ -13997,7 +13997,7 @@
           <p:cNvPr id="17" name="">
             <a:extLst xmlns:a="http://schemas.openxmlformats.org/drawingml/2006/main">
               <a:ext uri="{FF2B5EF4-FFF2-40B4-BE49-F238E27FC236}">
-                <a16:creationId xmlns:a16="http://schemas.microsoft.com/office/drawing/2014/main" id="{143B7C96-0201-4286-89D0-1463A7ECF998}"/>
+                <a16:creationId xmlns:a16="http://schemas.microsoft.com/office/drawing/2014/main" id="{783DE76A-8183-4A54-BFD4-C7217E4EC2F5}"/>
               </a:ext>
             </a:extLst>
           </p:cNvPr>
@@ -14061,7 +14061,7 @@
           <p:cNvPr id="18" name="">
             <a:extLst xmlns:a="http://schemas.openxmlformats.org/drawingml/2006/main">
               <a:ext uri="{FF2B5EF4-FFF2-40B4-BE49-F238E27FC236}">
-                <a16:creationId xmlns:a16="http://schemas.microsoft.com/office/drawing/2014/main" id="{5A406FEF-08D3-4A12-83B9-DDE51BBB9A00}"/>
+                <a16:creationId xmlns:a16="http://schemas.microsoft.com/office/drawing/2014/main" id="{B745245E-CA41-4E8F-B531-962D294CC7E1}"/>
               </a:ext>
             </a:extLst>
           </p:cNvPr>
@@ -14125,7 +14125,7 @@
           <p:cNvPr id="19" name="">
             <a:extLst xmlns:a="http://schemas.openxmlformats.org/drawingml/2006/main">
               <a:ext uri="{FF2B5EF4-FFF2-40B4-BE49-F238E27FC236}">
-                <a16:creationId xmlns:a16="http://schemas.microsoft.com/office/drawing/2014/main" id="{AB5924F0-79FE-4567-9B6F-245F40923135}"/>
+                <a16:creationId xmlns:a16="http://schemas.microsoft.com/office/drawing/2014/main" id="{0014A1F1-F346-4409-A8E5-910983E4964F}"/>
               </a:ext>
             </a:extLst>
           </p:cNvPr>
@@ -14158,7 +14158,7 @@
           <p:cNvPr id="20" name="">
             <a:extLst xmlns:a="http://schemas.openxmlformats.org/drawingml/2006/main">
               <a:ext uri="{FF2B5EF4-FFF2-40B4-BE49-F238E27FC236}">
-                <a16:creationId xmlns:a16="http://schemas.microsoft.com/office/drawing/2014/main" id="{43AD9F8C-08BD-4532-835D-7996C93B8641}"/>
+                <a16:creationId xmlns:a16="http://schemas.microsoft.com/office/drawing/2014/main" id="{176B5DB1-4EED-448B-A9AE-C095E55EBCEA}"/>
               </a:ext>
             </a:extLst>
           </p:cNvPr>
@@ -14222,7 +14222,7 @@
           <p:cNvPr id="21" name="">
             <a:extLst xmlns:a="http://schemas.openxmlformats.org/drawingml/2006/main">
               <a:ext uri="{FF2B5EF4-FFF2-40B4-BE49-F238E27FC236}">
-                <a16:creationId xmlns:a16="http://schemas.microsoft.com/office/drawing/2014/main" id="{FFD68075-94E1-4AFE-8073-638A45BC7F26}"/>
+                <a16:creationId xmlns:a16="http://schemas.microsoft.com/office/drawing/2014/main" id="{6BA5DE8F-A02D-4A3E-B88D-CDF232FD9184}"/>
               </a:ext>
             </a:extLst>
           </p:cNvPr>
@@ -14284,7 +14284,7 @@
     </p:spTree>
     <p:extLst>
       <p:ext uri="{BB962C8B-B14F-4D97-AF65-F5344CB8AC3E}">
-        <p14:creationId xmlns:p14="http://schemas.microsoft.com/office/powerpoint/2010/main" val="1668992986"/>
+        <p14:creationId xmlns:p14="http://schemas.microsoft.com/office/powerpoint/2010/main" val="1301372635"/>
       </p:ext>
     </p:extLst>
   </p:cSld>
@@ -14308,7 +14308,7 @@
           <p:cNvPr id="1" name="">
             <a:extLst xmlns:a="http://schemas.openxmlformats.org/drawingml/2006/main">
               <a:ext uri="{FF2B5EF4-FFF2-40B4-BE49-F238E27FC236}">
-                <a16:creationId xmlns:a16="http://schemas.microsoft.com/office/drawing/2014/main" id="{5682A653-7933-48ED-9E8B-99A8ACFA1DC6}"/>
+                <a16:creationId xmlns:a16="http://schemas.microsoft.com/office/drawing/2014/main" id="{A269024F-B8E3-48B0-BF31-CADA46DB9D1D}"/>
               </a:ext>
             </a:extLst>
           </p:cNvPr>
@@ -14343,7 +14343,7 @@
           <p:cNvPr id="2" name="">
             <a:extLst xmlns:a="http://schemas.openxmlformats.org/drawingml/2006/main">
               <a:ext uri="{FF2B5EF4-FFF2-40B4-BE49-F238E27FC236}">
-                <a16:creationId xmlns:a16="http://schemas.microsoft.com/office/drawing/2014/main" id="{2CD3388A-A321-4C7D-BCA7-78460A80AE8C}"/>
+                <a16:creationId xmlns:a16="http://schemas.microsoft.com/office/drawing/2014/main" id="{34A43DD9-A9E7-460D-98C8-FA1FE48F8EEE}"/>
               </a:ext>
             </a:extLst>
           </p:cNvPr>
@@ -14378,7 +14378,7 @@
           <p:cNvPr id="3" name="">
             <a:extLst xmlns:a="http://schemas.openxmlformats.org/drawingml/2006/main">
               <a:ext uri="{FF2B5EF4-FFF2-40B4-BE49-F238E27FC236}">
-                <a16:creationId xmlns:a16="http://schemas.microsoft.com/office/drawing/2014/main" id="{DF4437AD-8CBE-48E2-99ED-AB000F6ED9C3}"/>
+                <a16:creationId xmlns:a16="http://schemas.microsoft.com/office/drawing/2014/main" id="{C04F96EE-75EE-4F0D-A77F-0774A1A53E20}"/>
               </a:ext>
             </a:extLst>
           </p:cNvPr>
@@ -14413,7 +14413,7 @@
           <p:cNvPr id="4" name="kicker-4-label">
             <a:extLst xmlns:a="http://schemas.openxmlformats.org/drawingml/2006/main">
               <a:ext uri="{FF2B5EF4-FFF2-40B4-BE49-F238E27FC236}">
-                <a16:creationId xmlns:a16="http://schemas.microsoft.com/office/drawing/2014/main" id="{6109B01B-6DC8-4B3D-8531-BC43F18CAD4F}"/>
+                <a16:creationId xmlns:a16="http://schemas.microsoft.com/office/drawing/2014/main" id="{0A5BDFAA-5C22-4D27-A1A7-C0F1E8D96FE4}"/>
               </a:ext>
             </a:extLst>
           </p:cNvPr>
@@ -14477,7 +14477,7 @@
           <p:cNvPr id="5" name="">
             <a:extLst xmlns:a="http://schemas.openxmlformats.org/drawingml/2006/main">
               <a:ext uri="{FF2B5EF4-FFF2-40B4-BE49-F238E27FC236}">
-                <a16:creationId xmlns:a16="http://schemas.microsoft.com/office/drawing/2014/main" id="{2E7B36E2-E838-43A7-8461-B4BF26DAA416}"/>
+                <a16:creationId xmlns:a16="http://schemas.microsoft.com/office/drawing/2014/main" id="{AE95B04F-4E39-4D51-9D28-1B5CB5514E73}"/>
               </a:ext>
             </a:extLst>
           </p:cNvPr>
@@ -14541,7 +14541,7 @@
           <p:cNvPr id="6" name="">
             <a:extLst xmlns:a="http://schemas.openxmlformats.org/drawingml/2006/main">
               <a:ext uri="{FF2B5EF4-FFF2-40B4-BE49-F238E27FC236}">
-                <a16:creationId xmlns:a16="http://schemas.microsoft.com/office/drawing/2014/main" id="{22E421D5-536D-48CC-A0BB-3C7D5167358B}"/>
+                <a16:creationId xmlns:a16="http://schemas.microsoft.com/office/drawing/2014/main" id="{D5762D4F-FB51-4719-B58B-B35BD2C1FF80}"/>
               </a:ext>
             </a:extLst>
           </p:cNvPr>
@@ -14605,7 +14605,7 @@
           <p:cNvPr id="7" name="">
             <a:extLst xmlns:a="http://schemas.openxmlformats.org/drawingml/2006/main">
               <a:ext uri="{FF2B5EF4-FFF2-40B4-BE49-F238E27FC236}">
-                <a16:creationId xmlns:a16="http://schemas.microsoft.com/office/drawing/2014/main" id="{075EEC91-B431-4487-B75A-F2AAC2F0939E}"/>
+                <a16:creationId xmlns:a16="http://schemas.microsoft.com/office/drawing/2014/main" id="{D7F74D67-7ECB-43A8-918C-D1F56F5D984D}"/>
               </a:ext>
             </a:extLst>
           </p:cNvPr>
@@ -14640,7 +14640,7 @@
           <p:cNvPr id="8" name="">
             <a:extLst xmlns:a="http://schemas.openxmlformats.org/drawingml/2006/main">
               <a:ext uri="{FF2B5EF4-FFF2-40B4-BE49-F238E27FC236}">
-                <a16:creationId xmlns:a16="http://schemas.microsoft.com/office/drawing/2014/main" id="{E95DBFAE-261E-4357-A713-F2A6CE1626B0}"/>
+                <a16:creationId xmlns:a16="http://schemas.microsoft.com/office/drawing/2014/main" id="{7534387F-1A70-455C-9645-18A09C65A382}"/>
               </a:ext>
             </a:extLst>
           </p:cNvPr>
@@ -14704,7 +14704,7 @@
           <p:cNvPr id="9" name="">
             <a:extLst xmlns:a="http://schemas.openxmlformats.org/drawingml/2006/main">
               <a:ext uri="{FF2B5EF4-FFF2-40B4-BE49-F238E27FC236}">
-                <a16:creationId xmlns:a16="http://schemas.microsoft.com/office/drawing/2014/main" id="{BDF3549F-BE37-4BC2-96DD-A71733C08A96}"/>
+                <a16:creationId xmlns:a16="http://schemas.microsoft.com/office/drawing/2014/main" id="{4A8763F3-04A2-409C-BE81-2C1A2106A8E1}"/>
               </a:ext>
             </a:extLst>
           </p:cNvPr>
@@ -14739,7 +14739,7 @@
           <p:cNvPr id="10" name="">
             <a:extLst xmlns:a="http://schemas.openxmlformats.org/drawingml/2006/main">
               <a:ext uri="{FF2B5EF4-FFF2-40B4-BE49-F238E27FC236}">
-                <a16:creationId xmlns:a16="http://schemas.microsoft.com/office/drawing/2014/main" id="{5EECD15F-3331-4128-AA19-15E63F38CCEC}"/>
+                <a16:creationId xmlns:a16="http://schemas.microsoft.com/office/drawing/2014/main" id="{28B682E1-F876-48A4-9784-0AA4329EA8B6}"/>
               </a:ext>
             </a:extLst>
           </p:cNvPr>
@@ -14803,7 +14803,7 @@
           <p:cNvPr id="11" name="">
             <a:extLst xmlns:a="http://schemas.openxmlformats.org/drawingml/2006/main">
               <a:ext uri="{FF2B5EF4-FFF2-40B4-BE49-F238E27FC236}">
-                <a16:creationId xmlns:a16="http://schemas.microsoft.com/office/drawing/2014/main" id="{01D9BFCB-F03C-45AC-88F0-44124C0BE22F}"/>
+                <a16:creationId xmlns:a16="http://schemas.microsoft.com/office/drawing/2014/main" id="{3A2BA406-93CF-4551-9E19-28FE55C0F45B}"/>
               </a:ext>
             </a:extLst>
           </p:cNvPr>
@@ -14838,7 +14838,7 @@
           <p:cNvPr id="12" name="">
             <a:extLst xmlns:a="http://schemas.openxmlformats.org/drawingml/2006/main">
               <a:ext uri="{FF2B5EF4-FFF2-40B4-BE49-F238E27FC236}">
-                <a16:creationId xmlns:a16="http://schemas.microsoft.com/office/drawing/2014/main" id="{D61C581A-B159-4A3E-8EE6-38DC33E205BE}"/>
+                <a16:creationId xmlns:a16="http://schemas.microsoft.com/office/drawing/2014/main" id="{43DE7BAA-CADA-4FEF-9899-245307978225}"/>
               </a:ext>
             </a:extLst>
           </p:cNvPr>
@@ -14902,7 +14902,7 @@
           <p:cNvPr id="13" name="">
             <a:extLst xmlns:a="http://schemas.openxmlformats.org/drawingml/2006/main">
               <a:ext uri="{FF2B5EF4-FFF2-40B4-BE49-F238E27FC236}">
-                <a16:creationId xmlns:a16="http://schemas.microsoft.com/office/drawing/2014/main" id="{FCC20DC7-0003-409B-AE0B-0045414CF1FC}"/>
+                <a16:creationId xmlns:a16="http://schemas.microsoft.com/office/drawing/2014/main" id="{8A769546-0F4D-4655-B062-C98020120C85}"/>
               </a:ext>
             </a:extLst>
           </p:cNvPr>
@@ -14935,7 +14935,7 @@
           <p:cNvPr id="14" name="">
             <a:extLst xmlns:a="http://schemas.openxmlformats.org/drawingml/2006/main">
               <a:ext uri="{FF2B5EF4-FFF2-40B4-BE49-F238E27FC236}">
-                <a16:creationId xmlns:a16="http://schemas.microsoft.com/office/drawing/2014/main" id="{843636B3-60ED-45CC-A5F2-7E1A4EAF5A62}"/>
+                <a16:creationId xmlns:a16="http://schemas.microsoft.com/office/drawing/2014/main" id="{4820561A-3186-4BDB-9DDD-FF306D2395CA}"/>
               </a:ext>
             </a:extLst>
           </p:cNvPr>
@@ -14999,7 +14999,7 @@
           <p:cNvPr id="15" name="">
             <a:extLst xmlns:a="http://schemas.openxmlformats.org/drawingml/2006/main">
               <a:ext uri="{FF2B5EF4-FFF2-40B4-BE49-F238E27FC236}">
-                <a16:creationId xmlns:a16="http://schemas.microsoft.com/office/drawing/2014/main" id="{A5D37212-666F-42D4-AC42-F90C570E0C41}"/>
+                <a16:creationId xmlns:a16="http://schemas.microsoft.com/office/drawing/2014/main" id="{FDAA47E7-68B7-4423-B20A-9E001595B857}"/>
               </a:ext>
             </a:extLst>
           </p:cNvPr>
@@ -15053,7 +15053,7 @@
                 <a:ea typeface="Arial"/>
                 <a:cs typeface="Arial"/>
               </a:rPr>
-              <a:t>linha de visada e conferência item a item</a:t>
+              <a:t>de conferência visual item a item</a:t>
             </a:r>
           </a:p>
         </p:txBody>
@@ -15063,7 +15063,7 @@
           <p:cNvPr id="16" name="">
             <a:extLst xmlns:a="http://schemas.openxmlformats.org/drawingml/2006/main">
               <a:ext uri="{FF2B5EF4-FFF2-40B4-BE49-F238E27FC236}">
-                <a16:creationId xmlns:a16="http://schemas.microsoft.com/office/drawing/2014/main" id="{41A5C573-7709-407C-9003-F4594B0A9B57}"/>
+                <a16:creationId xmlns:a16="http://schemas.microsoft.com/office/drawing/2014/main" id="{685F7988-B5C6-450A-9F93-85F84633C9C9}"/>
               </a:ext>
             </a:extLst>
           </p:cNvPr>
@@ -15096,7 +15096,7 @@
           <p:cNvPr id="17" name="">
             <a:extLst xmlns:a="http://schemas.openxmlformats.org/drawingml/2006/main">
               <a:ext uri="{FF2B5EF4-FFF2-40B4-BE49-F238E27FC236}">
-                <a16:creationId xmlns:a16="http://schemas.microsoft.com/office/drawing/2014/main" id="{30854912-4823-41B9-9C11-9CC7E8E72DA5}"/>
+                <a16:creationId xmlns:a16="http://schemas.microsoft.com/office/drawing/2014/main" id="{43D552CF-0CE9-4DDB-A2B7-3519106EFA79}"/>
               </a:ext>
             </a:extLst>
           </p:cNvPr>
@@ -15160,7 +15160,7 @@
           <p:cNvPr id="18" name="">
             <a:extLst xmlns:a="http://schemas.openxmlformats.org/drawingml/2006/main">
               <a:ext uri="{FF2B5EF4-FFF2-40B4-BE49-F238E27FC236}">
-                <a16:creationId xmlns:a16="http://schemas.microsoft.com/office/drawing/2014/main" id="{4F956515-99A7-445C-827D-C73136A4D8AF}"/>
+                <a16:creationId xmlns:a16="http://schemas.microsoft.com/office/drawing/2014/main" id="{42F0719D-520F-48B8-B5DE-EBFC290D6BB6}"/>
               </a:ext>
             </a:extLst>
           </p:cNvPr>
@@ -15214,7 +15214,7 @@
                 <a:ea typeface="Arial"/>
                 <a:cs typeface="Arial"/>
               </a:rPr>
-              <a:t>histórico, auditoria e inconsistências</a:t>
+              <a:t>com histórico e auditoria por evento</a:t>
             </a:r>
           </a:p>
         </p:txBody>
@@ -15224,7 +15224,7 @@
           <p:cNvPr id="19" name="">
             <a:extLst xmlns:a="http://schemas.openxmlformats.org/drawingml/2006/main">
               <a:ext uri="{FF2B5EF4-FFF2-40B4-BE49-F238E27FC236}">
-                <a16:creationId xmlns:a16="http://schemas.microsoft.com/office/drawing/2014/main" id="{896F317D-7BAB-4FFF-9927-2F1BDF426DDF}"/>
+                <a16:creationId xmlns:a16="http://schemas.microsoft.com/office/drawing/2014/main" id="{12CCDD70-16A5-40B4-A93F-0A289D667B75}"/>
               </a:ext>
             </a:extLst>
           </p:cNvPr>
@@ -15257,7 +15257,7 @@
           <p:cNvPr id="20" name="">
             <a:extLst xmlns:a="http://schemas.openxmlformats.org/drawingml/2006/main">
               <a:ext uri="{FF2B5EF4-FFF2-40B4-BE49-F238E27FC236}">
-                <a16:creationId xmlns:a16="http://schemas.microsoft.com/office/drawing/2014/main" id="{9583D764-6739-4BCC-ACDE-02B29955FE6A}"/>
+                <a16:creationId xmlns:a16="http://schemas.microsoft.com/office/drawing/2014/main" id="{92B70AEA-A3E3-4E98-8322-5EF9F73B243C}"/>
               </a:ext>
             </a:extLst>
           </p:cNvPr>
@@ -15321,7 +15321,7 @@
           <p:cNvPr id="21" name="">
             <a:extLst xmlns:a="http://schemas.openxmlformats.org/drawingml/2006/main">
               <a:ext uri="{FF2B5EF4-FFF2-40B4-BE49-F238E27FC236}">
-                <a16:creationId xmlns:a16="http://schemas.microsoft.com/office/drawing/2014/main" id="{C601DEDA-DA13-4928-A0D3-F3E733227160}"/>
+                <a16:creationId xmlns:a16="http://schemas.microsoft.com/office/drawing/2014/main" id="{2C0B9707-18E5-413F-84EE-4C716DCC80EE}"/>
               </a:ext>
             </a:extLst>
           </p:cNvPr>
@@ -15375,7 +15375,7 @@
                 <a:ea typeface="Arial"/>
                 <a:cs typeface="Arial"/>
               </a:rPr>
-              <a:t>sem extrapolar alcance ou leitura simultânea</a:t>
+              <a:t>sem extrapolar alcance físico</a:t>
             </a:r>
           </a:p>
         </p:txBody>
@@ -15383,7 +15383,7 @@
     </p:spTree>
     <p:extLst>
       <p:ext uri="{BB962C8B-B14F-4D97-AF65-F5344CB8AC3E}">
-        <p14:creationId xmlns:p14="http://schemas.microsoft.com/office/powerpoint/2010/main" val="1771763336"/>
+        <p14:creationId xmlns:p14="http://schemas.microsoft.com/office/powerpoint/2010/main" val="1320552648"/>
       </p:ext>
     </p:extLst>
   </p:cSld>
@@ -15407,7 +15407,7 @@
           <p:cNvPr id="1" name="">
             <a:extLst xmlns:a="http://schemas.openxmlformats.org/drawingml/2006/main">
               <a:ext uri="{FF2B5EF4-FFF2-40B4-BE49-F238E27FC236}">
-                <a16:creationId xmlns:a16="http://schemas.microsoft.com/office/drawing/2014/main" id="{C07449A2-7D7E-48C2-9FEE-734F7D00C4E3}"/>
+                <a16:creationId xmlns:a16="http://schemas.microsoft.com/office/drawing/2014/main" id="{F8473816-01DC-46AF-A4AF-B016BC4AC8C3}"/>
               </a:ext>
             </a:extLst>
           </p:cNvPr>
@@ -15442,7 +15442,7 @@
           <p:cNvPr id="2" name="">
             <a:extLst xmlns:a="http://schemas.openxmlformats.org/drawingml/2006/main">
               <a:ext uri="{FF2B5EF4-FFF2-40B4-BE49-F238E27FC236}">
-                <a16:creationId xmlns:a16="http://schemas.microsoft.com/office/drawing/2014/main" id="{B4D76861-8FF7-4123-9402-46FD0E0BC1BA}"/>
+                <a16:creationId xmlns:a16="http://schemas.microsoft.com/office/drawing/2014/main" id="{D31AE9C5-B404-4B9F-BB74-602847A5B88E}"/>
               </a:ext>
             </a:extLst>
           </p:cNvPr>
@@ -15477,7 +15477,7 @@
           <p:cNvPr id="3" name="">
             <a:extLst xmlns:a="http://schemas.openxmlformats.org/drawingml/2006/main">
               <a:ext uri="{FF2B5EF4-FFF2-40B4-BE49-F238E27FC236}">
-                <a16:creationId xmlns:a16="http://schemas.microsoft.com/office/drawing/2014/main" id="{F505338C-4D07-4035-BAFB-FE647F680048}"/>
+                <a16:creationId xmlns:a16="http://schemas.microsoft.com/office/drawing/2014/main" id="{EAB931F4-EFC3-417F-A237-672CCC8E309A}"/>
               </a:ext>
             </a:extLst>
           </p:cNvPr>
@@ -15512,7 +15512,7 @@
           <p:cNvPr id="4" name="kicker-5-label">
             <a:extLst xmlns:a="http://schemas.openxmlformats.org/drawingml/2006/main">
               <a:ext uri="{FF2B5EF4-FFF2-40B4-BE49-F238E27FC236}">
-                <a16:creationId xmlns:a16="http://schemas.microsoft.com/office/drawing/2014/main" id="{8FF2698A-BC89-4D04-BF6E-D4531B72DE00}"/>
+                <a16:creationId xmlns:a16="http://schemas.microsoft.com/office/drawing/2014/main" id="{CB53EB09-8532-41F7-8084-12902B584AEE}"/>
               </a:ext>
             </a:extLst>
           </p:cNvPr>
@@ -15576,7 +15576,7 @@
           <p:cNvPr id="5" name="">
             <a:extLst xmlns:a="http://schemas.openxmlformats.org/drawingml/2006/main">
               <a:ext uri="{FF2B5EF4-FFF2-40B4-BE49-F238E27FC236}">
-                <a16:creationId xmlns:a16="http://schemas.microsoft.com/office/drawing/2014/main" id="{423F18EB-38A1-453C-8173-44362C4A62CF}"/>
+                <a16:creationId xmlns:a16="http://schemas.microsoft.com/office/drawing/2014/main" id="{AD412528-65A1-4D2B-9AD6-B0A5E8AE4E2F}"/>
               </a:ext>
             </a:extLst>
           </p:cNvPr>
@@ -15640,7 +15640,7 @@
           <p:cNvPr id="6" name="">
             <a:extLst xmlns:a="http://schemas.openxmlformats.org/drawingml/2006/main">
               <a:ext uri="{FF2B5EF4-FFF2-40B4-BE49-F238E27FC236}">
-                <a16:creationId xmlns:a16="http://schemas.microsoft.com/office/drawing/2014/main" id="{735AF56D-3E94-4211-8F22-D659DF653C06}"/>
+                <a16:creationId xmlns:a16="http://schemas.microsoft.com/office/drawing/2014/main" id="{35231A09-634A-425E-B306-6C74EC5E1249}"/>
               </a:ext>
             </a:extLst>
           </p:cNvPr>
@@ -15704,7 +15704,7 @@
           <p:cNvPr id="7" name="">
             <a:extLst xmlns:a="http://schemas.openxmlformats.org/drawingml/2006/main">
               <a:ext uri="{FF2B5EF4-FFF2-40B4-BE49-F238E27FC236}">
-                <a16:creationId xmlns:a16="http://schemas.microsoft.com/office/drawing/2014/main" id="{E6AC2719-DA4E-459D-A7B7-8C8627371868}"/>
+                <a16:creationId xmlns:a16="http://schemas.microsoft.com/office/drawing/2014/main" id="{6DCFE402-CA74-4125-9C36-AE1C82A1F937}"/>
               </a:ext>
             </a:extLst>
           </p:cNvPr>
@@ -15739,7 +15739,7 @@
           <p:cNvPr id="8" name="">
             <a:extLst xmlns:a="http://schemas.openxmlformats.org/drawingml/2006/main">
               <a:ext uri="{FF2B5EF4-FFF2-40B4-BE49-F238E27FC236}">
-                <a16:creationId xmlns:a16="http://schemas.microsoft.com/office/drawing/2014/main" id="{1A17CBBC-F820-4361-88BC-13B9711AFAAA}"/>
+                <a16:creationId xmlns:a16="http://schemas.microsoft.com/office/drawing/2014/main" id="{35C07D33-E4AD-4B47-BE8F-CEDD99CE1D52}"/>
               </a:ext>
             </a:extLst>
           </p:cNvPr>
@@ -15803,7 +15803,7 @@
           <p:cNvPr id="9" name="">
             <a:extLst xmlns:a="http://schemas.openxmlformats.org/drawingml/2006/main">
               <a:ext uri="{FF2B5EF4-FFF2-40B4-BE49-F238E27FC236}">
-                <a16:creationId xmlns:a16="http://schemas.microsoft.com/office/drawing/2014/main" id="{A5D87CBA-4A41-4D96-ADFF-F068644A9D2A}"/>
+                <a16:creationId xmlns:a16="http://schemas.microsoft.com/office/drawing/2014/main" id="{4C323495-CED3-4156-821A-BA7F5A0D736E}"/>
               </a:ext>
             </a:extLst>
           </p:cNvPr>
@@ -15838,7 +15838,7 @@
           <p:cNvPr id="10" name="">
             <a:extLst xmlns:a="http://schemas.openxmlformats.org/drawingml/2006/main">
               <a:ext uri="{FF2B5EF4-FFF2-40B4-BE49-F238E27FC236}">
-                <a16:creationId xmlns:a16="http://schemas.microsoft.com/office/drawing/2014/main" id="{A0322CAE-1A3A-4F02-83AE-E648CD319C4B}"/>
+                <a16:creationId xmlns:a16="http://schemas.microsoft.com/office/drawing/2014/main" id="{8246E8C3-57C1-4B31-BF9C-F955188875A7}"/>
               </a:ext>
             </a:extLst>
           </p:cNvPr>
@@ -15902,7 +15902,7 @@
           <p:cNvPr id="11" name="">
             <a:extLst xmlns:a="http://schemas.openxmlformats.org/drawingml/2006/main">
               <a:ext uri="{FF2B5EF4-FFF2-40B4-BE49-F238E27FC236}">
-                <a16:creationId xmlns:a16="http://schemas.microsoft.com/office/drawing/2014/main" id="{DC330C25-4282-4158-987F-3389117651E6}"/>
+                <a16:creationId xmlns:a16="http://schemas.microsoft.com/office/drawing/2014/main" id="{334306AA-ECE8-40D0-BA7C-EB0A14AD388C}"/>
               </a:ext>
             </a:extLst>
           </p:cNvPr>
@@ -15937,7 +15937,7 @@
           <p:cNvPr id="12" name="">
             <a:extLst xmlns:a="http://schemas.openxmlformats.org/drawingml/2006/main">
               <a:ext uri="{FF2B5EF4-FFF2-40B4-BE49-F238E27FC236}">
-                <a16:creationId xmlns:a16="http://schemas.microsoft.com/office/drawing/2014/main" id="{61254F03-8A63-4DD6-97F6-AC0D43DB203D}"/>
+                <a16:creationId xmlns:a16="http://schemas.microsoft.com/office/drawing/2014/main" id="{9710CB6D-7B8D-4601-A3D0-A20B78078045}"/>
               </a:ext>
             </a:extLst>
           </p:cNvPr>
@@ -16001,7 +16001,7 @@
           <p:cNvPr id="13" name="">
             <a:extLst xmlns:a="http://schemas.openxmlformats.org/drawingml/2006/main">
               <a:ext uri="{FF2B5EF4-FFF2-40B4-BE49-F238E27FC236}">
-                <a16:creationId xmlns:a16="http://schemas.microsoft.com/office/drawing/2014/main" id="{0777030A-D5BB-440F-9E93-CC2FBB159911}"/>
+                <a16:creationId xmlns:a16="http://schemas.microsoft.com/office/drawing/2014/main" id="{48E12933-B29F-4807-A210-A41DCC1B4EE1}"/>
               </a:ext>
             </a:extLst>
           </p:cNvPr>
@@ -16034,7 +16034,7 @@
           <p:cNvPr id="14" name="">
             <a:extLst xmlns:a="http://schemas.openxmlformats.org/drawingml/2006/main">
               <a:ext uri="{FF2B5EF4-FFF2-40B4-BE49-F238E27FC236}">
-                <a16:creationId xmlns:a16="http://schemas.microsoft.com/office/drawing/2014/main" id="{446E2FC6-0FE8-422F-94E5-CD1BCAB51971}"/>
+                <a16:creationId xmlns:a16="http://schemas.microsoft.com/office/drawing/2014/main" id="{2624E647-AAB1-4EC8-BBA1-D10046F83D6E}"/>
               </a:ext>
             </a:extLst>
           </p:cNvPr>
@@ -16098,7 +16098,7 @@
           <p:cNvPr id="15" name="">
             <a:extLst xmlns:a="http://schemas.openxmlformats.org/drawingml/2006/main">
               <a:ext uri="{FF2B5EF4-FFF2-40B4-BE49-F238E27FC236}">
-                <a16:creationId xmlns:a16="http://schemas.microsoft.com/office/drawing/2014/main" id="{B292A2E0-264F-43BE-9C1C-77129C12795E}"/>
+                <a16:creationId xmlns:a16="http://schemas.microsoft.com/office/drawing/2014/main" id="{1491B5C7-5307-4B7A-B56F-D2B5175FD61D}"/>
               </a:ext>
             </a:extLst>
           </p:cNvPr>
@@ -16162,7 +16162,7 @@
           <p:cNvPr id="16" name="">
             <a:extLst xmlns:a="http://schemas.openxmlformats.org/drawingml/2006/main">
               <a:ext uri="{FF2B5EF4-FFF2-40B4-BE49-F238E27FC236}">
-                <a16:creationId xmlns:a16="http://schemas.microsoft.com/office/drawing/2014/main" id="{D69322F6-670B-4592-BB7A-7DD4E680E891}"/>
+                <a16:creationId xmlns:a16="http://schemas.microsoft.com/office/drawing/2014/main" id="{82799811-A352-492E-965D-EA0357D9ECF4}"/>
               </a:ext>
             </a:extLst>
           </p:cNvPr>
@@ -16195,7 +16195,7 @@
           <p:cNvPr id="17" name="">
             <a:extLst xmlns:a="http://schemas.openxmlformats.org/drawingml/2006/main">
               <a:ext uri="{FF2B5EF4-FFF2-40B4-BE49-F238E27FC236}">
-                <a16:creationId xmlns:a16="http://schemas.microsoft.com/office/drawing/2014/main" id="{92AC1358-C7E6-432D-AC62-CBAE5F4D510B}"/>
+                <a16:creationId xmlns:a16="http://schemas.microsoft.com/office/drawing/2014/main" id="{33B002FB-6EB6-4502-B2D2-C26721877475}"/>
               </a:ext>
             </a:extLst>
           </p:cNvPr>
@@ -16259,7 +16259,7 @@
           <p:cNvPr id="18" name="">
             <a:extLst xmlns:a="http://schemas.openxmlformats.org/drawingml/2006/main">
               <a:ext uri="{FF2B5EF4-FFF2-40B4-BE49-F238E27FC236}">
-                <a16:creationId xmlns:a16="http://schemas.microsoft.com/office/drawing/2014/main" id="{E092E3C7-8C2C-4A70-8896-0D545245FD3B}"/>
+                <a16:creationId xmlns:a16="http://schemas.microsoft.com/office/drawing/2014/main" id="{7546EDD4-4F43-4715-82E8-15CAD7E085C5}"/>
               </a:ext>
             </a:extLst>
           </p:cNvPr>
@@ -16323,7 +16323,7 @@
           <p:cNvPr id="19" name="">
             <a:extLst xmlns:a="http://schemas.openxmlformats.org/drawingml/2006/main">
               <a:ext uri="{FF2B5EF4-FFF2-40B4-BE49-F238E27FC236}">
-                <a16:creationId xmlns:a16="http://schemas.microsoft.com/office/drawing/2014/main" id="{395FF2F4-EF3A-4412-8DA0-FB5CFDBFC02D}"/>
+                <a16:creationId xmlns:a16="http://schemas.microsoft.com/office/drawing/2014/main" id="{45CB3BD6-936D-4049-BF7B-D616D579D4D8}"/>
               </a:ext>
             </a:extLst>
           </p:cNvPr>
@@ -16356,7 +16356,7 @@
           <p:cNvPr id="20" name="">
             <a:extLst xmlns:a="http://schemas.openxmlformats.org/drawingml/2006/main">
               <a:ext uri="{FF2B5EF4-FFF2-40B4-BE49-F238E27FC236}">
-                <a16:creationId xmlns:a16="http://schemas.microsoft.com/office/drawing/2014/main" id="{738615B2-65BE-46F2-81D5-FE7B5233DF7E}"/>
+                <a16:creationId xmlns:a16="http://schemas.microsoft.com/office/drawing/2014/main" id="{0FBB46AC-AAF0-4227-ABB0-F1E10F916D17}"/>
               </a:ext>
             </a:extLst>
           </p:cNvPr>
@@ -16420,7 +16420,7 @@
           <p:cNvPr id="21" name="">
             <a:extLst xmlns:a="http://schemas.openxmlformats.org/drawingml/2006/main">
               <a:ext uri="{FF2B5EF4-FFF2-40B4-BE49-F238E27FC236}">
-                <a16:creationId xmlns:a16="http://schemas.microsoft.com/office/drawing/2014/main" id="{ED5B29A5-4DDB-4655-B736-35F02C2FA365}"/>
+                <a16:creationId xmlns:a16="http://schemas.microsoft.com/office/drawing/2014/main" id="{5294D067-00BC-49EC-80EC-C73A59F25602}"/>
               </a:ext>
             </a:extLst>
           </p:cNvPr>
@@ -16474,7 +16474,7 @@
                 <a:ea typeface="Arial"/>
                 <a:cs typeface="Arial"/>
               </a:rPr>
-              <a:t>comparação lógico/físico</a:t>
+              <a:t>comparação entre lógico e físico</a:t>
             </a:r>
           </a:p>
         </p:txBody>
@@ -16482,7 +16482,7 @@
     </p:spTree>
     <p:extLst>
       <p:ext uri="{BB962C8B-B14F-4D97-AF65-F5344CB8AC3E}">
-        <p14:creationId xmlns:p14="http://schemas.microsoft.com/office/powerpoint/2010/main" val="1974732029"/>
+        <p14:creationId xmlns:p14="http://schemas.microsoft.com/office/powerpoint/2010/main" val="835845221"/>
       </p:ext>
     </p:extLst>
   </p:cSld>
@@ -16506,7 +16506,7 @@
           <p:cNvPr id="1" name="">
             <a:extLst xmlns:a="http://schemas.openxmlformats.org/drawingml/2006/main">
               <a:ext uri="{FF2B5EF4-FFF2-40B4-BE49-F238E27FC236}">
-                <a16:creationId xmlns:a16="http://schemas.microsoft.com/office/drawing/2014/main" id="{2B421B9E-F98B-4C3F-A0D2-2FA74789F6CF}"/>
+                <a16:creationId xmlns:a16="http://schemas.microsoft.com/office/drawing/2014/main" id="{EC904F11-C0BB-4FB9-AE4E-9B13CED80A76}"/>
               </a:ext>
             </a:extLst>
           </p:cNvPr>
@@ -16541,7 +16541,7 @@
           <p:cNvPr id="2" name="">
             <a:extLst xmlns:a="http://schemas.openxmlformats.org/drawingml/2006/main">
               <a:ext uri="{FF2B5EF4-FFF2-40B4-BE49-F238E27FC236}">
-                <a16:creationId xmlns:a16="http://schemas.microsoft.com/office/drawing/2014/main" id="{06360BC1-3784-4EB2-914D-41C9F77C975E}"/>
+                <a16:creationId xmlns:a16="http://schemas.microsoft.com/office/drawing/2014/main" id="{4BC7F43C-CEDD-45F6-8577-331E59696F7E}"/>
               </a:ext>
             </a:extLst>
           </p:cNvPr>
@@ -16576,7 +16576,7 @@
           <p:cNvPr id="3" name="">
             <a:extLst xmlns:a="http://schemas.openxmlformats.org/drawingml/2006/main">
               <a:ext uri="{FF2B5EF4-FFF2-40B4-BE49-F238E27FC236}">
-                <a16:creationId xmlns:a16="http://schemas.microsoft.com/office/drawing/2014/main" id="{1F7C6F19-A2B3-4BC1-BC98-A4D678072F58}"/>
+                <a16:creationId xmlns:a16="http://schemas.microsoft.com/office/drawing/2014/main" id="{35F34332-5C30-4593-BB35-A9B69E6AD13B}"/>
               </a:ext>
             </a:extLst>
           </p:cNvPr>
@@ -16611,7 +16611,7 @@
           <p:cNvPr id="4" name="kicker-6-label">
             <a:extLst xmlns:a="http://schemas.openxmlformats.org/drawingml/2006/main">
               <a:ext uri="{FF2B5EF4-FFF2-40B4-BE49-F238E27FC236}">
-                <a16:creationId xmlns:a16="http://schemas.microsoft.com/office/drawing/2014/main" id="{03E84B96-78C3-4E26-AB1B-4951FDD674D9}"/>
+                <a16:creationId xmlns:a16="http://schemas.microsoft.com/office/drawing/2014/main" id="{D8FCA900-2620-457D-BFB5-B43F5B8BFCB5}"/>
               </a:ext>
             </a:extLst>
           </p:cNvPr>
@@ -16675,7 +16675,7 @@
           <p:cNvPr id="5" name="">
             <a:extLst xmlns:a="http://schemas.openxmlformats.org/drawingml/2006/main">
               <a:ext uri="{FF2B5EF4-FFF2-40B4-BE49-F238E27FC236}">
-                <a16:creationId xmlns:a16="http://schemas.microsoft.com/office/drawing/2014/main" id="{69D5928E-4875-4DCF-AF97-D24FB3CFE159}"/>
+                <a16:creationId xmlns:a16="http://schemas.microsoft.com/office/drawing/2014/main" id="{98B73FCE-637A-4837-96AB-49814E3551F7}"/>
               </a:ext>
             </a:extLst>
           </p:cNvPr>
@@ -16739,7 +16739,7 @@
           <p:cNvPr id="6" name="">
             <a:extLst xmlns:a="http://schemas.openxmlformats.org/drawingml/2006/main">
               <a:ext uri="{FF2B5EF4-FFF2-40B4-BE49-F238E27FC236}">
-                <a16:creationId xmlns:a16="http://schemas.microsoft.com/office/drawing/2014/main" id="{9ABE7433-7DBA-4885-A4A3-E74DAF7C0DF3}"/>
+                <a16:creationId xmlns:a16="http://schemas.microsoft.com/office/drawing/2014/main" id="{214519F2-DC96-4730-85CA-9B675E77FFD7}"/>
               </a:ext>
             </a:extLst>
           </p:cNvPr>
@@ -16793,7 +16793,7 @@
                 <a:ea typeface="Arial"/>
                 <a:cs typeface="Arial"/>
               </a:rPr>
-              <a:t>A literatura reforça RFID, middleware e cautela na validação física.</a:t>
+              <a:t>A literatura fundamenta RFID e middleware, com cautela na validação física.</a:t>
             </a:r>
           </a:p>
         </p:txBody>
@@ -16803,7 +16803,7 @@
           <p:cNvPr id="7" name="">
             <a:extLst xmlns:a="http://schemas.openxmlformats.org/drawingml/2006/main">
               <a:ext uri="{FF2B5EF4-FFF2-40B4-BE49-F238E27FC236}">
-                <a16:creationId xmlns:a16="http://schemas.microsoft.com/office/drawing/2014/main" id="{30912BDF-1171-4658-97D3-F7508745DD56}"/>
+                <a16:creationId xmlns:a16="http://schemas.microsoft.com/office/drawing/2014/main" id="{0CE79FBE-EDAF-4ED3-A165-5C8BB6E21E59}"/>
               </a:ext>
             </a:extLst>
           </p:cNvPr>
@@ -16836,7 +16836,7 @@
           <p:cNvPr id="8" name="">
             <a:extLst xmlns:a="http://schemas.openxmlformats.org/drawingml/2006/main">
               <a:ext uri="{FF2B5EF4-FFF2-40B4-BE49-F238E27FC236}">
-                <a16:creationId xmlns:a16="http://schemas.microsoft.com/office/drawing/2014/main" id="{1FC620EC-9A8A-47CA-A84C-8BEA7FB07D80}"/>
+                <a16:creationId xmlns:a16="http://schemas.microsoft.com/office/drawing/2014/main" id="{D6173A54-D5A3-4873-B231-2E5C9F121B46}"/>
               </a:ext>
             </a:extLst>
           </p:cNvPr>
@@ -16900,7 +16900,7 @@
           <p:cNvPr id="9" name="">
             <a:extLst xmlns:a="http://schemas.openxmlformats.org/drawingml/2006/main">
               <a:ext uri="{FF2B5EF4-FFF2-40B4-BE49-F238E27FC236}">
-                <a16:creationId xmlns:a16="http://schemas.microsoft.com/office/drawing/2014/main" id="{73C9B3B1-DB14-4E3A-9A38-9C4867286E0F}"/>
+                <a16:creationId xmlns:a16="http://schemas.microsoft.com/office/drawing/2014/main" id="{CDB5564D-C1BA-461C-8504-9BBAC1414D2F}"/>
               </a:ext>
             </a:extLst>
           </p:cNvPr>
@@ -16964,7 +16964,7 @@
           <p:cNvPr id="10" name="">
             <a:extLst xmlns:a="http://schemas.openxmlformats.org/drawingml/2006/main">
               <a:ext uri="{FF2B5EF4-FFF2-40B4-BE49-F238E27FC236}">
-                <a16:creationId xmlns:a16="http://schemas.microsoft.com/office/drawing/2014/main" id="{E1861867-8C96-4A3B-9601-CC30A02558D6}"/>
+                <a16:creationId xmlns:a16="http://schemas.microsoft.com/office/drawing/2014/main" id="{94A11E62-EDE9-497A-83F0-CFCACC32939F}"/>
               </a:ext>
             </a:extLst>
           </p:cNvPr>
@@ -16997,7 +16997,7 @@
           <p:cNvPr id="11" name="">
             <a:extLst xmlns:a="http://schemas.openxmlformats.org/drawingml/2006/main">
               <a:ext uri="{FF2B5EF4-FFF2-40B4-BE49-F238E27FC236}">
-                <a16:creationId xmlns:a16="http://schemas.microsoft.com/office/drawing/2014/main" id="{7CF5C5A6-B68F-4412-B266-DF7F678963E4}"/>
+                <a16:creationId xmlns:a16="http://schemas.microsoft.com/office/drawing/2014/main" id="{35665C58-FE04-4920-897C-405CAD51CAAB}"/>
               </a:ext>
             </a:extLst>
           </p:cNvPr>
@@ -17061,7 +17061,7 @@
           <p:cNvPr id="12" name="">
             <a:extLst xmlns:a="http://schemas.openxmlformats.org/drawingml/2006/main">
               <a:ext uri="{FF2B5EF4-FFF2-40B4-BE49-F238E27FC236}">
-                <a16:creationId xmlns:a16="http://schemas.microsoft.com/office/drawing/2014/main" id="{47B3CF00-4847-4BE7-90C2-6C95A3680C0F}"/>
+                <a16:creationId xmlns:a16="http://schemas.microsoft.com/office/drawing/2014/main" id="{E198F8AF-5533-4777-BEE5-9D058B918CC0}"/>
               </a:ext>
             </a:extLst>
           </p:cNvPr>
@@ -17125,7 +17125,7 @@
           <p:cNvPr id="13" name="">
             <a:extLst xmlns:a="http://schemas.openxmlformats.org/drawingml/2006/main">
               <a:ext uri="{FF2B5EF4-FFF2-40B4-BE49-F238E27FC236}">
-                <a16:creationId xmlns:a16="http://schemas.microsoft.com/office/drawing/2014/main" id="{09F53B12-9CF9-454D-9553-BF5B0F643261}"/>
+                <a16:creationId xmlns:a16="http://schemas.microsoft.com/office/drawing/2014/main" id="{F44F5437-F668-47D3-95E4-17083628C59C}"/>
               </a:ext>
             </a:extLst>
           </p:cNvPr>
@@ -17158,7 +17158,7 @@
           <p:cNvPr id="14" name="">
             <a:extLst xmlns:a="http://schemas.openxmlformats.org/drawingml/2006/main">
               <a:ext uri="{FF2B5EF4-FFF2-40B4-BE49-F238E27FC236}">
-                <a16:creationId xmlns:a16="http://schemas.microsoft.com/office/drawing/2014/main" id="{6B7ED31D-4680-40A0-A2B4-7A7F65E12F65}"/>
+                <a16:creationId xmlns:a16="http://schemas.microsoft.com/office/drawing/2014/main" id="{5C55AB55-20F6-4787-AC0D-C06458B534FA}"/>
               </a:ext>
             </a:extLst>
           </p:cNvPr>
@@ -17222,7 +17222,7 @@
           <p:cNvPr id="15" name="">
             <a:extLst xmlns:a="http://schemas.openxmlformats.org/drawingml/2006/main">
               <a:ext uri="{FF2B5EF4-FFF2-40B4-BE49-F238E27FC236}">
-                <a16:creationId xmlns:a16="http://schemas.microsoft.com/office/drawing/2014/main" id="{38F63085-0A41-4777-A259-FDDC28DD3A2E}"/>
+                <a16:creationId xmlns:a16="http://schemas.microsoft.com/office/drawing/2014/main" id="{AE96A801-3D82-4C40-A15F-9E6450DF2EEF}"/>
               </a:ext>
             </a:extLst>
           </p:cNvPr>
@@ -17276,7 +17276,7 @@
                 <a:ea typeface="Arial"/>
                 <a:cs typeface="Arial"/>
               </a:rPr>
-              <a:t>auditoria patrimonial com comparação esperado-observado</a:t>
+              <a:t>auditoria patrimonial entre esperado e observado</a:t>
             </a:r>
           </a:p>
         </p:txBody>
@@ -17286,7 +17286,7 @@
           <p:cNvPr id="16" name="">
             <a:extLst xmlns:a="http://schemas.openxmlformats.org/drawingml/2006/main">
               <a:ext uri="{FF2B5EF4-FFF2-40B4-BE49-F238E27FC236}">
-                <a16:creationId xmlns:a16="http://schemas.microsoft.com/office/drawing/2014/main" id="{131776D3-BF1B-4DA7-A9B4-DB7B282BDDF0}"/>
+                <a16:creationId xmlns:a16="http://schemas.microsoft.com/office/drawing/2014/main" id="{71492C5F-1E55-4547-8694-5C2CACE8A491}"/>
               </a:ext>
             </a:extLst>
           </p:cNvPr>
@@ -17348,7 +17348,7 @@
     </p:spTree>
     <p:extLst>
       <p:ext uri="{BB962C8B-B14F-4D97-AF65-F5344CB8AC3E}">
-        <p14:creationId xmlns:p14="http://schemas.microsoft.com/office/powerpoint/2010/main" val="1041976899"/>
+        <p14:creationId xmlns:p14="http://schemas.microsoft.com/office/powerpoint/2010/main" val="666585265"/>
       </p:ext>
     </p:extLst>
   </p:cSld>
@@ -17372,7 +17372,7 @@
           <p:cNvPr id="1" name="">
             <a:extLst xmlns:a="http://schemas.openxmlformats.org/drawingml/2006/main">
               <a:ext uri="{FF2B5EF4-FFF2-40B4-BE49-F238E27FC236}">
-                <a16:creationId xmlns:a16="http://schemas.microsoft.com/office/drawing/2014/main" id="{4688B10A-E55E-43AD-9185-961C3727704C}"/>
+                <a16:creationId xmlns:a16="http://schemas.microsoft.com/office/drawing/2014/main" id="{9163FB62-9F47-45FE-BEE8-180B4D0A84B4}"/>
               </a:ext>
             </a:extLst>
           </p:cNvPr>
@@ -17407,7 +17407,7 @@
           <p:cNvPr id="2" name="">
             <a:extLst xmlns:a="http://schemas.openxmlformats.org/drawingml/2006/main">
               <a:ext uri="{FF2B5EF4-FFF2-40B4-BE49-F238E27FC236}">
-                <a16:creationId xmlns:a16="http://schemas.microsoft.com/office/drawing/2014/main" id="{7FF85C3A-43E8-48D6-B989-504794C9C392}"/>
+                <a16:creationId xmlns:a16="http://schemas.microsoft.com/office/drawing/2014/main" id="{E30963E9-1851-4147-82C7-2B3D0C5E24F4}"/>
               </a:ext>
             </a:extLst>
           </p:cNvPr>
@@ -17442,7 +17442,7 @@
           <p:cNvPr id="3" name="">
             <a:extLst xmlns:a="http://schemas.openxmlformats.org/drawingml/2006/main">
               <a:ext uri="{FF2B5EF4-FFF2-40B4-BE49-F238E27FC236}">
-                <a16:creationId xmlns:a16="http://schemas.microsoft.com/office/drawing/2014/main" id="{8F225FF3-4211-410D-8D26-5C8F8F2FDDDD}"/>
+                <a16:creationId xmlns:a16="http://schemas.microsoft.com/office/drawing/2014/main" id="{9C867D47-9FAC-4971-B030-D21E4C9CEC78}"/>
               </a:ext>
             </a:extLst>
           </p:cNvPr>
@@ -17477,7 +17477,7 @@
           <p:cNvPr id="4" name="kicker-7-label">
             <a:extLst xmlns:a="http://schemas.openxmlformats.org/drawingml/2006/main">
               <a:ext uri="{FF2B5EF4-FFF2-40B4-BE49-F238E27FC236}">
-                <a16:creationId xmlns:a16="http://schemas.microsoft.com/office/drawing/2014/main" id="{27451451-F106-4926-985E-5EA8FD4B633E}"/>
+                <a16:creationId xmlns:a16="http://schemas.microsoft.com/office/drawing/2014/main" id="{F545D938-825B-4A28-9E9E-0BFD716673A0}"/>
               </a:ext>
             </a:extLst>
           </p:cNvPr>
@@ -17541,7 +17541,7 @@
           <p:cNvPr id="5" name="">
             <a:extLst xmlns:a="http://schemas.openxmlformats.org/drawingml/2006/main">
               <a:ext uri="{FF2B5EF4-FFF2-40B4-BE49-F238E27FC236}">
-                <a16:creationId xmlns:a16="http://schemas.microsoft.com/office/drawing/2014/main" id="{D8E91901-8A7E-41A0-A8E3-CF05EAE35733}"/>
+                <a16:creationId xmlns:a16="http://schemas.microsoft.com/office/drawing/2014/main" id="{CD673141-C2E3-444D-A9F4-A25AEA82546B}"/>
               </a:ext>
             </a:extLst>
           </p:cNvPr>
@@ -17605,7 +17605,7 @@
           <p:cNvPr id="6" name="">
             <a:extLst xmlns:a="http://schemas.openxmlformats.org/drawingml/2006/main">
               <a:ext uri="{FF2B5EF4-FFF2-40B4-BE49-F238E27FC236}">
-                <a16:creationId xmlns:a16="http://schemas.microsoft.com/office/drawing/2014/main" id="{3EF2C3AD-D6ED-463C-822D-99FD0CD2F6A6}"/>
+                <a16:creationId xmlns:a16="http://schemas.microsoft.com/office/drawing/2014/main" id="{9E0B005A-EBA0-452B-856E-1E56D92A3A95}"/>
               </a:ext>
             </a:extLst>
           </p:cNvPr>
@@ -17669,7 +17669,7 @@
           <p:cNvPr id="7" name="">
             <a:extLst xmlns:a="http://schemas.openxmlformats.org/drawingml/2006/main">
               <a:ext uri="{FF2B5EF4-FFF2-40B4-BE49-F238E27FC236}">
-                <a16:creationId xmlns:a16="http://schemas.microsoft.com/office/drawing/2014/main" id="{30C14658-72FD-4D1F-9B59-6AFDA8D29C4E}"/>
+                <a16:creationId xmlns:a16="http://schemas.microsoft.com/office/drawing/2014/main" id="{39EBD25C-5C1E-414A-90B4-1C7BC857E371}"/>
               </a:ext>
             </a:extLst>
           </p:cNvPr>
@@ -17702,7 +17702,7 @@
           <p:cNvPr id="8" name="">
             <a:extLst xmlns:a="http://schemas.openxmlformats.org/drawingml/2006/main">
               <a:ext uri="{FF2B5EF4-FFF2-40B4-BE49-F238E27FC236}">
-                <a16:creationId xmlns:a16="http://schemas.microsoft.com/office/drawing/2014/main" id="{09AEA49A-F237-4ED3-8C95-7C1554E7CEAC}"/>
+                <a16:creationId xmlns:a16="http://schemas.microsoft.com/office/drawing/2014/main" id="{5E597F8A-371A-4340-B6D7-1116B16F23CD}"/>
               </a:ext>
             </a:extLst>
           </p:cNvPr>
@@ -17735,7 +17735,7 @@
           <p:cNvPr id="9" name="">
             <a:extLst xmlns:a="http://schemas.openxmlformats.org/drawingml/2006/main">
               <a:ext uri="{FF2B5EF4-FFF2-40B4-BE49-F238E27FC236}">
-                <a16:creationId xmlns:a16="http://schemas.microsoft.com/office/drawing/2014/main" id="{A5ECDB47-6713-4C1D-AEBA-49285E97540C}"/>
+                <a16:creationId xmlns:a16="http://schemas.microsoft.com/office/drawing/2014/main" id="{0D59B8F0-6712-4411-9489-BD801AAFCD5C}"/>
               </a:ext>
             </a:extLst>
           </p:cNvPr>
@@ -17799,7 +17799,7 @@
           <p:cNvPr id="10" name="">
             <a:extLst xmlns:a="http://schemas.openxmlformats.org/drawingml/2006/main">
               <a:ext uri="{FF2B5EF4-FFF2-40B4-BE49-F238E27FC236}">
-                <a16:creationId xmlns:a16="http://schemas.microsoft.com/office/drawing/2014/main" id="{D8A5C78C-12D2-4E2B-AC94-4B3FAF1DE6E6}"/>
+                <a16:creationId xmlns:a16="http://schemas.microsoft.com/office/drawing/2014/main" id="{884D7218-51F8-48FF-A077-62FF843D0C06}"/>
               </a:ext>
             </a:extLst>
           </p:cNvPr>
@@ -17863,7 +17863,7 @@
           <p:cNvPr id="11" name="">
             <a:extLst xmlns:a="http://schemas.openxmlformats.org/drawingml/2006/main">
               <a:ext uri="{FF2B5EF4-FFF2-40B4-BE49-F238E27FC236}">
-                <a16:creationId xmlns:a16="http://schemas.microsoft.com/office/drawing/2014/main" id="{CEB09167-3824-4E8B-8043-84A9DFE1C600}"/>
+                <a16:creationId xmlns:a16="http://schemas.microsoft.com/office/drawing/2014/main" id="{E2B2C1AF-4960-4549-A064-8A16AD93416D}"/>
               </a:ext>
             </a:extLst>
           </p:cNvPr>
@@ -17927,7 +17927,7 @@
           <p:cNvPr id="12" name="">
             <a:extLst xmlns:a="http://schemas.openxmlformats.org/drawingml/2006/main">
               <a:ext uri="{FF2B5EF4-FFF2-40B4-BE49-F238E27FC236}">
-                <a16:creationId xmlns:a16="http://schemas.microsoft.com/office/drawing/2014/main" id="{ECF4E883-356C-496A-87FC-6758B6FF9D94}"/>
+                <a16:creationId xmlns:a16="http://schemas.microsoft.com/office/drawing/2014/main" id="{CEBE83B5-A6DD-454F-AEED-96FA017FC05B}"/>
               </a:ext>
             </a:extLst>
           </p:cNvPr>
@@ -17960,7 +17960,7 @@
           <p:cNvPr id="13" name="">
             <a:extLst xmlns:a="http://schemas.openxmlformats.org/drawingml/2006/main">
               <a:ext uri="{FF2B5EF4-FFF2-40B4-BE49-F238E27FC236}">
-                <a16:creationId xmlns:a16="http://schemas.microsoft.com/office/drawing/2014/main" id="{A5DD2BE7-593E-4DF6-8A27-749341A8EB7E}"/>
+                <a16:creationId xmlns:a16="http://schemas.microsoft.com/office/drawing/2014/main" id="{3D2270A4-BD3E-4965-A6DD-09FFCEA06509}"/>
               </a:ext>
             </a:extLst>
           </p:cNvPr>
@@ -17993,7 +17993,7 @@
           <p:cNvPr id="14" name="">
             <a:extLst xmlns:a="http://schemas.openxmlformats.org/drawingml/2006/main">
               <a:ext uri="{FF2B5EF4-FFF2-40B4-BE49-F238E27FC236}">
-                <a16:creationId xmlns:a16="http://schemas.microsoft.com/office/drawing/2014/main" id="{45EE3405-2512-4090-AA28-C184057BC20E}"/>
+                <a16:creationId xmlns:a16="http://schemas.microsoft.com/office/drawing/2014/main" id="{29B07EB9-DA23-4D79-B7C6-94D7CD2550FA}"/>
               </a:ext>
             </a:extLst>
           </p:cNvPr>
@@ -18057,7 +18057,7 @@
           <p:cNvPr id="15" name="">
             <a:extLst xmlns:a="http://schemas.openxmlformats.org/drawingml/2006/main">
               <a:ext uri="{FF2B5EF4-FFF2-40B4-BE49-F238E27FC236}">
-                <a16:creationId xmlns:a16="http://schemas.microsoft.com/office/drawing/2014/main" id="{EEBEB5EB-9707-468A-8BB4-19B53B5D20A4}"/>
+                <a16:creationId xmlns:a16="http://schemas.microsoft.com/office/drawing/2014/main" id="{4106548B-AA82-4C91-ABAA-A4AA4FD65C88}"/>
               </a:ext>
             </a:extLst>
           </p:cNvPr>
@@ -18121,7 +18121,7 @@
           <p:cNvPr id="16" name="">
             <a:extLst xmlns:a="http://schemas.openxmlformats.org/drawingml/2006/main">
               <a:ext uri="{FF2B5EF4-FFF2-40B4-BE49-F238E27FC236}">
-                <a16:creationId xmlns:a16="http://schemas.microsoft.com/office/drawing/2014/main" id="{188E8E19-5C1D-497C-838E-8AC1218DC6CD}"/>
+                <a16:creationId xmlns:a16="http://schemas.microsoft.com/office/drawing/2014/main" id="{E06657C8-A008-4DF7-BDA2-69EA70735DB9}"/>
               </a:ext>
             </a:extLst>
           </p:cNvPr>
@@ -18185,7 +18185,7 @@
           <p:cNvPr id="17" name="">
             <a:extLst xmlns:a="http://schemas.openxmlformats.org/drawingml/2006/main">
               <a:ext uri="{FF2B5EF4-FFF2-40B4-BE49-F238E27FC236}">
-                <a16:creationId xmlns:a16="http://schemas.microsoft.com/office/drawing/2014/main" id="{B91DF3D5-1443-4235-8E00-56CC83AE6732}"/>
+                <a16:creationId xmlns:a16="http://schemas.microsoft.com/office/drawing/2014/main" id="{3909492C-C711-4535-BF33-F61501FAC5C4}"/>
               </a:ext>
             </a:extLst>
           </p:cNvPr>
@@ -18218,7 +18218,7 @@
           <p:cNvPr id="18" name="">
             <a:extLst xmlns:a="http://schemas.openxmlformats.org/drawingml/2006/main">
               <a:ext uri="{FF2B5EF4-FFF2-40B4-BE49-F238E27FC236}">
-                <a16:creationId xmlns:a16="http://schemas.microsoft.com/office/drawing/2014/main" id="{5B82170A-477D-41C1-9987-19CBE41B352D}"/>
+                <a16:creationId xmlns:a16="http://schemas.microsoft.com/office/drawing/2014/main" id="{5E76BA26-2978-4967-8F49-D3F28B0B67B6}"/>
               </a:ext>
             </a:extLst>
           </p:cNvPr>
@@ -18251,7 +18251,7 @@
           <p:cNvPr id="19" name="">
             <a:extLst xmlns:a="http://schemas.openxmlformats.org/drawingml/2006/main">
               <a:ext uri="{FF2B5EF4-FFF2-40B4-BE49-F238E27FC236}">
-                <a16:creationId xmlns:a16="http://schemas.microsoft.com/office/drawing/2014/main" id="{843BE51D-E6CC-436C-ABEB-96FE5979CF88}"/>
+                <a16:creationId xmlns:a16="http://schemas.microsoft.com/office/drawing/2014/main" id="{71F5CAD2-6EB1-4CE8-86F5-7602B3600B7D}"/>
               </a:ext>
             </a:extLst>
           </p:cNvPr>
@@ -18315,7 +18315,7 @@
           <p:cNvPr id="20" name="">
             <a:extLst xmlns:a="http://schemas.openxmlformats.org/drawingml/2006/main">
               <a:ext uri="{FF2B5EF4-FFF2-40B4-BE49-F238E27FC236}">
-                <a16:creationId xmlns:a16="http://schemas.microsoft.com/office/drawing/2014/main" id="{470AE754-0972-46C5-82B4-C1A9398971E9}"/>
+                <a16:creationId xmlns:a16="http://schemas.microsoft.com/office/drawing/2014/main" id="{FFB8A36F-0A3C-4016-828C-A7080FE70FDF}"/>
               </a:ext>
             </a:extLst>
           </p:cNvPr>
@@ -18379,7 +18379,7 @@
           <p:cNvPr id="21" name="">
             <a:extLst xmlns:a="http://schemas.openxmlformats.org/drawingml/2006/main">
               <a:ext uri="{FF2B5EF4-FFF2-40B4-BE49-F238E27FC236}">
-                <a16:creationId xmlns:a16="http://schemas.microsoft.com/office/drawing/2014/main" id="{76CE5C56-B465-4987-BA83-CA23D50D0DE0}"/>
+                <a16:creationId xmlns:a16="http://schemas.microsoft.com/office/drawing/2014/main" id="{C5825CF1-E3D9-4283-8359-0521B0EEAB8B}"/>
               </a:ext>
             </a:extLst>
           </p:cNvPr>
@@ -18441,7 +18441,7 @@
     </p:spTree>
     <p:extLst>
       <p:ext uri="{BB962C8B-B14F-4D97-AF65-F5344CB8AC3E}">
-        <p14:creationId xmlns:p14="http://schemas.microsoft.com/office/powerpoint/2010/main" val="1068643559"/>
+        <p14:creationId xmlns:p14="http://schemas.microsoft.com/office/powerpoint/2010/main" val="1559413908"/>
       </p:ext>
     </p:extLst>
   </p:cSld>
@@ -18465,7 +18465,7 @@
           <p:cNvPr id="1" name="">
             <a:extLst xmlns:a="http://schemas.openxmlformats.org/drawingml/2006/main">
               <a:ext uri="{FF2B5EF4-FFF2-40B4-BE49-F238E27FC236}">
-                <a16:creationId xmlns:a16="http://schemas.microsoft.com/office/drawing/2014/main" id="{BD7B27F7-807A-46C7-BC02-518C6DBBBE1E}"/>
+                <a16:creationId xmlns:a16="http://schemas.microsoft.com/office/drawing/2014/main" id="{B87CA378-21C1-4C4D-9863-0B8DB4B61E2C}"/>
               </a:ext>
             </a:extLst>
           </p:cNvPr>
@@ -18500,7 +18500,7 @@
           <p:cNvPr id="2" name="">
             <a:extLst xmlns:a="http://schemas.openxmlformats.org/drawingml/2006/main">
               <a:ext uri="{FF2B5EF4-FFF2-40B4-BE49-F238E27FC236}">
-                <a16:creationId xmlns:a16="http://schemas.microsoft.com/office/drawing/2014/main" id="{95B2A32A-A61A-46FE-B55D-4D3F86407365}"/>
+                <a16:creationId xmlns:a16="http://schemas.microsoft.com/office/drawing/2014/main" id="{CB5A709A-3D79-43A6-A1B7-ABD9202DB771}"/>
               </a:ext>
             </a:extLst>
           </p:cNvPr>
@@ -18535,7 +18535,7 @@
           <p:cNvPr id="3" name="">
             <a:extLst xmlns:a="http://schemas.openxmlformats.org/drawingml/2006/main">
               <a:ext uri="{FF2B5EF4-FFF2-40B4-BE49-F238E27FC236}">
-                <a16:creationId xmlns:a16="http://schemas.microsoft.com/office/drawing/2014/main" id="{4C194B3C-92D0-412C-BA5F-C8C75753DED5}"/>
+                <a16:creationId xmlns:a16="http://schemas.microsoft.com/office/drawing/2014/main" id="{BB02A5F1-2843-4E3A-99AD-BD76C1C99A1A}"/>
               </a:ext>
             </a:extLst>
           </p:cNvPr>
@@ -18570,7 +18570,7 @@
           <p:cNvPr id="4" name="kicker-8-label">
             <a:extLst xmlns:a="http://schemas.openxmlformats.org/drawingml/2006/main">
               <a:ext uri="{FF2B5EF4-FFF2-40B4-BE49-F238E27FC236}">
-                <a16:creationId xmlns:a16="http://schemas.microsoft.com/office/drawing/2014/main" id="{7B462C0A-AF2D-42EA-82EF-95294B274072}"/>
+                <a16:creationId xmlns:a16="http://schemas.microsoft.com/office/drawing/2014/main" id="{4496E2D9-7126-4656-8740-8145ED614BD3}"/>
               </a:ext>
             </a:extLst>
           </p:cNvPr>
@@ -18634,7 +18634,7 @@
           <p:cNvPr id="5" name="">
             <a:extLst xmlns:a="http://schemas.openxmlformats.org/drawingml/2006/main">
               <a:ext uri="{FF2B5EF4-FFF2-40B4-BE49-F238E27FC236}">
-                <a16:creationId xmlns:a16="http://schemas.microsoft.com/office/drawing/2014/main" id="{20D30A2E-4668-4518-98BD-D8E335C24A9E}"/>
+                <a16:creationId xmlns:a16="http://schemas.microsoft.com/office/drawing/2014/main" id="{B0E68D8F-9E84-4AEB-8C88-D655526FE9CC}"/>
               </a:ext>
             </a:extLst>
           </p:cNvPr>
@@ -18698,7 +18698,7 @@
           <p:cNvPr id="6" name="">
             <a:extLst xmlns:a="http://schemas.openxmlformats.org/drawingml/2006/main">
               <a:ext uri="{FF2B5EF4-FFF2-40B4-BE49-F238E27FC236}">
-                <a16:creationId xmlns:a16="http://schemas.microsoft.com/office/drawing/2014/main" id="{45791ECC-19B1-43BA-B3F8-E4E3D971A620}"/>
+                <a16:creationId xmlns:a16="http://schemas.microsoft.com/office/drawing/2014/main" id="{FF70112A-36CE-4296-929C-0B5614DA570A}"/>
               </a:ext>
             </a:extLst>
           </p:cNvPr>
@@ -18762,7 +18762,7 @@
           <p:cNvPr id="7" name="">
             <a:extLst xmlns:a="http://schemas.openxmlformats.org/drawingml/2006/main">
               <a:ext uri="{FF2B5EF4-FFF2-40B4-BE49-F238E27FC236}">
-                <a16:creationId xmlns:a16="http://schemas.microsoft.com/office/drawing/2014/main" id="{9C412276-6715-4500-B072-873F271238BD}"/>
+                <a16:creationId xmlns:a16="http://schemas.microsoft.com/office/drawing/2014/main" id="{6C9DD2D6-2CA5-4E4D-B283-922E9FA97156}"/>
               </a:ext>
             </a:extLst>
           </p:cNvPr>
@@ -18797,7 +18797,7 @@
           <p:cNvPr id="8" name="">
             <a:extLst xmlns:a="http://schemas.openxmlformats.org/drawingml/2006/main">
               <a:ext uri="{FF2B5EF4-FFF2-40B4-BE49-F238E27FC236}">
-                <a16:creationId xmlns:a16="http://schemas.microsoft.com/office/drawing/2014/main" id="{5A625FEA-2F34-4C84-AE65-79E15CF3E2CE}"/>
+                <a16:creationId xmlns:a16="http://schemas.microsoft.com/office/drawing/2014/main" id="{7022F594-E0D9-405C-B1C4-38FC8D7CDF3C}"/>
               </a:ext>
             </a:extLst>
           </p:cNvPr>
@@ -18861,7 +18861,7 @@
           <p:cNvPr id="9" name="">
             <a:extLst xmlns:a="http://schemas.openxmlformats.org/drawingml/2006/main">
               <a:ext uri="{FF2B5EF4-FFF2-40B4-BE49-F238E27FC236}">
-                <a16:creationId xmlns:a16="http://schemas.microsoft.com/office/drawing/2014/main" id="{E202E605-B1BF-4597-B432-B6C6C9EA7313}"/>
+                <a16:creationId xmlns:a16="http://schemas.microsoft.com/office/drawing/2014/main" id="{400C8AA6-6325-40A7-A184-1B89CFC58AB8}"/>
               </a:ext>
             </a:extLst>
           </p:cNvPr>
@@ -18896,7 +18896,7 @@
           <p:cNvPr id="10" name="">
             <a:extLst xmlns:a="http://schemas.openxmlformats.org/drawingml/2006/main">
               <a:ext uri="{FF2B5EF4-FFF2-40B4-BE49-F238E27FC236}">
-                <a16:creationId xmlns:a16="http://schemas.microsoft.com/office/drawing/2014/main" id="{C011CAC3-341F-47CF-AD20-0BF6DA1A3F60}"/>
+                <a16:creationId xmlns:a16="http://schemas.microsoft.com/office/drawing/2014/main" id="{F3ED8C6D-7C7D-490C-9795-0AB90F423AD9}"/>
               </a:ext>
             </a:extLst>
           </p:cNvPr>
@@ -18960,7 +18960,7 @@
           <p:cNvPr id="11" name="">
             <a:extLst xmlns:a="http://schemas.openxmlformats.org/drawingml/2006/main">
               <a:ext uri="{FF2B5EF4-FFF2-40B4-BE49-F238E27FC236}">
-                <a16:creationId xmlns:a16="http://schemas.microsoft.com/office/drawing/2014/main" id="{57CE44C6-F9AF-4FA0-8190-BEA81F688C68}"/>
+                <a16:creationId xmlns:a16="http://schemas.microsoft.com/office/drawing/2014/main" id="{FFB500B6-8D71-474A-A3E6-74C047FA67FB}"/>
               </a:ext>
             </a:extLst>
           </p:cNvPr>
@@ -18995,7 +18995,7 @@
           <p:cNvPr id="12" name="">
             <a:extLst xmlns:a="http://schemas.openxmlformats.org/drawingml/2006/main">
               <a:ext uri="{FF2B5EF4-FFF2-40B4-BE49-F238E27FC236}">
-                <a16:creationId xmlns:a16="http://schemas.microsoft.com/office/drawing/2014/main" id="{597D012E-B4E9-4AB2-BB9E-7380ED4717C3}"/>
+                <a16:creationId xmlns:a16="http://schemas.microsoft.com/office/drawing/2014/main" id="{9C0B39C8-BDCB-413E-B68D-15B31B6F1B58}"/>
               </a:ext>
             </a:extLst>
           </p:cNvPr>
@@ -19059,7 +19059,7 @@
           <p:cNvPr id="13" name="">
             <a:extLst xmlns:a="http://schemas.openxmlformats.org/drawingml/2006/main">
               <a:ext uri="{FF2B5EF4-FFF2-40B4-BE49-F238E27FC236}">
-                <a16:creationId xmlns:a16="http://schemas.microsoft.com/office/drawing/2014/main" id="{CF3D637F-74D3-41CC-8B9D-AD3F9F4DC9EF}"/>
+                <a16:creationId xmlns:a16="http://schemas.microsoft.com/office/drawing/2014/main" id="{8875110B-D448-4C08-87B0-A63022E813A0}"/>
               </a:ext>
             </a:extLst>
           </p:cNvPr>
@@ -19092,7 +19092,7 @@
           <p:cNvPr id="14" name="">
             <a:extLst xmlns:a="http://schemas.openxmlformats.org/drawingml/2006/main">
               <a:ext uri="{FF2B5EF4-FFF2-40B4-BE49-F238E27FC236}">
-                <a16:creationId xmlns:a16="http://schemas.microsoft.com/office/drawing/2014/main" id="{16DE0031-07FB-4092-8316-05959616400C}"/>
+                <a16:creationId xmlns:a16="http://schemas.microsoft.com/office/drawing/2014/main" id="{76F38AFA-8F4F-4C01-8F90-D5CD7E1EEE63}"/>
               </a:ext>
             </a:extLst>
           </p:cNvPr>
@@ -19156,7 +19156,7 @@
           <p:cNvPr id="15" name="">
             <a:extLst xmlns:a="http://schemas.openxmlformats.org/drawingml/2006/main">
               <a:ext uri="{FF2B5EF4-FFF2-40B4-BE49-F238E27FC236}">
-                <a16:creationId xmlns:a16="http://schemas.microsoft.com/office/drawing/2014/main" id="{C168403D-9F84-4B28-B4A4-1A7B27B6A6DE}"/>
+                <a16:creationId xmlns:a16="http://schemas.microsoft.com/office/drawing/2014/main" id="{5DB42B3C-A35B-479D-81C0-0261B29B0B0A}"/>
               </a:ext>
             </a:extLst>
           </p:cNvPr>
@@ -19220,7 +19220,7 @@
           <p:cNvPr id="16" name="">
             <a:extLst xmlns:a="http://schemas.openxmlformats.org/drawingml/2006/main">
               <a:ext uri="{FF2B5EF4-FFF2-40B4-BE49-F238E27FC236}">
-                <a16:creationId xmlns:a16="http://schemas.microsoft.com/office/drawing/2014/main" id="{AC23681E-FFDC-48B1-AAD7-DDB9DA5883A6}"/>
+                <a16:creationId xmlns:a16="http://schemas.microsoft.com/office/drawing/2014/main" id="{D4262282-7414-4D3D-A3C5-CFA881E9BF82}"/>
               </a:ext>
             </a:extLst>
           </p:cNvPr>
@@ -19253,7 +19253,7 @@
           <p:cNvPr id="17" name="">
             <a:extLst xmlns:a="http://schemas.openxmlformats.org/drawingml/2006/main">
               <a:ext uri="{FF2B5EF4-FFF2-40B4-BE49-F238E27FC236}">
-                <a16:creationId xmlns:a16="http://schemas.microsoft.com/office/drawing/2014/main" id="{0D904575-9A1A-4AB8-A82C-0E5A453FB3E2}"/>
+                <a16:creationId xmlns:a16="http://schemas.microsoft.com/office/drawing/2014/main" id="{55710E53-16CB-49EA-AC6D-75672CC0DC67}"/>
               </a:ext>
             </a:extLst>
           </p:cNvPr>
@@ -19317,7 +19317,7 @@
           <p:cNvPr id="18" name="">
             <a:extLst xmlns:a="http://schemas.openxmlformats.org/drawingml/2006/main">
               <a:ext uri="{FF2B5EF4-FFF2-40B4-BE49-F238E27FC236}">
-                <a16:creationId xmlns:a16="http://schemas.microsoft.com/office/drawing/2014/main" id="{1D921895-E3F8-4D82-BA43-B92E02B1B2BB}"/>
+                <a16:creationId xmlns:a16="http://schemas.microsoft.com/office/drawing/2014/main" id="{6D9CB5C7-9091-4E41-A4F9-9FE0734C32D9}"/>
               </a:ext>
             </a:extLst>
           </p:cNvPr>
@@ -19381,7 +19381,7 @@
           <p:cNvPr id="19" name="">
             <a:extLst xmlns:a="http://schemas.openxmlformats.org/drawingml/2006/main">
               <a:ext uri="{FF2B5EF4-FFF2-40B4-BE49-F238E27FC236}">
-                <a16:creationId xmlns:a16="http://schemas.microsoft.com/office/drawing/2014/main" id="{17010D6A-532C-494F-9481-556BB796DC1B}"/>
+                <a16:creationId xmlns:a16="http://schemas.microsoft.com/office/drawing/2014/main" id="{A8E8DBF4-57BD-464B-99AF-777C5BD43A80}"/>
               </a:ext>
             </a:extLst>
           </p:cNvPr>
@@ -19414,7 +19414,7 @@
           <p:cNvPr id="20" name="">
             <a:extLst xmlns:a="http://schemas.openxmlformats.org/drawingml/2006/main">
               <a:ext uri="{FF2B5EF4-FFF2-40B4-BE49-F238E27FC236}">
-                <a16:creationId xmlns:a16="http://schemas.microsoft.com/office/drawing/2014/main" id="{4782762D-1DDF-41C5-8A5D-EEBD67A57FAC}"/>
+                <a16:creationId xmlns:a16="http://schemas.microsoft.com/office/drawing/2014/main" id="{0B3A30F3-E491-4128-9B12-A74EEB3079D7}"/>
               </a:ext>
             </a:extLst>
           </p:cNvPr>
@@ -19478,7 +19478,7 @@
           <p:cNvPr id="21" name="">
             <a:extLst xmlns:a="http://schemas.openxmlformats.org/drawingml/2006/main">
               <a:ext uri="{FF2B5EF4-FFF2-40B4-BE49-F238E27FC236}">
-                <a16:creationId xmlns:a16="http://schemas.microsoft.com/office/drawing/2014/main" id="{B86D6E0A-ABB9-40B9-80F7-458AED28415B}"/>
+                <a16:creationId xmlns:a16="http://schemas.microsoft.com/office/drawing/2014/main" id="{F4F5E6E1-BF48-47C0-8B98-5369E12AAC52}"/>
               </a:ext>
             </a:extLst>
           </p:cNvPr>
@@ -19540,7 +19540,7 @@
     </p:spTree>
     <p:extLst>
       <p:ext uri="{BB962C8B-B14F-4D97-AF65-F5344CB8AC3E}">
-        <p14:creationId xmlns:p14="http://schemas.microsoft.com/office/powerpoint/2010/main" val="1305790616"/>
+        <p14:creationId xmlns:p14="http://schemas.microsoft.com/office/powerpoint/2010/main" val="2077774848"/>
       </p:ext>
     </p:extLst>
   </p:cSld>
@@ -19564,7 +19564,7 @@
           <p:cNvPr id="1" name="">
             <a:extLst xmlns:a="http://schemas.openxmlformats.org/drawingml/2006/main">
               <a:ext uri="{FF2B5EF4-FFF2-40B4-BE49-F238E27FC236}">
-                <a16:creationId xmlns:a16="http://schemas.microsoft.com/office/drawing/2014/main" id="{5ADBCBBC-6253-41D0-ADBB-DB8F9A30F829}"/>
+                <a16:creationId xmlns:a16="http://schemas.microsoft.com/office/drawing/2014/main" id="{3003B01F-95C1-40BA-9DF0-39A5C4EDAB47}"/>
               </a:ext>
             </a:extLst>
           </p:cNvPr>
@@ -19599,7 +19599,7 @@
           <p:cNvPr id="2" name="">
             <a:extLst xmlns:a="http://schemas.openxmlformats.org/drawingml/2006/main">
               <a:ext uri="{FF2B5EF4-FFF2-40B4-BE49-F238E27FC236}">
-                <a16:creationId xmlns:a16="http://schemas.microsoft.com/office/drawing/2014/main" id="{C912C82B-B254-474D-89D1-26A62BDA13DF}"/>
+                <a16:creationId xmlns:a16="http://schemas.microsoft.com/office/drawing/2014/main" id="{B1CB8E51-A5A8-471F-998B-FCF5564C73A8}"/>
               </a:ext>
             </a:extLst>
           </p:cNvPr>
@@ -19634,7 +19634,7 @@
           <p:cNvPr id="3" name="">
             <a:extLst xmlns:a="http://schemas.openxmlformats.org/drawingml/2006/main">
               <a:ext uri="{FF2B5EF4-FFF2-40B4-BE49-F238E27FC236}">
-                <a16:creationId xmlns:a16="http://schemas.microsoft.com/office/drawing/2014/main" id="{2AC6824F-7B5B-4EE5-9B3B-54CF79266457}"/>
+                <a16:creationId xmlns:a16="http://schemas.microsoft.com/office/drawing/2014/main" id="{5DBC14EC-C2EB-40F2-AFA4-33B2E4B0A0A1}"/>
               </a:ext>
             </a:extLst>
           </p:cNvPr>
@@ -19669,7 +19669,7 @@
           <p:cNvPr id="4" name="kicker-9-label">
             <a:extLst xmlns:a="http://schemas.openxmlformats.org/drawingml/2006/main">
               <a:ext uri="{FF2B5EF4-FFF2-40B4-BE49-F238E27FC236}">
-                <a16:creationId xmlns:a16="http://schemas.microsoft.com/office/drawing/2014/main" id="{92CE9E3C-DAD5-4E0C-9B08-4D6FC30F559B}"/>
+                <a16:creationId xmlns:a16="http://schemas.microsoft.com/office/drawing/2014/main" id="{2249C914-C6CE-4EC3-9E7C-45208ABECD7F}"/>
               </a:ext>
             </a:extLst>
           </p:cNvPr>
@@ -19733,7 +19733,7 @@
           <p:cNvPr id="5" name="">
             <a:extLst xmlns:a="http://schemas.openxmlformats.org/drawingml/2006/main">
               <a:ext uri="{FF2B5EF4-FFF2-40B4-BE49-F238E27FC236}">
-                <a16:creationId xmlns:a16="http://schemas.microsoft.com/office/drawing/2014/main" id="{29D4EC95-6836-45E5-82C7-EC65D8D33CBD}"/>
+                <a16:creationId xmlns:a16="http://schemas.microsoft.com/office/drawing/2014/main" id="{8BD24FF5-9CF3-4172-940F-98A2A81D1B3B}"/>
               </a:ext>
             </a:extLst>
           </p:cNvPr>
@@ -19797,7 +19797,7 @@
           <p:cNvPr id="6" name="">
             <a:extLst xmlns:a="http://schemas.openxmlformats.org/drawingml/2006/main">
               <a:ext uri="{FF2B5EF4-FFF2-40B4-BE49-F238E27FC236}">
-                <a16:creationId xmlns:a16="http://schemas.microsoft.com/office/drawing/2014/main" id="{3994148E-8EDE-43D9-9793-8DE7DF3564E9}"/>
+                <a16:creationId xmlns:a16="http://schemas.microsoft.com/office/drawing/2014/main" id="{6CC73660-C896-4AC4-A181-AE5733AE063E}"/>
               </a:ext>
             </a:extLst>
           </p:cNvPr>
@@ -19861,7 +19861,7 @@
           <p:cNvPr id="7" name="">
             <a:extLst xmlns:a="http://schemas.openxmlformats.org/drawingml/2006/main">
               <a:ext uri="{FF2B5EF4-FFF2-40B4-BE49-F238E27FC236}">
-                <a16:creationId xmlns:a16="http://schemas.microsoft.com/office/drawing/2014/main" id="{ED579214-6606-48F5-A897-D4BE9EF3F40E}"/>
+                <a16:creationId xmlns:a16="http://schemas.microsoft.com/office/drawing/2014/main" id="{8472E87A-098E-4416-B97C-69D1FD84F452}"/>
               </a:ext>
             </a:extLst>
           </p:cNvPr>
@@ -19898,7 +19898,7 @@
           <p:nvPr/>
         </p:nvPicPr>
         <p:blipFill>
-          <a:blip xmlns:r="http://schemas.openxmlformats.org/officeDocument/2006/relationships" xmlns:a="http://schemas.openxmlformats.org/drawingml/2006/main" r:embed="Rd536408dfa6f4682"/>
+          <a:blip xmlns:r="http://schemas.openxmlformats.org/officeDocument/2006/relationships" xmlns:a="http://schemas.openxmlformats.org/drawingml/2006/main" r:embed="Rf30456cebc934054"/>
           <a:stretch xmlns:a="http://schemas.openxmlformats.org/drawingml/2006/main"/>
         </p:blipFill>
         <p:spPr>
@@ -19916,7 +19916,7 @@
           <p:cNvPr id="9" name="">
             <a:extLst xmlns:a="http://schemas.openxmlformats.org/drawingml/2006/main">
               <a:ext uri="{FF2B5EF4-FFF2-40B4-BE49-F238E27FC236}">
-                <a16:creationId xmlns:a16="http://schemas.microsoft.com/office/drawing/2014/main" id="{78E3FF44-1FA2-4422-8FF1-4C2831D9C7E9}"/>
+                <a16:creationId xmlns:a16="http://schemas.microsoft.com/office/drawing/2014/main" id="{4BCFCA0F-2CFA-45F1-A078-6B7551BD710C}"/>
               </a:ext>
             </a:extLst>
           </p:cNvPr>
@@ -19978,7 +19978,7 @@
     </p:spTree>
     <p:extLst>
       <p:ext uri="{BB962C8B-B14F-4D97-AF65-F5344CB8AC3E}">
-        <p14:creationId xmlns:p14="http://schemas.microsoft.com/office/powerpoint/2010/main" val="2077401362"/>
+        <p14:creationId xmlns:p14="http://schemas.microsoft.com/office/powerpoint/2010/main" val="1773400220"/>
       </p:ext>
     </p:extLst>
   </p:cSld>

</xml_diff>